<commit_message>
Rework poster for presenting and add team guide
Poster: one takeaway line per chart instead of captions, taller charts,
the question and six key terms on top, an answer line with three
findings at the bottom, and data, limitations and sources moved to a
small footnote. Adds build_guide.py and the 13-page presenting guide
(one page per chart), and rewrites the notebook text with a finding
after every chart and a closing conclusion.

Co-Authored-By: Claude Opus 5.5 <noreply@anthropic.com>
</commit_message>
<xml_diff>
--- a/shrinkflation_poster.pptx
+++ b/shrinkflation_poster.pptx
@@ -3096,7 +3096,7 @@
         </p:nvSpPr>
         <p:spPr>
           <a:xfrm>
-            <a:off x="274320" y="182880"/>
+            <a:off x="274320" y="164592"/>
             <a:ext cx="7013448" cy="384048"/>
           </a:xfrm>
           <a:prstGeom prst="rect">
@@ -3110,7 +3110,7 @@
           </a:bodyPr>
           <a:lstStyle/>
           <a:p>
-            <a:pPr algn="l">
+            <a:pPr>
               <a:lnSpc>
                 <a:spcPct val="105000"/>
               </a:lnSpc>
@@ -3132,14 +3132,14 @@
       </p:sp>
       <p:sp>
         <p:nvSpPr>
-          <p:cNvPr id="3" name="Subtitle"/>
+          <p:cNvPr id="3" name="Question"/>
           <p:cNvSpPr txBox="1"/>
           <p:nvPr/>
         </p:nvSpPr>
         <p:spPr>
           <a:xfrm>
             <a:off x="274320" y="566928"/>
-            <a:ext cx="7013448" cy="182880"/>
+            <a:ext cx="7013448" cy="201168"/>
           </a:xfrm>
           <a:prstGeom prst="rect">
             <a:avLst/>
@@ -3152,7 +3152,7 @@
           </a:bodyPr>
           <a:lstStyle/>
           <a:p>
-            <a:pPr algn="l">
+            <a:pPr>
               <a:lnSpc>
                 <a:spcPct val="105000"/>
               </a:lnSpc>
@@ -3161,13 +3161,13 @@
               </a:spcAft>
             </a:pPr>
             <a:r>
-              <a:rPr sz="950" b="0">
+              <a:rPr sz="1250" b="0">
                 <a:solidFill>
                   <a:srgbClr val="0B0B0B"/>
                 </a:solidFill>
                 <a:latin typeface="Arial"/>
               </a:rPr>
-              <a:t>Homes shrank by 40% to keep the price tag within reach. Since URA capped unit numbers, the price tag rises instead.</a:t>
+              <a:t>Did homes shrink to keep the price tag within reach, and is it still happening in 2025?</a:t>
             </a:r>
           </a:p>
         </p:txBody>
@@ -3180,7 +3180,7 @@
         </p:nvSpPr>
         <p:spPr>
           <a:xfrm>
-            <a:off x="274320" y="768096"/>
+            <a:off x="274320" y="804672"/>
             <a:ext cx="7013448" cy="128016"/>
           </a:xfrm>
           <a:prstGeom prst="rect">
@@ -3194,7 +3194,7 @@
           </a:bodyPr>
           <a:lstStyle/>
           <a:p>
-            <a:pPr algn="l">
+            <a:pPr>
               <a:lnSpc>
                 <a:spcPct val="105000"/>
               </a:lnSpc>
@@ -3216,14 +3216,14 @@
       </p:sp>
       <p:sp>
         <p:nvSpPr>
-          <p:cNvPr id="5" name="Introduction card"/>
+          <p:cNvPr id="5" name="Key terms card"/>
           <p:cNvSpPr/>
           <p:nvPr/>
         </p:nvSpPr>
         <p:spPr>
           <a:xfrm>
-            <a:off x="274320" y="941832"/>
-            <a:ext cx="7013448" cy="786384"/>
+            <a:off x="274320" y="969264"/>
+            <a:ext cx="7013448" cy="978408"/>
           </a:xfrm>
           <a:prstGeom prst="roundRect">
             <a:avLst>
@@ -3262,14 +3262,14 @@
       </p:sp>
       <p:sp>
         <p:nvSpPr>
-          <p:cNvPr id="6" name="Intro Shrinkflation in housing"/>
+          <p:cNvPr id="6" name="Term Shrinkflation"/>
           <p:cNvSpPr txBox="1"/>
           <p:nvPr/>
         </p:nvSpPr>
         <p:spPr>
           <a:xfrm>
-            <a:off x="365760" y="1014984"/>
-            <a:ext cx="2167127" cy="658368"/>
+            <a:off x="393192" y="1051560"/>
+            <a:ext cx="2124456" cy="402336"/>
           </a:xfrm>
           <a:prstGeom prst="rect">
             <a:avLst/>
@@ -3282,55 +3282,55 @@
           </a:bodyPr>
           <a:lstStyle/>
           <a:p>
-            <a:pPr algn="l">
+            <a:pPr>
               <a:lnSpc>
                 <a:spcPct val="105000"/>
               </a:lnSpc>
               <a:spcAft>
-                <a:spcPts val="150"/>
+                <a:spcPts val="80"/>
               </a:spcAft>
             </a:pPr>
             <a:r>
-              <a:rPr sz="700" b="1">
+              <a:rPr sz="760" b="1">
                 <a:solidFill>
                   <a:srgbClr val="0D366B"/>
                 </a:solidFill>
                 <a:latin typeface="Arial"/>
               </a:rPr>
-              <a:t>Shrinkflation in housing</a:t>
-            </a:r>
-          </a:p>
-          <a:p>
-            <a:pPr algn="l">
+              <a:t>Shrinkflation</a:t>
+            </a:r>
+          </a:p>
+          <a:p>
+            <a:pPr>
               <a:lnSpc>
                 <a:spcPct val="105000"/>
               </a:lnSpc>
               <a:spcAft>
-                <a:spcPts val="150"/>
+                <a:spcPts val="80"/>
               </a:spcAft>
             </a:pPr>
             <a:r>
-              <a:rPr sz="620" b="0">
+              <a:rPr sz="680" b="0">
                 <a:solidFill>
                   <a:srgbClr val="0B0B0B"/>
                 </a:solidFill>
                 <a:latin typeface="Arial"/>
               </a:rPr>
-              <a:t>Shrinkflation means a product gets smaller while its price stays put, so the price per unit rises without the tag moving [7]. In a home, the product is floor area, the unit price is price per sq ft (PSF) and the tag is the total price, which is what a bank lends against. MAS caps repayments at 55% of income, tested at 4% interest or more [4].</a:t>
-            </a:r>
-          </a:p>
-        </p:txBody>
-      </p:sp>
-      <p:sp>
-        <p:nvSpPr>
-          <p:cNvPr id="7" name="Intro Question"/>
+              <a:t>Less product for the same price tag. For a home: fewer sq ft for the same total price [6].</a:t>
+            </a:r>
+          </a:p>
+        </p:txBody>
+      </p:sp>
+      <p:sp>
+        <p:nvSpPr>
+          <p:cNvPr id="7" name="Term Price tag = floor area × PSF"/>
           <p:cNvSpPr txBox="1"/>
           <p:nvPr/>
         </p:nvSpPr>
         <p:spPr>
           <a:xfrm>
-            <a:off x="2697479" y="1014984"/>
-            <a:ext cx="2167127" cy="658368"/>
+            <a:off x="2718816" y="1051560"/>
+            <a:ext cx="2124456" cy="402336"/>
           </a:xfrm>
           <a:prstGeom prst="rect">
             <a:avLst/>
@@ -3343,55 +3343,55 @@
           </a:bodyPr>
           <a:lstStyle/>
           <a:p>
-            <a:pPr algn="l">
+            <a:pPr>
               <a:lnSpc>
                 <a:spcPct val="105000"/>
               </a:lnSpc>
               <a:spcAft>
-                <a:spcPts val="150"/>
+                <a:spcPts val="80"/>
               </a:spcAft>
             </a:pPr>
             <a:r>
-              <a:rPr sz="700" b="1">
+              <a:rPr sz="760" b="1">
                 <a:solidFill>
                   <a:srgbClr val="0D366B"/>
                 </a:solidFill>
                 <a:latin typeface="Arial"/>
               </a:rPr>
-              <a:t>Question</a:t>
-            </a:r>
-          </a:p>
-          <a:p>
-            <a:pPr algn="l">
+              <a:t>Price tag = floor area × PSF</a:t>
+            </a:r>
+          </a:p>
+          <a:p>
+            <a:pPr>
               <a:lnSpc>
                 <a:spcPct val="105000"/>
               </a:lnSpc>
               <a:spcAft>
-                <a:spcPts val="150"/>
+                <a:spcPts val="80"/>
               </a:spcAft>
             </a:pPr>
             <a:r>
-              <a:rPr sz="620" b="0">
+              <a:rPr sz="680" b="0">
                 <a:solidFill>
                   <a:srgbClr val="0B0B0B"/>
                 </a:solidFill>
                 <a:latin typeface="Arial"/>
               </a:rPr>
-              <a:t>Did Singapore's private homes shrink to keep the total price within reach, and is that still happening in 2025? Row 1 shows what shrank, row 2 whether the shrink is real and how it works, and row 3 why it happened and what changed once URA capped the number of units a project may build [5].</a:t>
-            </a:r>
-          </a:p>
-        </p:txBody>
-      </p:sp>
-      <p:sp>
-        <p:nvSpPr>
-          <p:cNvPr id="8" name="Intro Data"/>
+              <a:t>PSF is the price per square foot. When PSF rises, a smaller unit keeps the price tag flat.</a:t>
+            </a:r>
+          </a:p>
+        </p:txBody>
+      </p:sp>
+      <p:sp>
+        <p:nvSpPr>
+          <p:cNvPr id="8" name="Term New launch vs resale"/>
           <p:cNvSpPr txBox="1"/>
           <p:nvPr/>
         </p:nvSpPr>
         <p:spPr>
           <a:xfrm>
-            <a:off x="5029200" y="1014984"/>
-            <a:ext cx="2167127" cy="658368"/>
+            <a:off x="5044440" y="1051560"/>
+            <a:ext cx="2124456" cy="402336"/>
           </a:xfrm>
           <a:prstGeom prst="rect">
             <a:avLst/>
@@ -3404,54 +3404,237 @@
           </a:bodyPr>
           <a:lstStyle/>
           <a:p>
-            <a:pPr algn="l">
+            <a:pPr>
               <a:lnSpc>
                 <a:spcPct val="105000"/>
               </a:lnSpc>
               <a:spcAft>
-                <a:spcPts val="150"/>
+                <a:spcPts val="80"/>
               </a:spcAft>
             </a:pPr>
             <a:r>
-              <a:rPr sz="700" b="1">
+              <a:rPr sz="760" b="1">
                 <a:solidFill>
                   <a:srgbClr val="0D366B"/>
                 </a:solidFill>
                 <a:latin typeface="Arial"/>
               </a:rPr>
-              <a:t>Data</a:t>
-            </a:r>
-          </a:p>
-          <a:p>
-            <a:pPr algn="l">
+              <a:t>New launch vs resale</a:t>
+            </a:r>
+          </a:p>
+          <a:p>
+            <a:pPr>
               <a:lnSpc>
                 <a:spcPct val="105000"/>
               </a:lnSpc>
               <a:spcAft>
-                <a:spcPts val="150"/>
+                <a:spcPts val="80"/>
               </a:spcAft>
             </a:pPr>
             <a:r>
-              <a:rPr sz="620" b="0">
+              <a:rPr sz="680" b="0">
                 <a:solidFill>
                   <a:srgbClr val="0B0B0B"/>
                 </a:solidFill>
                 <a:latin typeface="Arial"/>
               </a:rPr>
-              <a:t>24,131 URA transactions from 2025 and 74,436 from Aug 2020 to Dec 2023 [1], after dropping 155 rows outside 200–5,000 sq ft and fixing the 'freenhold' typo. A home's vintage is its lease-start year (99-year leaseholds, 66,237 sales), close to the year its land was sold. Outside data: URA price index [2], SingStat income [3], MAS rules [4].</a:t>
-            </a:r>
-          </a:p>
-        </p:txBody>
-      </p:sp>
-      <p:sp>
-        <p:nvSpPr>
-          <p:cNvPr id="9" name="Row 1 label"/>
+              <a:t>A new launch is bought from the developer. A resale home is second-hand.</a:t>
+            </a:r>
+          </a:p>
+        </p:txBody>
+      </p:sp>
+      <p:sp>
+        <p:nvSpPr>
+          <p:cNvPr id="9" name="Term Lease-start year"/>
           <p:cNvSpPr txBox="1"/>
           <p:nvPr/>
         </p:nvSpPr>
         <p:spPr>
           <a:xfrm>
-            <a:off x="274320" y="1783080"/>
+            <a:off x="393192" y="1472184"/>
+            <a:ext cx="2124456" cy="402336"/>
+          </a:xfrm>
+          <a:prstGeom prst="rect">
+            <a:avLst/>
+          </a:prstGeom>
+          <a:noFill/>
+        </p:spPr>
+        <p:txBody>
+          <a:bodyPr wrap="square" lIns="0" rIns="0" tIns="0" bIns="0" anchor="t">
+            <a:spAutoFit/>
+          </a:bodyPr>
+          <a:lstStyle/>
+          <a:p>
+            <a:pPr>
+              <a:lnSpc>
+                <a:spcPct val="105000"/>
+              </a:lnSpc>
+              <a:spcAft>
+                <a:spcPts val="80"/>
+              </a:spcAft>
+            </a:pPr>
+            <a:r>
+              <a:rPr sz="760" b="1">
+                <a:solidFill>
+                  <a:srgbClr val="0D366B"/>
+                </a:solidFill>
+                <a:latin typeface="Arial"/>
+              </a:rPr>
+              <a:t>Lease-start year</a:t>
+            </a:r>
+          </a:p>
+          <a:p>
+            <a:pPr>
+              <a:lnSpc>
+                <a:spcPct val="105000"/>
+              </a:lnSpc>
+              <a:spcAft>
+                <a:spcPts val="80"/>
+              </a:spcAft>
+            </a:pPr>
+            <a:r>
+              <a:rPr sz="680" b="0">
+                <a:solidFill>
+                  <a:srgbClr val="0B0B0B"/>
+                </a:solidFill>
+                <a:latin typeface="Arial"/>
+              </a:rPr>
+              <a:t>When a 99-year lease began, roughly the year the land was sold and the unit sizes were planned.</a:t>
+            </a:r>
+          </a:p>
+        </p:txBody>
+      </p:sp>
+      <p:sp>
+        <p:nvSpPr>
+          <p:cNvPr id="10" name="Term URA unit cap"/>
+          <p:cNvSpPr txBox="1"/>
+          <p:nvPr/>
+        </p:nvSpPr>
+        <p:spPr>
+          <a:xfrm>
+            <a:off x="2718816" y="1472184"/>
+            <a:ext cx="2124456" cy="402336"/>
+          </a:xfrm>
+          <a:prstGeom prst="rect">
+            <a:avLst/>
+          </a:prstGeom>
+          <a:noFill/>
+        </p:spPr>
+        <p:txBody>
+          <a:bodyPr wrap="square" lIns="0" rIns="0" tIns="0" bIns="0" anchor="t">
+            <a:spAutoFit/>
+          </a:bodyPr>
+          <a:lstStyle/>
+          <a:p>
+            <a:pPr>
+              <a:lnSpc>
+                <a:spcPct val="105000"/>
+              </a:lnSpc>
+              <a:spcAft>
+                <a:spcPts val="80"/>
+              </a:spcAft>
+            </a:pPr>
+            <a:r>
+              <a:rPr sz="760" b="1">
+                <a:solidFill>
+                  <a:srgbClr val="0D366B"/>
+                </a:solidFill>
+                <a:latin typeface="Arial"/>
+              </a:rPr>
+              <a:t>URA unit cap</a:t>
+            </a:r>
+          </a:p>
+          <a:p>
+            <a:pPr>
+              <a:lnSpc>
+                <a:spcPct val="105000"/>
+              </a:lnSpc>
+              <a:spcAft>
+                <a:spcPts val="80"/>
+              </a:spcAft>
+            </a:pPr>
+            <a:r>
+              <a:rPr sz="680" b="0">
+                <a:solidFill>
+                  <a:srgbClr val="0B0B0B"/>
+                </a:solidFill>
+                <a:latin typeface="Arial"/>
+              </a:rPr>
+              <a:t>Since 2012 a project's unit count is capped at floor area ÷ 70 m² (85 m² since 2019), which sets a floor under unit sizes [5].</a:t>
+            </a:r>
+          </a:p>
+        </p:txBody>
+      </p:sp>
+      <p:sp>
+        <p:nvSpPr>
+          <p:cNvPr id="11" name="Term MAS loan limit"/>
+          <p:cNvSpPr txBox="1"/>
+          <p:nvPr/>
+        </p:nvSpPr>
+        <p:spPr>
+          <a:xfrm>
+            <a:off x="5044440" y="1472184"/>
+            <a:ext cx="2124456" cy="402336"/>
+          </a:xfrm>
+          <a:prstGeom prst="rect">
+            <a:avLst/>
+          </a:prstGeom>
+          <a:noFill/>
+        </p:spPr>
+        <p:txBody>
+          <a:bodyPr wrap="square" lIns="0" rIns="0" tIns="0" bIns="0" anchor="t">
+            <a:spAutoFit/>
+          </a:bodyPr>
+          <a:lstStyle/>
+          <a:p>
+            <a:pPr>
+              <a:lnSpc>
+                <a:spcPct val="105000"/>
+              </a:lnSpc>
+              <a:spcAft>
+                <a:spcPts val="80"/>
+              </a:spcAft>
+            </a:pPr>
+            <a:r>
+              <a:rPr sz="760" b="1">
+                <a:solidFill>
+                  <a:srgbClr val="0D366B"/>
+                </a:solidFill>
+                <a:latin typeface="Arial"/>
+              </a:rPr>
+              <a:t>MAS loan limit</a:t>
+            </a:r>
+          </a:p>
+          <a:p>
+            <a:pPr>
+              <a:lnSpc>
+                <a:spcPct val="105000"/>
+              </a:lnSpc>
+              <a:spcAft>
+                <a:spcPts val="80"/>
+              </a:spcAft>
+            </a:pPr>
+            <a:r>
+              <a:rPr sz="680" b="0">
+                <a:solidFill>
+                  <a:srgbClr val="0B0B0B"/>
+                </a:solidFill>
+                <a:latin typeface="Arial"/>
+              </a:rPr>
+              <a:t>Loan repayments can take at most 55% of income, tested at 4% interest or more [4].</a:t>
+            </a:r>
+          </a:p>
+        </p:txBody>
+      </p:sp>
+      <p:sp>
+        <p:nvSpPr>
+          <p:cNvPr id="12" name="Row 1 label"/>
+          <p:cNvSpPr txBox="1"/>
+          <p:nvPr/>
+        </p:nvSpPr>
+        <p:spPr>
+          <a:xfrm>
+            <a:off x="274320" y="2011679"/>
             <a:ext cx="7013448" cy="164592"/>
           </a:xfrm>
           <a:prstGeom prst="rect">
@@ -3465,7 +3648,7 @@
           </a:bodyPr>
           <a:lstStyle/>
           <a:p>
-            <a:pPr algn="l">
+            <a:pPr>
               <a:lnSpc>
                 <a:spcPct val="105000"/>
               </a:lnSpc>
@@ -3474,7 +3657,7 @@
               </a:spcAft>
             </a:pPr>
             <a:r>
-              <a:rPr sz="680" b="1">
+              <a:rPr sz="700" b="1">
                 <a:solidFill>
                   <a:srgbClr val="1C5CAB"/>
                 </a:solidFill>
@@ -3487,14 +3670,14 @@
       </p:sp>
       <p:sp>
         <p:nvSpPr>
-          <p:cNvPr id="10" name="Panel 1 card"/>
+          <p:cNvPr id="13" name="Panel 1 card"/>
           <p:cNvSpPr/>
           <p:nvPr/>
         </p:nvSpPr>
         <p:spPr>
           <a:xfrm>
-            <a:off x="274320" y="1965960"/>
-            <a:ext cx="2252472" cy="2286000"/>
+            <a:off x="274320" y="2203703"/>
+            <a:ext cx="2252472" cy="2194560"/>
           </a:xfrm>
           <a:prstGeom prst="roundRect">
             <a:avLst>
@@ -3533,14 +3716,14 @@
       </p:sp>
       <p:sp>
         <p:nvSpPr>
-          <p:cNvPr id="11" name="Panel 1 number"/>
+          <p:cNvPr id="14" name="Panel 1 number"/>
           <p:cNvSpPr/>
           <p:nvPr/>
         </p:nvSpPr>
         <p:spPr>
           <a:xfrm>
-            <a:off x="347472" y="2039112"/>
-            <a:ext cx="182880" cy="182880"/>
+            <a:off x="347472" y="2295144"/>
+            <a:ext cx="201168" cy="201168"/>
           </a:xfrm>
           <a:prstGeom prst="ellipse">
             <a:avLst/>
@@ -3573,7 +3756,7 @@
           <a:p>
             <a:pPr algn="ctr"/>
             <a:r>
-              <a:rPr sz="700" b="1">
+              <a:rPr sz="750" b="1">
                 <a:solidFill>
                   <a:srgbClr val="FFFFFF"/>
                 </a:solidFill>
@@ -3586,14 +3769,14 @@
       </p:sp>
       <p:sp>
         <p:nvSpPr>
-          <p:cNvPr id="12" name="Panel 1 headline"/>
+          <p:cNvPr id="15" name="Panel 1 takeaway"/>
           <p:cNvSpPr txBox="1"/>
           <p:nvPr/>
         </p:nvSpPr>
         <p:spPr>
           <a:xfrm>
-            <a:off x="585216" y="2020824"/>
-            <a:ext cx="1868424" cy="292608"/>
+            <a:off x="612647" y="2249423"/>
+            <a:ext cx="1840991" cy="310896"/>
           </a:xfrm>
           <a:prstGeom prst="rect">
             <a:avLst/>
@@ -3606,7 +3789,7 @@
           </a:bodyPr>
           <a:lstStyle/>
           <a:p>
-            <a:pPr algn="l">
+            <a:pPr>
               <a:lnSpc>
                 <a:spcPct val="105000"/>
               </a:lnSpc>
@@ -3615,20 +3798,20 @@
               </a:spcAft>
             </a:pPr>
             <a:r>
-              <a:rPr sz="720" b="1">
+              <a:rPr sz="780" b="1">
                 <a:solidFill>
                   <a:srgbClr val="0B0B0B"/>
                 </a:solidFill>
                 <a:latin typeface="Arial"/>
               </a:rPr>
-              <a:t>New launches in 2025 are 21% smaller than resale homes</a:t>
+              <a:t>New launches are 21% smaller than resale homes</a:t>
             </a:r>
           </a:p>
         </p:txBody>
       </p:sp>
       <p:pic>
         <p:nvPicPr>
-          <p:cNvPr id="13" name="Panel 1 figure" descr="01_histogram.png"/>
+          <p:cNvPr id="16" name="Panel 1 figure" descr="01_histogram.png"/>
           <p:cNvPicPr>
             <a:picLocks noChangeAspect="1"/>
           </p:cNvPicPr>
@@ -3642,8 +3825,8 @@
         </p:blipFill>
         <p:spPr>
           <a:xfrm>
-            <a:off x="348996" y="2322576"/>
-            <a:ext cx="2103120" cy="1417320"/>
+            <a:off x="321564" y="2578607"/>
+            <a:ext cx="2157984" cy="1783080"/>
           </a:xfrm>
           <a:prstGeom prst="rect">
             <a:avLst/>
@@ -3652,14 +3835,113 @@
       </p:pic>
       <p:sp>
         <p:nvSpPr>
-          <p:cNvPr id="14" name="Panel 1 caption"/>
+          <p:cNvPr id="17" name="Panel 2 card"/>
+          <p:cNvSpPr/>
+          <p:nvPr/>
+        </p:nvSpPr>
+        <p:spPr>
+          <a:xfrm>
+            <a:off x="2654808" y="2203703"/>
+            <a:ext cx="2252472" cy="2194560"/>
+          </a:xfrm>
+          <a:prstGeom prst="roundRect">
+            <a:avLst>
+              <a:gd name="adj" fmla="val 4000"/>
+            </a:avLst>
+          </a:prstGeom>
+          <a:solidFill>
+            <a:srgbClr val="F4F5F7"/>
+          </a:solidFill>
+          <a:ln>
+            <a:noFill/>
+          </a:ln>
+          <a:effectLst/>
+        </p:spPr>
+        <p:style>
+          <a:lnRef idx="1">
+            <a:schemeClr val="accent1"/>
+          </a:lnRef>
+          <a:fillRef idx="3">
+            <a:schemeClr val="accent1"/>
+          </a:fillRef>
+          <a:effectRef idx="2">
+            <a:schemeClr val="accent1"/>
+          </a:effectRef>
+          <a:fontRef idx="minor">
+            <a:schemeClr val="lt1"/>
+          </a:fontRef>
+        </p:style>
+        <p:txBody>
+          <a:bodyPr rtlCol="0" anchor="ctr"/>
+          <a:lstStyle/>
+          <a:p>
+            <a:pPr algn="ctr"/>
+          </a:p>
+        </p:txBody>
+      </p:sp>
+      <p:sp>
+        <p:nvSpPr>
+          <p:cNvPr id="18" name="Panel 2 number"/>
+          <p:cNvSpPr/>
+          <p:nvPr/>
+        </p:nvSpPr>
+        <p:spPr>
+          <a:xfrm>
+            <a:off x="2727960" y="2295144"/>
+            <a:ext cx="201168" cy="201168"/>
+          </a:xfrm>
+          <a:prstGeom prst="ellipse">
+            <a:avLst/>
+          </a:prstGeom>
+          <a:solidFill>
+            <a:srgbClr val="0D366B"/>
+          </a:solidFill>
+          <a:ln>
+            <a:noFill/>
+          </a:ln>
+          <a:effectLst/>
+        </p:spPr>
+        <p:style>
+          <a:lnRef idx="1">
+            <a:schemeClr val="accent1"/>
+          </a:lnRef>
+          <a:fillRef idx="3">
+            <a:schemeClr val="accent1"/>
+          </a:fillRef>
+          <a:effectRef idx="2">
+            <a:schemeClr val="accent1"/>
+          </a:effectRef>
+          <a:fontRef idx="minor">
+            <a:schemeClr val="lt1"/>
+          </a:fontRef>
+        </p:style>
+        <p:txBody>
+          <a:bodyPr rtlCol="0" anchor="ctr" lIns="0" rIns="0" tIns="0" bIns="0"/>
+          <a:lstStyle/>
+          <a:p>
+            <a:pPr algn="ctr"/>
+            <a:r>
+              <a:rPr sz="750" b="1">
+                <a:solidFill>
+                  <a:srgbClr val="FFFFFF"/>
+                </a:solidFill>
+                <a:latin typeface="Arial"/>
+              </a:rPr>
+              <a:t>2</a:t>
+            </a:r>
+          </a:p>
+        </p:txBody>
+      </p:sp>
+      <p:sp>
+        <p:nvSpPr>
+          <p:cNvPr id="19" name="Panel 2 takeaway"/>
           <p:cNvSpPr txBox="1"/>
           <p:nvPr/>
         </p:nvSpPr>
         <p:spPr>
           <a:xfrm>
-            <a:off x="356616" y="3767328"/>
-            <a:ext cx="2087880" cy="457199"/>
+            <a:off x="2993136" y="2249423"/>
+            <a:ext cx="1840991" cy="310896"/>
           </a:xfrm>
           <a:prstGeom prst="rect">
             <a:avLst/>
@@ -3667,12 +3949,12 @@
           <a:noFill/>
         </p:spPr>
         <p:txBody>
-          <a:bodyPr wrap="square" lIns="0" rIns="0" tIns="0" bIns="0" anchor="t">
+          <a:bodyPr wrap="square" lIns="0" rIns="0" tIns="0" bIns="0" anchor="ctr">
             <a:spAutoFit/>
           </a:bodyPr>
           <a:lstStyle/>
           <a:p>
-            <a:pPr algn="l">
+            <a:pPr>
               <a:lnSpc>
                 <a:spcPct val="105000"/>
               </a:lnSpc>
@@ -3681,161 +3963,20 @@
               </a:spcAft>
             </a:pPr>
             <a:r>
-              <a:rPr sz="570" b="0">
-                <a:solidFill>
-                  <a:srgbClr val="52514E"/>
+              <a:rPr sz="780" b="1">
+                <a:solidFill>
+                  <a:srgbClr val="0B0B0B"/>
                 </a:solidFill>
                 <a:latin typeface="Arial"/>
               </a:rPr>
-              <a:t>Share of 2025 sales per 50 sq ft band, new launches above the axis and resale below. Median new unit 797 sq ft against 1,012 for resale. Homes of 1,200 sq ft or more are 34% of resale but only 18% of new launches.</a:t>
-            </a:r>
-          </a:p>
-        </p:txBody>
-      </p:sp>
-      <p:sp>
-        <p:nvSpPr>
-          <p:cNvPr id="15" name="Panel 2 card"/>
-          <p:cNvSpPr/>
-          <p:nvPr/>
-        </p:nvSpPr>
-        <p:spPr>
-          <a:xfrm>
-            <a:off x="2654808" y="1965960"/>
-            <a:ext cx="2252472" cy="2286000"/>
-          </a:xfrm>
-          <a:prstGeom prst="roundRect">
-            <a:avLst>
-              <a:gd name="adj" fmla="val 4000"/>
-            </a:avLst>
-          </a:prstGeom>
-          <a:solidFill>
-            <a:srgbClr val="F4F5F7"/>
-          </a:solidFill>
-          <a:ln>
-            <a:noFill/>
-          </a:ln>
-          <a:effectLst/>
-        </p:spPr>
-        <p:style>
-          <a:lnRef idx="1">
-            <a:schemeClr val="accent1"/>
-          </a:lnRef>
-          <a:fillRef idx="3">
-            <a:schemeClr val="accent1"/>
-          </a:fillRef>
-          <a:effectRef idx="2">
-            <a:schemeClr val="accent1"/>
-          </a:effectRef>
-          <a:fontRef idx="minor">
-            <a:schemeClr val="lt1"/>
-          </a:fontRef>
-        </p:style>
-        <p:txBody>
-          <a:bodyPr rtlCol="0" anchor="ctr"/>
-          <a:lstStyle/>
-          <a:p>
-            <a:pPr algn="ctr"/>
-          </a:p>
-        </p:txBody>
-      </p:sp>
-      <p:sp>
-        <p:nvSpPr>
-          <p:cNvPr id="16" name="Panel 2 number"/>
-          <p:cNvSpPr/>
-          <p:nvPr/>
-        </p:nvSpPr>
-        <p:spPr>
-          <a:xfrm>
-            <a:off x="2727960" y="2039112"/>
-            <a:ext cx="182880" cy="182880"/>
-          </a:xfrm>
-          <a:prstGeom prst="ellipse">
-            <a:avLst/>
-          </a:prstGeom>
-          <a:solidFill>
-            <a:srgbClr val="0D366B"/>
-          </a:solidFill>
-          <a:ln>
-            <a:noFill/>
-          </a:ln>
-          <a:effectLst/>
-        </p:spPr>
-        <p:style>
-          <a:lnRef idx="1">
-            <a:schemeClr val="accent1"/>
-          </a:lnRef>
-          <a:fillRef idx="3">
-            <a:schemeClr val="accent1"/>
-          </a:fillRef>
-          <a:effectRef idx="2">
-            <a:schemeClr val="accent1"/>
-          </a:effectRef>
-          <a:fontRef idx="minor">
-            <a:schemeClr val="lt1"/>
-          </a:fontRef>
-        </p:style>
-        <p:txBody>
-          <a:bodyPr rtlCol="0" anchor="ctr" lIns="0" rIns="0" tIns="0" bIns="0"/>
-          <a:lstStyle/>
-          <a:p>
-            <a:pPr algn="ctr"/>
-            <a:r>
-              <a:rPr sz="700" b="1">
-                <a:solidFill>
-                  <a:srgbClr val="FFFFFF"/>
-                </a:solidFill>
-                <a:latin typeface="Arial"/>
-              </a:rPr>
-              <a:t>2</a:t>
-            </a:r>
-          </a:p>
-        </p:txBody>
-      </p:sp>
-      <p:sp>
-        <p:nvSpPr>
-          <p:cNvPr id="17" name="Panel 2 headline"/>
-          <p:cNvSpPr txBox="1"/>
-          <p:nvPr/>
-        </p:nvSpPr>
-        <p:spPr>
-          <a:xfrm>
-            <a:off x="2965704" y="2020824"/>
-            <a:ext cx="1868424" cy="292608"/>
-          </a:xfrm>
-          <a:prstGeom prst="rect">
-            <a:avLst/>
-          </a:prstGeom>
-          <a:noFill/>
-        </p:spPr>
-        <p:txBody>
-          <a:bodyPr wrap="square" lIns="0" rIns="0" tIns="0" bIns="0" anchor="ctr">
-            <a:spAutoFit/>
-          </a:bodyPr>
-          <a:lstStyle/>
-          <a:p>
-            <a:pPr algn="l">
-              <a:lnSpc>
-                <a:spcPct val="105000"/>
-              </a:lnSpc>
-              <a:spcAft>
-                <a:spcPts val="0"/>
-              </a:spcAft>
-            </a:pPr>
-            <a:r>
-              <a:rPr sz="720" b="1">
-                <a:solidFill>
-                  <a:srgbClr val="0B0B0B"/>
-                </a:solidFill>
-                <a:latin typeface="Arial"/>
-              </a:rPr>
-              <a:t>Homes on land sold after 2008 are 43% smaller</a:t>
+              <a:t>Homes shrank 43% for land sold after 2008</a:t>
             </a:r>
           </a:p>
         </p:txBody>
       </p:sp>
       <p:pic>
         <p:nvPicPr>
-          <p:cNvPr id="18" name="Panel 2 figure" descr="02_line_vintage.png"/>
+          <p:cNvPr id="20" name="Panel 2 figure" descr="02_line_vintage.png"/>
           <p:cNvPicPr>
             <a:picLocks noChangeAspect="1"/>
           </p:cNvPicPr>
@@ -3849,8 +3990,8 @@
         </p:blipFill>
         <p:spPr>
           <a:xfrm>
-            <a:off x="2729484" y="2322576"/>
-            <a:ext cx="2103120" cy="1417320"/>
+            <a:off x="2702052" y="2578607"/>
+            <a:ext cx="2157984" cy="1783080"/>
           </a:xfrm>
           <a:prstGeom prst="rect">
             <a:avLst/>
@@ -3859,14 +4000,113 @@
       </p:pic>
       <p:sp>
         <p:nvSpPr>
-          <p:cNvPr id="19" name="Panel 2 caption"/>
+          <p:cNvPr id="21" name="Panel 3 card"/>
+          <p:cNvSpPr/>
+          <p:nvPr/>
+        </p:nvSpPr>
+        <p:spPr>
+          <a:xfrm>
+            <a:off x="5035296" y="2203703"/>
+            <a:ext cx="2252472" cy="2194560"/>
+          </a:xfrm>
+          <a:prstGeom prst="roundRect">
+            <a:avLst>
+              <a:gd name="adj" fmla="val 4000"/>
+            </a:avLst>
+          </a:prstGeom>
+          <a:solidFill>
+            <a:srgbClr val="F4F5F7"/>
+          </a:solidFill>
+          <a:ln>
+            <a:noFill/>
+          </a:ln>
+          <a:effectLst/>
+        </p:spPr>
+        <p:style>
+          <a:lnRef idx="1">
+            <a:schemeClr val="accent1"/>
+          </a:lnRef>
+          <a:fillRef idx="3">
+            <a:schemeClr val="accent1"/>
+          </a:fillRef>
+          <a:effectRef idx="2">
+            <a:schemeClr val="accent1"/>
+          </a:effectRef>
+          <a:fontRef idx="minor">
+            <a:schemeClr val="lt1"/>
+          </a:fontRef>
+        </p:style>
+        <p:txBody>
+          <a:bodyPr rtlCol="0" anchor="ctr"/>
+          <a:lstStyle/>
+          <a:p>
+            <a:pPr algn="ctr"/>
+          </a:p>
+        </p:txBody>
+      </p:sp>
+      <p:sp>
+        <p:nvSpPr>
+          <p:cNvPr id="22" name="Panel 3 number"/>
+          <p:cNvSpPr/>
+          <p:nvPr/>
+        </p:nvSpPr>
+        <p:spPr>
+          <a:xfrm>
+            <a:off x="5108448" y="2295144"/>
+            <a:ext cx="201168" cy="201168"/>
+          </a:xfrm>
+          <a:prstGeom prst="ellipse">
+            <a:avLst/>
+          </a:prstGeom>
+          <a:solidFill>
+            <a:srgbClr val="0D366B"/>
+          </a:solidFill>
+          <a:ln>
+            <a:noFill/>
+          </a:ln>
+          <a:effectLst/>
+        </p:spPr>
+        <p:style>
+          <a:lnRef idx="1">
+            <a:schemeClr val="accent1"/>
+          </a:lnRef>
+          <a:fillRef idx="3">
+            <a:schemeClr val="accent1"/>
+          </a:fillRef>
+          <a:effectRef idx="2">
+            <a:schemeClr val="accent1"/>
+          </a:effectRef>
+          <a:fontRef idx="minor">
+            <a:schemeClr val="lt1"/>
+          </a:fontRef>
+        </p:style>
+        <p:txBody>
+          <a:bodyPr rtlCol="0" anchor="ctr" lIns="0" rIns="0" tIns="0" bIns="0"/>
+          <a:lstStyle/>
+          <a:p>
+            <a:pPr algn="ctr"/>
+            <a:r>
+              <a:rPr sz="750" b="1">
+                <a:solidFill>
+                  <a:srgbClr val="FFFFFF"/>
+                </a:solidFill>
+                <a:latin typeface="Arial"/>
+              </a:rPr>
+              <a:t>3</a:t>
+            </a:r>
+          </a:p>
+        </p:txBody>
+      </p:sp>
+      <p:sp>
+        <p:nvSpPr>
+          <p:cNvPr id="23" name="Panel 3 takeaway"/>
           <p:cNvSpPr txBox="1"/>
           <p:nvPr/>
         </p:nvSpPr>
         <p:spPr>
           <a:xfrm>
-            <a:off x="2737104" y="3767328"/>
-            <a:ext cx="2087880" cy="457199"/>
+            <a:off x="5373624" y="2249423"/>
+            <a:ext cx="1840991" cy="310896"/>
           </a:xfrm>
           <a:prstGeom prst="rect">
             <a:avLst/>
@@ -3874,12 +4114,12 @@
           <a:noFill/>
         </p:spPr>
         <p:txBody>
-          <a:bodyPr wrap="square" lIns="0" rIns="0" tIns="0" bIns="0" anchor="t">
+          <a:bodyPr wrap="square" lIns="0" rIns="0" tIns="0" bIns="0" anchor="ctr">
             <a:spAutoFit/>
           </a:bodyPr>
           <a:lstStyle/>
           <a:p>
-            <a:pPr algn="l">
+            <a:pPr>
               <a:lnSpc>
                 <a:spcPct val="105000"/>
               </a:lnSpc>
@@ -3888,161 +4128,20 @@
               </a:spcAft>
             </a:pPr>
             <a:r>
-              <a:rPr sz="570" b="0">
-                <a:solidFill>
-                  <a:srgbClr val="52514E"/>
+              <a:rPr sz="780" b="1">
+                <a:solidFill>
+                  <a:srgbClr val="0B0B0B"/>
                 </a:solidFill>
                 <a:latin typeface="Arial"/>
               </a:rPr>
-              <a:t>Median and middle 50% of floor area by lease-start year, all 2020–25 sales. Sizes held near 1,240 sq ft until 2008, fell to 710 sq ft for land sold in 2013–15 and stayed there, the floor set by URA's caps on units per project [5].</a:t>
-            </a:r>
-          </a:p>
-        </p:txBody>
-      </p:sp>
-      <p:sp>
-        <p:nvSpPr>
-          <p:cNvPr id="20" name="Panel 3 card"/>
-          <p:cNvSpPr/>
-          <p:nvPr/>
-        </p:nvSpPr>
-        <p:spPr>
-          <a:xfrm>
-            <a:off x="5035296" y="1965960"/>
-            <a:ext cx="2252472" cy="2286000"/>
-          </a:xfrm>
-          <a:prstGeom prst="roundRect">
-            <a:avLst>
-              <a:gd name="adj" fmla="val 4000"/>
-            </a:avLst>
-          </a:prstGeom>
-          <a:solidFill>
-            <a:srgbClr val="F4F5F7"/>
-          </a:solidFill>
-          <a:ln>
-            <a:noFill/>
-          </a:ln>
-          <a:effectLst/>
-        </p:spPr>
-        <p:style>
-          <a:lnRef idx="1">
-            <a:schemeClr val="accent1"/>
-          </a:lnRef>
-          <a:fillRef idx="3">
-            <a:schemeClr val="accent1"/>
-          </a:fillRef>
-          <a:effectRef idx="2">
-            <a:schemeClr val="accent1"/>
-          </a:effectRef>
-          <a:fontRef idx="minor">
-            <a:schemeClr val="lt1"/>
-          </a:fontRef>
-        </p:style>
-        <p:txBody>
-          <a:bodyPr rtlCol="0" anchor="ctr"/>
-          <a:lstStyle/>
-          <a:p>
-            <a:pPr algn="ctr"/>
-          </a:p>
-        </p:txBody>
-      </p:sp>
-      <p:sp>
-        <p:nvSpPr>
-          <p:cNvPr id="21" name="Panel 3 number"/>
-          <p:cNvSpPr/>
-          <p:nvPr/>
-        </p:nvSpPr>
-        <p:spPr>
-          <a:xfrm>
-            <a:off x="5108448" y="2039112"/>
-            <a:ext cx="182880" cy="182880"/>
-          </a:xfrm>
-          <a:prstGeom prst="ellipse">
-            <a:avLst/>
-          </a:prstGeom>
-          <a:solidFill>
-            <a:srgbClr val="0D366B"/>
-          </a:solidFill>
-          <a:ln>
-            <a:noFill/>
-          </a:ln>
-          <a:effectLst/>
-        </p:spPr>
-        <p:style>
-          <a:lnRef idx="1">
-            <a:schemeClr val="accent1"/>
-          </a:lnRef>
-          <a:fillRef idx="3">
-            <a:schemeClr val="accent1"/>
-          </a:fillRef>
-          <a:effectRef idx="2">
-            <a:schemeClr val="accent1"/>
-          </a:effectRef>
-          <a:fontRef idx="minor">
-            <a:schemeClr val="lt1"/>
-          </a:fontRef>
-        </p:style>
-        <p:txBody>
-          <a:bodyPr rtlCol="0" anchor="ctr" lIns="0" rIns="0" tIns="0" bIns="0"/>
-          <a:lstStyle/>
-          <a:p>
-            <a:pPr algn="ctr"/>
-            <a:r>
-              <a:rPr sz="700" b="1">
-                <a:solidFill>
-                  <a:srgbClr val="FFFFFF"/>
-                </a:solidFill>
-                <a:latin typeface="Arial"/>
-              </a:rPr>
-              <a:t>3</a:t>
-            </a:r>
-          </a:p>
-        </p:txBody>
-      </p:sp>
-      <p:sp>
-        <p:nvSpPr>
-          <p:cNvPr id="22" name="Panel 3 headline"/>
-          <p:cNvSpPr txBox="1"/>
-          <p:nvPr/>
-        </p:nvSpPr>
-        <p:spPr>
-          <a:xfrm>
-            <a:off x="5346192" y="2020824"/>
-            <a:ext cx="1868424" cy="292608"/>
-          </a:xfrm>
-          <a:prstGeom prst="rect">
-            <a:avLst/>
-          </a:prstGeom>
-          <a:noFill/>
-        </p:spPr>
-        <p:txBody>
-          <a:bodyPr wrap="square" lIns="0" rIns="0" tIns="0" bIns="0" anchor="ctr">
-            <a:spAutoFit/>
-          </a:bodyPr>
-          <a:lstStyle/>
-          <a:p>
-            <a:pPr algn="l">
-              <a:lnSpc>
-                <a:spcPct val="105000"/>
-              </a:lnSpc>
-              <a:spcAft>
-                <a:spcPts val="0"/>
-              </a:spcAft>
-            </a:pPr>
-            <a:r>
-              <a:rPr sz="720" b="1">
-                <a:solidFill>
-                  <a:srgbClr val="0B0B0B"/>
-                </a:solidFill>
-                <a:latin typeface="Arial"/>
-              </a:rPr>
-              <a:t>Shoeboxes went from 1% to 13% of homes, big homes from 34% to 8%</a:t>
+              <a:t>Shoeboxes rose from 1% to 13%, big homes fell from 34% to 8%</a:t>
             </a:r>
           </a:p>
         </p:txBody>
       </p:sp>
       <p:pic>
         <p:nvPicPr>
-          <p:cNvPr id="23" name="Panel 3 figure" descr="03_stacked_mix.png"/>
+          <p:cNvPr id="24" name="Panel 3 figure" descr="03_stacked_mix.png"/>
           <p:cNvPicPr>
             <a:picLocks noChangeAspect="1"/>
           </p:cNvPicPr>
@@ -4056,8 +4155,8 @@
         </p:blipFill>
         <p:spPr>
           <a:xfrm>
-            <a:off x="5109972" y="2322576"/>
-            <a:ext cx="2103120" cy="1417320"/>
+            <a:off x="5082540" y="2578607"/>
+            <a:ext cx="2157984" cy="1783080"/>
           </a:xfrm>
           <a:prstGeom prst="rect">
             <a:avLst/>
@@ -4066,14 +4165,14 @@
       </p:pic>
       <p:sp>
         <p:nvSpPr>
-          <p:cNvPr id="24" name="Panel 3 caption"/>
+          <p:cNvPr id="25" name="Row 2 label"/>
           <p:cNvSpPr txBox="1"/>
           <p:nvPr/>
         </p:nvSpPr>
         <p:spPr>
           <a:xfrm>
-            <a:off x="5117592" y="3767328"/>
-            <a:ext cx="2087880" cy="457199"/>
+            <a:off x="274320" y="4453127"/>
+            <a:ext cx="7013448" cy="164592"/>
           </a:xfrm>
           <a:prstGeom prst="rect">
             <a:avLst/>
@@ -4081,12 +4180,12 @@
           <a:noFill/>
         </p:spPr>
         <p:txBody>
-          <a:bodyPr wrap="square" lIns="0" rIns="0" tIns="0" bIns="0" anchor="t">
+          <a:bodyPr wrap="square" lIns="0" rIns="0" tIns="0" bIns="0" anchor="ctr">
             <a:spAutoFit/>
           </a:bodyPr>
           <a:lstStyle/>
           <a:p>
-            <a:pPr algn="l">
+            <a:pPr>
               <a:lnSpc>
                 <a:spcPct val="105000"/>
               </a:lnSpc>
@@ -4095,27 +4194,126 @@
               </a:spcAft>
             </a:pPr>
             <a:r>
-              <a:rPr sz="570" b="0">
-                <a:solidFill>
-                  <a:srgbClr val="52514E"/>
+              <a:rPr sz="700" b="1">
+                <a:solidFill>
+                  <a:srgbClr val="1C5CAB"/>
                 </a:solidFill>
                 <a:latin typeface="Arial"/>
               </a:rPr>
-              <a:t>Unit-size mix by lease-start era. One- and two-bedroom sizes (507–750 sq ft) grew from 5% to 38% of units. The 2019 cap pushed shoeboxes back to 9%, but homes over 1,300 sq ft stayed rare at 11%.</a:t>
-            </a:r>
-          </a:p>
-        </p:txBody>
-      </p:sp>
-      <p:sp>
-        <p:nvSpPr>
-          <p:cNvPr id="25" name="Row 2 label"/>
+              <a:t>2   IS IT REAL, AND HOW DOES IT WORK?</a:t>
+            </a:r>
+          </a:p>
+        </p:txBody>
+      </p:sp>
+      <p:sp>
+        <p:nvSpPr>
+          <p:cNvPr id="26" name="Panel 4 card"/>
+          <p:cNvSpPr/>
+          <p:nvPr/>
+        </p:nvSpPr>
+        <p:spPr>
+          <a:xfrm>
+            <a:off x="274320" y="4645151"/>
+            <a:ext cx="2252472" cy="2194560"/>
+          </a:xfrm>
+          <a:prstGeom prst="roundRect">
+            <a:avLst>
+              <a:gd name="adj" fmla="val 4000"/>
+            </a:avLst>
+          </a:prstGeom>
+          <a:solidFill>
+            <a:srgbClr val="F4F5F7"/>
+          </a:solidFill>
+          <a:ln>
+            <a:noFill/>
+          </a:ln>
+          <a:effectLst/>
+        </p:spPr>
+        <p:style>
+          <a:lnRef idx="1">
+            <a:schemeClr val="accent1"/>
+          </a:lnRef>
+          <a:fillRef idx="3">
+            <a:schemeClr val="accent1"/>
+          </a:fillRef>
+          <a:effectRef idx="2">
+            <a:schemeClr val="accent1"/>
+          </a:effectRef>
+          <a:fontRef idx="minor">
+            <a:schemeClr val="lt1"/>
+          </a:fontRef>
+        </p:style>
+        <p:txBody>
+          <a:bodyPr rtlCol="0" anchor="ctr"/>
+          <a:lstStyle/>
+          <a:p>
+            <a:pPr algn="ctr"/>
+          </a:p>
+        </p:txBody>
+      </p:sp>
+      <p:sp>
+        <p:nvSpPr>
+          <p:cNvPr id="27" name="Panel 4 number"/>
+          <p:cNvSpPr/>
+          <p:nvPr/>
+        </p:nvSpPr>
+        <p:spPr>
+          <a:xfrm>
+            <a:off x="347472" y="4736591"/>
+            <a:ext cx="201168" cy="201168"/>
+          </a:xfrm>
+          <a:prstGeom prst="ellipse">
+            <a:avLst/>
+          </a:prstGeom>
+          <a:solidFill>
+            <a:srgbClr val="0D366B"/>
+          </a:solidFill>
+          <a:ln>
+            <a:noFill/>
+          </a:ln>
+          <a:effectLst/>
+        </p:spPr>
+        <p:style>
+          <a:lnRef idx="1">
+            <a:schemeClr val="accent1"/>
+          </a:lnRef>
+          <a:fillRef idx="3">
+            <a:schemeClr val="accent1"/>
+          </a:fillRef>
+          <a:effectRef idx="2">
+            <a:schemeClr val="accent1"/>
+          </a:effectRef>
+          <a:fontRef idx="minor">
+            <a:schemeClr val="lt1"/>
+          </a:fontRef>
+        </p:style>
+        <p:txBody>
+          <a:bodyPr rtlCol="0" anchor="ctr" lIns="0" rIns="0" tIns="0" bIns="0"/>
+          <a:lstStyle/>
+          <a:p>
+            <a:pPr algn="ctr"/>
+            <a:r>
+              <a:rPr sz="750" b="1">
+                <a:solidFill>
+                  <a:srgbClr val="FFFFFF"/>
+                </a:solidFill>
+                <a:latin typeface="Arial"/>
+              </a:rPr>
+              <a:t>4</a:t>
+            </a:r>
+          </a:p>
+        </p:txBody>
+      </p:sp>
+      <p:sp>
+        <p:nvSpPr>
+          <p:cNvPr id="28" name="Panel 4 takeaway"/>
           <p:cNvSpPr txBox="1"/>
           <p:nvPr/>
         </p:nvSpPr>
         <p:spPr>
           <a:xfrm>
-            <a:off x="274320" y="4288536"/>
-            <a:ext cx="7013448" cy="164592"/>
+            <a:off x="612647" y="4690871"/>
+            <a:ext cx="1840991" cy="310896"/>
           </a:xfrm>
           <a:prstGeom prst="rect">
             <a:avLst/>
@@ -4128,7 +4326,7 @@
           </a:bodyPr>
           <a:lstStyle/>
           <a:p>
-            <a:pPr algn="l">
+            <a:pPr>
               <a:lnSpc>
                 <a:spcPct val="105000"/>
               </a:lnSpc>
@@ -4137,154 +4335,13 @@
               </a:spcAft>
             </a:pPr>
             <a:r>
-              <a:rPr sz="680" b="1">
-                <a:solidFill>
-                  <a:srgbClr val="1C5CAB"/>
+              <a:rPr sz="780" b="1">
+                <a:solidFill>
+                  <a:srgbClr val="0B0B0B"/>
                 </a:solidFill>
                 <a:latin typeface="Arial"/>
               </a:rPr>
-              <a:t>2   IS IT REAL, AND HOW DOES IT WORK?</a:t>
-            </a:r>
-          </a:p>
-        </p:txBody>
-      </p:sp>
-      <p:sp>
-        <p:nvSpPr>
-          <p:cNvPr id="26" name="Panel 4 card"/>
-          <p:cNvSpPr/>
-          <p:nvPr/>
-        </p:nvSpPr>
-        <p:spPr>
-          <a:xfrm>
-            <a:off x="274320" y="4471416"/>
-            <a:ext cx="2252472" cy="2286000"/>
-          </a:xfrm>
-          <a:prstGeom prst="roundRect">
-            <a:avLst>
-              <a:gd name="adj" fmla="val 4000"/>
-            </a:avLst>
-          </a:prstGeom>
-          <a:solidFill>
-            <a:srgbClr val="F4F5F7"/>
-          </a:solidFill>
-          <a:ln>
-            <a:noFill/>
-          </a:ln>
-          <a:effectLst/>
-        </p:spPr>
-        <p:style>
-          <a:lnRef idx="1">
-            <a:schemeClr val="accent1"/>
-          </a:lnRef>
-          <a:fillRef idx="3">
-            <a:schemeClr val="accent1"/>
-          </a:fillRef>
-          <a:effectRef idx="2">
-            <a:schemeClr val="accent1"/>
-          </a:effectRef>
-          <a:fontRef idx="minor">
-            <a:schemeClr val="lt1"/>
-          </a:fontRef>
-        </p:style>
-        <p:txBody>
-          <a:bodyPr rtlCol="0" anchor="ctr"/>
-          <a:lstStyle/>
-          <a:p>
-            <a:pPr algn="ctr"/>
-          </a:p>
-        </p:txBody>
-      </p:sp>
-      <p:sp>
-        <p:nvSpPr>
-          <p:cNvPr id="27" name="Panel 4 number"/>
-          <p:cNvSpPr/>
-          <p:nvPr/>
-        </p:nvSpPr>
-        <p:spPr>
-          <a:xfrm>
-            <a:off x="347472" y="4544568"/>
-            <a:ext cx="182880" cy="182880"/>
-          </a:xfrm>
-          <a:prstGeom prst="ellipse">
-            <a:avLst/>
-          </a:prstGeom>
-          <a:solidFill>
-            <a:srgbClr val="0D366B"/>
-          </a:solidFill>
-          <a:ln>
-            <a:noFill/>
-          </a:ln>
-          <a:effectLst/>
-        </p:spPr>
-        <p:style>
-          <a:lnRef idx="1">
-            <a:schemeClr val="accent1"/>
-          </a:lnRef>
-          <a:fillRef idx="3">
-            <a:schemeClr val="accent1"/>
-          </a:fillRef>
-          <a:effectRef idx="2">
-            <a:schemeClr val="accent1"/>
-          </a:effectRef>
-          <a:fontRef idx="minor">
-            <a:schemeClr val="lt1"/>
-          </a:fontRef>
-        </p:style>
-        <p:txBody>
-          <a:bodyPr rtlCol="0" anchor="ctr" lIns="0" rIns="0" tIns="0" bIns="0"/>
-          <a:lstStyle/>
-          <a:p>
-            <a:pPr algn="ctr"/>
-            <a:r>
-              <a:rPr sz="700" b="1">
-                <a:solidFill>
-                  <a:srgbClr val="FFFFFF"/>
-                </a:solidFill>
-                <a:latin typeface="Arial"/>
-              </a:rPr>
-              <a:t>4</a:t>
-            </a:r>
-          </a:p>
-        </p:txBody>
-      </p:sp>
-      <p:sp>
-        <p:nvSpPr>
-          <p:cNvPr id="28" name="Panel 4 headline"/>
-          <p:cNvSpPr txBox="1"/>
-          <p:nvPr/>
-        </p:nvSpPr>
-        <p:spPr>
-          <a:xfrm>
-            <a:off x="585216" y="4526279"/>
-            <a:ext cx="1868424" cy="292608"/>
-          </a:xfrm>
-          <a:prstGeom prst="rect">
-            <a:avLst/>
-          </a:prstGeom>
-          <a:noFill/>
-        </p:spPr>
-        <p:txBody>
-          <a:bodyPr wrap="square" lIns="0" rIns="0" tIns="0" bIns="0" anchor="ctr">
-            <a:spAutoFit/>
-          </a:bodyPr>
-          <a:lstStyle/>
-          <a:p>
-            <a:pPr algn="l">
-              <a:lnSpc>
-                <a:spcPct val="105000"/>
-              </a:lnSpc>
-              <a:spcAft>
-                <a:spcPts val="0"/>
-              </a:spcAft>
-            </a:pPr>
-            <a:r>
-              <a:rPr sz="720" b="1">
-                <a:solidFill>
-                  <a:srgbClr val="0B0B0B"/>
-                </a:solidFill>
-                <a:latin typeface="Arial"/>
-              </a:rPr>
-              <a:t>The shrink is the same inside each district</a:t>
+              <a:t>Within the same district the gap stays at −34%</a:t>
             </a:r>
           </a:p>
         </p:txBody>
@@ -4305,8 +4362,8 @@
         </p:blipFill>
         <p:spPr>
           <a:xfrm>
-            <a:off x="348996" y="4828031"/>
-            <a:ext cx="2103120" cy="1417320"/>
+            <a:off x="321564" y="5020055"/>
+            <a:ext cx="2157984" cy="1783080"/>
           </a:xfrm>
           <a:prstGeom prst="rect">
             <a:avLst/>
@@ -4315,14 +4372,113 @@
       </p:pic>
       <p:sp>
         <p:nvSpPr>
-          <p:cNvPr id="30" name="Panel 4 caption"/>
+          <p:cNvPr id="30" name="Panel 5 card"/>
+          <p:cNvSpPr/>
+          <p:nvPr/>
+        </p:nvSpPr>
+        <p:spPr>
+          <a:xfrm>
+            <a:off x="2654808" y="4645151"/>
+            <a:ext cx="2252472" cy="2194560"/>
+          </a:xfrm>
+          <a:prstGeom prst="roundRect">
+            <a:avLst>
+              <a:gd name="adj" fmla="val 4000"/>
+            </a:avLst>
+          </a:prstGeom>
+          <a:solidFill>
+            <a:srgbClr val="F4F5F7"/>
+          </a:solidFill>
+          <a:ln>
+            <a:noFill/>
+          </a:ln>
+          <a:effectLst/>
+        </p:spPr>
+        <p:style>
+          <a:lnRef idx="1">
+            <a:schemeClr val="accent1"/>
+          </a:lnRef>
+          <a:fillRef idx="3">
+            <a:schemeClr val="accent1"/>
+          </a:fillRef>
+          <a:effectRef idx="2">
+            <a:schemeClr val="accent1"/>
+          </a:effectRef>
+          <a:fontRef idx="minor">
+            <a:schemeClr val="lt1"/>
+          </a:fontRef>
+        </p:style>
+        <p:txBody>
+          <a:bodyPr rtlCol="0" anchor="ctr"/>
+          <a:lstStyle/>
+          <a:p>
+            <a:pPr algn="ctr"/>
+          </a:p>
+        </p:txBody>
+      </p:sp>
+      <p:sp>
+        <p:nvSpPr>
+          <p:cNvPr id="31" name="Panel 5 number"/>
+          <p:cNvSpPr/>
+          <p:nvPr/>
+        </p:nvSpPr>
+        <p:spPr>
+          <a:xfrm>
+            <a:off x="2727960" y="4736591"/>
+            <a:ext cx="201168" cy="201168"/>
+          </a:xfrm>
+          <a:prstGeom prst="ellipse">
+            <a:avLst/>
+          </a:prstGeom>
+          <a:solidFill>
+            <a:srgbClr val="0D366B"/>
+          </a:solidFill>
+          <a:ln>
+            <a:noFill/>
+          </a:ln>
+          <a:effectLst/>
+        </p:spPr>
+        <p:style>
+          <a:lnRef idx="1">
+            <a:schemeClr val="accent1"/>
+          </a:lnRef>
+          <a:fillRef idx="3">
+            <a:schemeClr val="accent1"/>
+          </a:fillRef>
+          <a:effectRef idx="2">
+            <a:schemeClr val="accent1"/>
+          </a:effectRef>
+          <a:fontRef idx="minor">
+            <a:schemeClr val="lt1"/>
+          </a:fontRef>
+        </p:style>
+        <p:txBody>
+          <a:bodyPr rtlCol="0" anchor="ctr" lIns="0" rIns="0" tIns="0" bIns="0"/>
+          <a:lstStyle/>
+          <a:p>
+            <a:pPr algn="ctr"/>
+            <a:r>
+              <a:rPr sz="750" b="1">
+                <a:solidFill>
+                  <a:srgbClr val="FFFFFF"/>
+                </a:solidFill>
+                <a:latin typeface="Arial"/>
+              </a:rPr>
+              <a:t>5</a:t>
+            </a:r>
+          </a:p>
+        </p:txBody>
+      </p:sp>
+      <p:sp>
+        <p:nvSpPr>
+          <p:cNvPr id="32" name="Panel 5 takeaway"/>
           <p:cNvSpPr txBox="1"/>
           <p:nvPr/>
         </p:nvSpPr>
         <p:spPr>
           <a:xfrm>
-            <a:off x="356616" y="6272783"/>
-            <a:ext cx="2087880" cy="457199"/>
+            <a:off x="2993136" y="4690871"/>
+            <a:ext cx="1840991" cy="310896"/>
           </a:xfrm>
           <a:prstGeom prst="rect">
             <a:avLst/>
@@ -4330,12 +4486,12 @@
           <a:noFill/>
         </p:spPr>
         <p:txBody>
-          <a:bodyPr wrap="square" lIns="0" rIns="0" tIns="0" bIns="0" anchor="t">
+          <a:bodyPr wrap="square" lIns="0" rIns="0" tIns="0" bIns="0" anchor="ctr">
             <a:spAutoFit/>
           </a:bodyPr>
           <a:lstStyle/>
           <a:p>
-            <a:pPr algn="l">
+            <a:pPr>
               <a:lnSpc>
                 <a:spcPct val="105000"/>
               </a:lnSpc>
@@ -4344,161 +4500,20 @@
               </a:spcAft>
             </a:pPr>
             <a:r>
-              <a:rPr sz="570" b="0">
-                <a:solidFill>
-                  <a:srgbClr val="52514E"/>
+              <a:rPr sz="780" b="1">
+                <a:solidFill>
+                  <a:srgbClr val="0B0B0B"/>
                 </a:solidFill>
                 <a:latin typeface="Arial"/>
               </a:rPr>
-              <a:t>Regression of log floor area on lease-start era against 1990–08 (66,237 sales, 95% intervals clustered by 464 projects). Holding district, type and sale year fixed moves each gap by about one point, so location does not explain the shrink.</a:t>
-            </a:r>
-          </a:p>
-        </p:txBody>
-      </p:sp>
-      <p:sp>
-        <p:nvSpPr>
-          <p:cNvPr id="31" name="Panel 5 card"/>
-          <p:cNvSpPr/>
-          <p:nvPr/>
-        </p:nvSpPr>
-        <p:spPr>
-          <a:xfrm>
-            <a:off x="2654808" y="4471416"/>
-            <a:ext cx="2252472" cy="2286000"/>
-          </a:xfrm>
-          <a:prstGeom prst="roundRect">
-            <a:avLst>
-              <a:gd name="adj" fmla="val 4000"/>
-            </a:avLst>
-          </a:prstGeom>
-          <a:solidFill>
-            <a:srgbClr val="F4F5F7"/>
-          </a:solidFill>
-          <a:ln>
-            <a:noFill/>
-          </a:ln>
-          <a:effectLst/>
-        </p:spPr>
-        <p:style>
-          <a:lnRef idx="1">
-            <a:schemeClr val="accent1"/>
-          </a:lnRef>
-          <a:fillRef idx="3">
-            <a:schemeClr val="accent1"/>
-          </a:fillRef>
-          <a:effectRef idx="2">
-            <a:schemeClr val="accent1"/>
-          </a:effectRef>
-          <a:fontRef idx="minor">
-            <a:schemeClr val="lt1"/>
-          </a:fontRef>
-        </p:style>
-        <p:txBody>
-          <a:bodyPr rtlCol="0" anchor="ctr"/>
-          <a:lstStyle/>
-          <a:p>
-            <a:pPr algn="ctr"/>
-          </a:p>
-        </p:txBody>
-      </p:sp>
-      <p:sp>
-        <p:nvSpPr>
-          <p:cNvPr id="32" name="Panel 5 number"/>
-          <p:cNvSpPr/>
-          <p:nvPr/>
-        </p:nvSpPr>
-        <p:spPr>
-          <a:xfrm>
-            <a:off x="2727960" y="4544568"/>
-            <a:ext cx="182880" cy="182880"/>
-          </a:xfrm>
-          <a:prstGeom prst="ellipse">
-            <a:avLst/>
-          </a:prstGeom>
-          <a:solidFill>
-            <a:srgbClr val="0D366B"/>
-          </a:solidFill>
-          <a:ln>
-            <a:noFill/>
-          </a:ln>
-          <a:effectLst/>
-        </p:spPr>
-        <p:style>
-          <a:lnRef idx="1">
-            <a:schemeClr val="accent1"/>
-          </a:lnRef>
-          <a:fillRef idx="3">
-            <a:schemeClr val="accent1"/>
-          </a:fillRef>
-          <a:effectRef idx="2">
-            <a:schemeClr val="accent1"/>
-          </a:effectRef>
-          <a:fontRef idx="minor">
-            <a:schemeClr val="lt1"/>
-          </a:fontRef>
-        </p:style>
-        <p:txBody>
-          <a:bodyPr rtlCol="0" anchor="ctr" lIns="0" rIns="0" tIns="0" bIns="0"/>
-          <a:lstStyle/>
-          <a:p>
-            <a:pPr algn="ctr"/>
-            <a:r>
-              <a:rPr sz="700" b="1">
-                <a:solidFill>
-                  <a:srgbClr val="FFFFFF"/>
-                </a:solidFill>
-                <a:latin typeface="Arial"/>
-              </a:rPr>
-              <a:t>5</a:t>
-            </a:r>
-          </a:p>
-        </p:txBody>
-      </p:sp>
-      <p:sp>
-        <p:nvSpPr>
-          <p:cNvPr id="33" name="Panel 5 headline"/>
-          <p:cNvSpPr txBox="1"/>
-          <p:nvPr/>
-        </p:nvSpPr>
-        <p:spPr>
-          <a:xfrm>
-            <a:off x="2965704" y="4526279"/>
-            <a:ext cx="1868424" cy="292608"/>
-          </a:xfrm>
-          <a:prstGeom prst="rect">
-            <a:avLst/>
-          </a:prstGeom>
-          <a:noFill/>
-        </p:spPr>
-        <p:txBody>
-          <a:bodyPr wrap="square" lIns="0" rIns="0" tIns="0" bIns="0" anchor="ctr">
-            <a:spAutoFit/>
-          </a:bodyPr>
-          <a:lstStyle/>
-          <a:p>
-            <a:pPr algn="l">
-              <a:lnSpc>
-                <a:spcPct val="105000"/>
-              </a:lnSpc>
-              <a:spcAft>
-                <a:spcPts val="0"/>
-              </a:spcAft>
-            </a:pPr>
-            <a:r>
-              <a:rPr sz="720" b="1">
-                <a:solidFill>
-                  <a:srgbClr val="0B0B0B"/>
-                </a:solidFill>
-                <a:latin typeface="Arial"/>
-              </a:rPr>
-              <a:t>Smaller homes kept the price tag down until the 2019 cap</a:t>
+              <a:t>Shrinking cut prices to S$1.45M; after 2019 they jump to S$2.05M</a:t>
             </a:r>
           </a:p>
         </p:txBody>
       </p:sp>
       <p:pic>
         <p:nvPicPr>
-          <p:cNvPr id="34" name="Panel 5 figure" descr="05_scatter_isoprice.png"/>
+          <p:cNvPr id="33" name="Panel 5 figure" descr="05_scatter_isoprice.png"/>
           <p:cNvPicPr>
             <a:picLocks noChangeAspect="1"/>
           </p:cNvPicPr>
@@ -4512,8 +4527,8 @@
         </p:blipFill>
         <p:spPr>
           <a:xfrm>
-            <a:off x="2729484" y="4828031"/>
-            <a:ext cx="2103120" cy="1417320"/>
+            <a:off x="2702052" y="5020055"/>
+            <a:ext cx="2157984" cy="1783080"/>
           </a:xfrm>
           <a:prstGeom prst="rect">
             <a:avLst/>
@@ -4522,14 +4537,113 @@
       </p:pic>
       <p:sp>
         <p:nvSpPr>
-          <p:cNvPr id="35" name="Panel 5 caption"/>
+          <p:cNvPr id="34" name="Panel 6 card"/>
+          <p:cNvSpPr/>
+          <p:nvPr/>
+        </p:nvSpPr>
+        <p:spPr>
+          <a:xfrm>
+            <a:off x="5035296" y="4645151"/>
+            <a:ext cx="2252472" cy="2194560"/>
+          </a:xfrm>
+          <a:prstGeom prst="roundRect">
+            <a:avLst>
+              <a:gd name="adj" fmla="val 4000"/>
+            </a:avLst>
+          </a:prstGeom>
+          <a:solidFill>
+            <a:srgbClr val="F4F5F7"/>
+          </a:solidFill>
+          <a:ln>
+            <a:noFill/>
+          </a:ln>
+          <a:effectLst/>
+        </p:spPr>
+        <p:style>
+          <a:lnRef idx="1">
+            <a:schemeClr val="accent1"/>
+          </a:lnRef>
+          <a:fillRef idx="3">
+            <a:schemeClr val="accent1"/>
+          </a:fillRef>
+          <a:effectRef idx="2">
+            <a:schemeClr val="accent1"/>
+          </a:effectRef>
+          <a:fontRef idx="minor">
+            <a:schemeClr val="lt1"/>
+          </a:fontRef>
+        </p:style>
+        <p:txBody>
+          <a:bodyPr rtlCol="0" anchor="ctr"/>
+          <a:lstStyle/>
+          <a:p>
+            <a:pPr algn="ctr"/>
+          </a:p>
+        </p:txBody>
+      </p:sp>
+      <p:sp>
+        <p:nvSpPr>
+          <p:cNvPr id="35" name="Panel 6 number"/>
+          <p:cNvSpPr/>
+          <p:nvPr/>
+        </p:nvSpPr>
+        <p:spPr>
+          <a:xfrm>
+            <a:off x="5108448" y="4736591"/>
+            <a:ext cx="201168" cy="201168"/>
+          </a:xfrm>
+          <a:prstGeom prst="ellipse">
+            <a:avLst/>
+          </a:prstGeom>
+          <a:solidFill>
+            <a:srgbClr val="0D366B"/>
+          </a:solidFill>
+          <a:ln>
+            <a:noFill/>
+          </a:ln>
+          <a:effectLst/>
+        </p:spPr>
+        <p:style>
+          <a:lnRef idx="1">
+            <a:schemeClr val="accent1"/>
+          </a:lnRef>
+          <a:fillRef idx="3">
+            <a:schemeClr val="accent1"/>
+          </a:fillRef>
+          <a:effectRef idx="2">
+            <a:schemeClr val="accent1"/>
+          </a:effectRef>
+          <a:fontRef idx="minor">
+            <a:schemeClr val="lt1"/>
+          </a:fontRef>
+        </p:style>
+        <p:txBody>
+          <a:bodyPr rtlCol="0" anchor="ctr" lIns="0" rIns="0" tIns="0" bIns="0"/>
+          <a:lstStyle/>
+          <a:p>
+            <a:pPr algn="ctr"/>
+            <a:r>
+              <a:rPr sz="750" b="1">
+                <a:solidFill>
+                  <a:srgbClr val="FFFFFF"/>
+                </a:solidFill>
+                <a:latin typeface="Arial"/>
+              </a:rPr>
+              <a:t>6</a:t>
+            </a:r>
+          </a:p>
+        </p:txBody>
+      </p:sp>
+      <p:sp>
+        <p:nvSpPr>
+          <p:cNvPr id="36" name="Panel 6 takeaway"/>
           <p:cNvSpPr txBox="1"/>
           <p:nvPr/>
         </p:nvSpPr>
         <p:spPr>
           <a:xfrm>
-            <a:off x="2737104" y="6272783"/>
-            <a:ext cx="2087880" cy="457199"/>
+            <a:off x="5373624" y="4690871"/>
+            <a:ext cx="1840991" cy="310896"/>
           </a:xfrm>
           <a:prstGeom prst="rect">
             <a:avLst/>
@@ -4537,12 +4651,12 @@
           <a:noFill/>
         </p:spPr>
         <p:txBody>
-          <a:bodyPr wrap="square" lIns="0" rIns="0" tIns="0" bIns="0" anchor="t">
+          <a:bodyPr wrap="square" lIns="0" rIns="0" tIns="0" bIns="0" anchor="ctr">
             <a:spAutoFit/>
           </a:bodyPr>
           <a:lstStyle/>
           <a:p>
-            <a:pPr algn="l">
+            <a:pPr>
               <a:lnSpc>
                 <a:spcPct val="105000"/>
               </a:lnSpc>
@@ -4551,161 +4665,20 @@
               </a:spcAft>
             </a:pPr>
             <a:r>
-              <a:rPr sz="570" b="0">
-                <a:solidFill>
-                  <a:srgbClr val="52514E"/>
+              <a:rPr sz="780" b="1">
+                <a:solidFill>
+                  <a:srgbClr val="0B0B0B"/>
                 </a:solidFill>
                 <a:latin typeface="Arial"/>
               </a:rPr>
-              <a:t>2025 prices. Dots are projects, large markers era medians; points on one grey curve cost the same. From 1990–08 to 2013–18 floor area fell 40% and PSF rose 27%, and the median price fell from S$1.72M to S$1.45M. Post-2019 homes are 7% larger and cost S$2.05M.</a:t>
-            </a:r>
-          </a:p>
-        </p:txBody>
-      </p:sp>
-      <p:sp>
-        <p:nvSpPr>
-          <p:cNvPr id="36" name="Panel 6 card"/>
-          <p:cNvSpPr/>
-          <p:nvPr/>
-        </p:nvSpPr>
-        <p:spPr>
-          <a:xfrm>
-            <a:off x="5035296" y="4471416"/>
-            <a:ext cx="2252472" cy="2286000"/>
-          </a:xfrm>
-          <a:prstGeom prst="roundRect">
-            <a:avLst>
-              <a:gd name="adj" fmla="val 4000"/>
-            </a:avLst>
-          </a:prstGeom>
-          <a:solidFill>
-            <a:srgbClr val="F4F5F7"/>
-          </a:solidFill>
-          <a:ln>
-            <a:noFill/>
-          </a:ln>
-          <a:effectLst/>
-        </p:spPr>
-        <p:style>
-          <a:lnRef idx="1">
-            <a:schemeClr val="accent1"/>
-          </a:lnRef>
-          <a:fillRef idx="3">
-            <a:schemeClr val="accent1"/>
-          </a:fillRef>
-          <a:effectRef idx="2">
-            <a:schemeClr val="accent1"/>
-          </a:effectRef>
-          <a:fontRef idx="minor">
-            <a:schemeClr val="lt1"/>
-          </a:fontRef>
-        </p:style>
-        <p:txBody>
-          <a:bodyPr rtlCol="0" anchor="ctr"/>
-          <a:lstStyle/>
-          <a:p>
-            <a:pPr algn="ctr"/>
-          </a:p>
-        </p:txBody>
-      </p:sp>
-      <p:sp>
-        <p:nvSpPr>
-          <p:cNvPr id="37" name="Panel 6 number"/>
-          <p:cNvSpPr/>
-          <p:nvPr/>
-        </p:nvSpPr>
-        <p:spPr>
-          <a:xfrm>
-            <a:off x="5108448" y="4544568"/>
-            <a:ext cx="182880" cy="182880"/>
-          </a:xfrm>
-          <a:prstGeom prst="ellipse">
-            <a:avLst/>
-          </a:prstGeom>
-          <a:solidFill>
-            <a:srgbClr val="0D366B"/>
-          </a:solidFill>
-          <a:ln>
-            <a:noFill/>
-          </a:ln>
-          <a:effectLst/>
-        </p:spPr>
-        <p:style>
-          <a:lnRef idx="1">
-            <a:schemeClr val="accent1"/>
-          </a:lnRef>
-          <a:fillRef idx="3">
-            <a:schemeClr val="accent1"/>
-          </a:fillRef>
-          <a:effectRef idx="2">
-            <a:schemeClr val="accent1"/>
-          </a:effectRef>
-          <a:fontRef idx="minor">
-            <a:schemeClr val="lt1"/>
-          </a:fontRef>
-        </p:style>
-        <p:txBody>
-          <a:bodyPr rtlCol="0" anchor="ctr" lIns="0" rIns="0" tIns="0" bIns="0"/>
-          <a:lstStyle/>
-          <a:p>
-            <a:pPr algn="ctr"/>
-            <a:r>
-              <a:rPr sz="700" b="1">
-                <a:solidFill>
-                  <a:srgbClr val="FFFFFF"/>
-                </a:solidFill>
-                <a:latin typeface="Arial"/>
-              </a:rPr>
-              <a:t>6</a:t>
-            </a:r>
-          </a:p>
-        </p:txBody>
-      </p:sp>
-      <p:sp>
-        <p:nvSpPr>
-          <p:cNvPr id="38" name="Panel 6 headline"/>
-          <p:cNvSpPr txBox="1"/>
-          <p:nvPr/>
-        </p:nvSpPr>
-        <p:spPr>
-          <a:xfrm>
-            <a:off x="5346192" y="4526279"/>
-            <a:ext cx="1868424" cy="292608"/>
-          </a:xfrm>
-          <a:prstGeom prst="rect">
-            <a:avLst/>
-          </a:prstGeom>
-          <a:noFill/>
-        </p:spPr>
-        <p:txBody>
-          <a:bodyPr wrap="square" lIns="0" rIns="0" tIns="0" bIns="0" anchor="ctr">
-            <a:spAutoFit/>
-          </a:bodyPr>
-          <a:lstStyle/>
-          <a:p>
-            <a:pPr algn="l">
-              <a:lnSpc>
-                <a:spcPct val="105000"/>
-              </a:lnSpc>
-              <a:spcAft>
-                <a:spcPts val="0"/>
-              </a:spcAft>
-            </a:pPr>
-            <a:r>
-              <a:rPr sz="720" b="1">
-                <a:solidFill>
-                  <a:srgbClr val="0B0B0B"/>
-                </a:solidFill>
-                <a:latin typeface="Arial"/>
-              </a:rPr>
-              <a:t>A launch is priced per sq ft, so floor area is the only lever on the price tag</a:t>
+              <a:t>Every unit size sells at its project's PSF, within 1.5%</a:t>
             </a:r>
           </a:p>
         </p:txBody>
       </p:sp>
       <p:pic>
         <p:nvPicPr>
-          <p:cNvPr id="39" name="Panel 6 figure" descr="06_violin_pricing.png"/>
+          <p:cNvPr id="37" name="Panel 6 figure" descr="06_violin_pricing.png"/>
           <p:cNvPicPr>
             <a:picLocks noChangeAspect="1"/>
           </p:cNvPicPr>
@@ -4719,8 +4692,8 @@
         </p:blipFill>
         <p:spPr>
           <a:xfrm>
-            <a:off x="5109972" y="4828031"/>
-            <a:ext cx="2103120" cy="1417320"/>
+            <a:off x="5082540" y="5020055"/>
+            <a:ext cx="2157984" cy="1783080"/>
           </a:xfrm>
           <a:prstGeom prst="rect">
             <a:avLst/>
@@ -4729,14 +4702,14 @@
       </p:pic>
       <p:sp>
         <p:nvSpPr>
-          <p:cNvPr id="40" name="Panel 6 caption"/>
+          <p:cNvPr id="38" name="Row 3 label"/>
           <p:cNvSpPr txBox="1"/>
           <p:nvPr/>
         </p:nvSpPr>
         <p:spPr>
           <a:xfrm>
-            <a:off x="5117592" y="6272783"/>
-            <a:ext cx="2087880" cy="457199"/>
+            <a:off x="274320" y="6894575"/>
+            <a:ext cx="7013448" cy="164592"/>
           </a:xfrm>
           <a:prstGeom prst="rect">
             <a:avLst/>
@@ -4744,12 +4717,12 @@
           <a:noFill/>
         </p:spPr>
         <p:txBody>
-          <a:bodyPr wrap="square" lIns="0" rIns="0" tIns="0" bIns="0" anchor="t">
+          <a:bodyPr wrap="square" lIns="0" rIns="0" tIns="0" bIns="0" anchor="ctr">
             <a:spAutoFit/>
           </a:bodyPr>
           <a:lstStyle/>
           <a:p>
-            <a:pPr algn="l">
+            <a:pPr>
               <a:lnSpc>
                 <a:spcPct val="105000"/>
               </a:lnSpc>
@@ -4758,27 +4731,126 @@
               </a:spcAft>
             </a:pPr>
             <a:r>
-              <a:rPr sz="570" b="0">
-                <a:solidFill>
-                  <a:srgbClr val="52514E"/>
+              <a:rPr sz="700" b="1">
+                <a:solidFill>
+                  <a:srgbClr val="1C5CAB"/>
                 </a:solidFill>
                 <a:latin typeface="Arial"/>
               </a:rPr>
-              <a:t>2025 new sales in 50 projects with 20+ sales (10,389 units), each unit's PSF against its own project's median. Every size band's median sits within 1.5% of zero. Price moves one for one with floor area, so a lower price tag means fewer sq ft.</a:t>
-            </a:r>
-          </a:p>
-        </p:txBody>
-      </p:sp>
-      <p:sp>
-        <p:nvSpPr>
-          <p:cNvPr id="41" name="Row 3 label"/>
+              <a:t>3   WHY IT HAPPENED, AND WHAT CHANGED</a:t>
+            </a:r>
+          </a:p>
+        </p:txBody>
+      </p:sp>
+      <p:sp>
+        <p:nvSpPr>
+          <p:cNvPr id="39" name="Panel 7 card"/>
+          <p:cNvSpPr/>
+          <p:nvPr/>
+        </p:nvSpPr>
+        <p:spPr>
+          <a:xfrm>
+            <a:off x="274320" y="7086599"/>
+            <a:ext cx="2252472" cy="2194560"/>
+          </a:xfrm>
+          <a:prstGeom prst="roundRect">
+            <a:avLst>
+              <a:gd name="adj" fmla="val 4000"/>
+            </a:avLst>
+          </a:prstGeom>
+          <a:solidFill>
+            <a:srgbClr val="F4F5F7"/>
+          </a:solidFill>
+          <a:ln>
+            <a:noFill/>
+          </a:ln>
+          <a:effectLst/>
+        </p:spPr>
+        <p:style>
+          <a:lnRef idx="1">
+            <a:schemeClr val="accent1"/>
+          </a:lnRef>
+          <a:fillRef idx="3">
+            <a:schemeClr val="accent1"/>
+          </a:fillRef>
+          <a:effectRef idx="2">
+            <a:schemeClr val="accent1"/>
+          </a:effectRef>
+          <a:fontRef idx="minor">
+            <a:schemeClr val="lt1"/>
+          </a:fontRef>
+        </p:style>
+        <p:txBody>
+          <a:bodyPr rtlCol="0" anchor="ctr"/>
+          <a:lstStyle/>
+          <a:p>
+            <a:pPr algn="ctr"/>
+          </a:p>
+        </p:txBody>
+      </p:sp>
+      <p:sp>
+        <p:nvSpPr>
+          <p:cNvPr id="40" name="Panel 7 number"/>
+          <p:cNvSpPr/>
+          <p:nvPr/>
+        </p:nvSpPr>
+        <p:spPr>
+          <a:xfrm>
+            <a:off x="347472" y="7178039"/>
+            <a:ext cx="201168" cy="201168"/>
+          </a:xfrm>
+          <a:prstGeom prst="ellipse">
+            <a:avLst/>
+          </a:prstGeom>
+          <a:solidFill>
+            <a:srgbClr val="0D366B"/>
+          </a:solidFill>
+          <a:ln>
+            <a:noFill/>
+          </a:ln>
+          <a:effectLst/>
+        </p:spPr>
+        <p:style>
+          <a:lnRef idx="1">
+            <a:schemeClr val="accent1"/>
+          </a:lnRef>
+          <a:fillRef idx="3">
+            <a:schemeClr val="accent1"/>
+          </a:fillRef>
+          <a:effectRef idx="2">
+            <a:schemeClr val="accent1"/>
+          </a:effectRef>
+          <a:fontRef idx="minor">
+            <a:schemeClr val="lt1"/>
+          </a:fontRef>
+        </p:style>
+        <p:txBody>
+          <a:bodyPr rtlCol="0" anchor="ctr" lIns="0" rIns="0" tIns="0" bIns="0"/>
+          <a:lstStyle/>
+          <a:p>
+            <a:pPr algn="ctr"/>
+            <a:r>
+              <a:rPr sz="750" b="1">
+                <a:solidFill>
+                  <a:srgbClr val="FFFFFF"/>
+                </a:solidFill>
+                <a:latin typeface="Arial"/>
+              </a:rPr>
+              <a:t>7</a:t>
+            </a:r>
+          </a:p>
+        </p:txBody>
+      </p:sp>
+      <p:sp>
+        <p:nvSpPr>
+          <p:cNvPr id="41" name="Panel 7 takeaway"/>
           <p:cNvSpPr txBox="1"/>
           <p:nvPr/>
         </p:nvSpPr>
         <p:spPr>
           <a:xfrm>
-            <a:off x="274320" y="6793992"/>
-            <a:ext cx="7013448" cy="164592"/>
+            <a:off x="612647" y="7132319"/>
+            <a:ext cx="1840991" cy="310896"/>
           </a:xfrm>
           <a:prstGeom prst="rect">
             <a:avLst/>
@@ -4791,7 +4863,7 @@
           </a:bodyPr>
           <a:lstStyle/>
           <a:p>
-            <a:pPr algn="l">
+            <a:pPr>
               <a:lnSpc>
                 <a:spcPct val="105000"/>
               </a:lnSpc>
@@ -4800,161 +4872,20 @@
               </a:spcAft>
             </a:pPr>
             <a:r>
-              <a:rPr sz="680" b="1">
-                <a:solidFill>
-                  <a:srgbClr val="1C5CAB"/>
+              <a:rPr sz="780" b="1">
+                <a:solidFill>
+                  <a:srgbClr val="0B0B0B"/>
                 </a:solidFill>
                 <a:latin typeface="Arial"/>
               </a:rPr>
-              <a:t>3   WHY IT HAPPENED, AND WHAT CHANGED</a:t>
-            </a:r>
-          </a:p>
-        </p:txBody>
-      </p:sp>
-      <p:sp>
-        <p:nvSpPr>
-          <p:cNvPr id="42" name="Panel 7 card"/>
-          <p:cNvSpPr/>
-          <p:nvPr/>
-        </p:nvSpPr>
-        <p:spPr>
-          <a:xfrm>
-            <a:off x="274320" y="6976871"/>
-            <a:ext cx="2252472" cy="2286000"/>
-          </a:xfrm>
-          <a:prstGeom prst="roundRect">
-            <a:avLst>
-              <a:gd name="adj" fmla="val 4000"/>
-            </a:avLst>
-          </a:prstGeom>
-          <a:solidFill>
-            <a:srgbClr val="F4F5F7"/>
-          </a:solidFill>
-          <a:ln>
-            <a:noFill/>
-          </a:ln>
-          <a:effectLst/>
-        </p:spPr>
-        <p:style>
-          <a:lnRef idx="1">
-            <a:schemeClr val="accent1"/>
-          </a:lnRef>
-          <a:fillRef idx="3">
-            <a:schemeClr val="accent1"/>
-          </a:fillRef>
-          <a:effectRef idx="2">
-            <a:schemeClr val="accent1"/>
-          </a:effectRef>
-          <a:fontRef idx="minor">
-            <a:schemeClr val="lt1"/>
-          </a:fontRef>
-        </p:style>
-        <p:txBody>
-          <a:bodyPr rtlCol="0" anchor="ctr"/>
-          <a:lstStyle/>
-          <a:p>
-            <a:pPr algn="ctr"/>
-          </a:p>
-        </p:txBody>
-      </p:sp>
-      <p:sp>
-        <p:nvSpPr>
-          <p:cNvPr id="43" name="Panel 7 number"/>
-          <p:cNvSpPr/>
-          <p:nvPr/>
-        </p:nvSpPr>
-        <p:spPr>
-          <a:xfrm>
-            <a:off x="347472" y="7050023"/>
-            <a:ext cx="182880" cy="182880"/>
-          </a:xfrm>
-          <a:prstGeom prst="ellipse">
-            <a:avLst/>
-          </a:prstGeom>
-          <a:solidFill>
-            <a:srgbClr val="0D366B"/>
-          </a:solidFill>
-          <a:ln>
-            <a:noFill/>
-          </a:ln>
-          <a:effectLst/>
-        </p:spPr>
-        <p:style>
-          <a:lnRef idx="1">
-            <a:schemeClr val="accent1"/>
-          </a:lnRef>
-          <a:fillRef idx="3">
-            <a:schemeClr val="accent1"/>
-          </a:fillRef>
-          <a:effectRef idx="2">
-            <a:schemeClr val="accent1"/>
-          </a:effectRef>
-          <a:fontRef idx="minor">
-            <a:schemeClr val="lt1"/>
-          </a:fontRef>
-        </p:style>
-        <p:txBody>
-          <a:bodyPr rtlCol="0" anchor="ctr" lIns="0" rIns="0" tIns="0" bIns="0"/>
-          <a:lstStyle/>
-          <a:p>
-            <a:pPr algn="ctr"/>
-            <a:r>
-              <a:rPr sz="700" b="1">
-                <a:solidFill>
-                  <a:srgbClr val="FFFFFF"/>
-                </a:solidFill>
-                <a:latin typeface="Arial"/>
-              </a:rPr>
-              <a:t>7</a:t>
-            </a:r>
-          </a:p>
-        </p:txBody>
-      </p:sp>
-      <p:sp>
-        <p:nvSpPr>
-          <p:cNvPr id="44" name="Panel 7 headline"/>
-          <p:cNvSpPr txBox="1"/>
-          <p:nvPr/>
-        </p:nvSpPr>
-        <p:spPr>
-          <a:xfrm>
-            <a:off x="585216" y="7031735"/>
-            <a:ext cx="1868424" cy="292608"/>
-          </a:xfrm>
-          <a:prstGeom prst="rect">
-            <a:avLst/>
-          </a:prstGeom>
-          <a:noFill/>
-        </p:spPr>
-        <p:txBody>
-          <a:bodyPr wrap="square" lIns="0" rIns="0" tIns="0" bIns="0" anchor="ctr">
-            <a:spAutoFit/>
-          </a:bodyPr>
-          <a:lstStyle/>
-          <a:p>
-            <a:pPr algn="l">
-              <a:lnSpc>
-                <a:spcPct val="105000"/>
-              </a:lnSpc>
-              <a:spcAft>
-                <a:spcPts val="0"/>
-              </a:spcAft>
-            </a:pPr>
-            <a:r>
-              <a:rPr sz="720" b="1">
-                <a:solidFill>
-                  <a:srgbClr val="0B0B0B"/>
-                </a:solidFill>
-                <a:latin typeface="Arial"/>
-              </a:rPr>
-              <a:t>Prices ran furthest ahead of incomes in 2007–13, when that land was sold</a:t>
+              <a:t>Least affordable in 2007–13, when that land was sold</a:t>
             </a:r>
           </a:p>
         </p:txBody>
       </p:sp>
       <p:pic>
         <p:nvPicPr>
-          <p:cNvPr id="45" name="Panel 7 figure" descr="07_lollipop_macro.png"/>
+          <p:cNvPr id="42" name="Panel 7 figure" descr="07_lollipop_macro.png"/>
           <p:cNvPicPr>
             <a:picLocks noChangeAspect="1"/>
           </p:cNvPicPr>
@@ -4968,8 +4899,8 @@
         </p:blipFill>
         <p:spPr>
           <a:xfrm>
-            <a:off x="348996" y="7333488"/>
-            <a:ext cx="2103120" cy="1417320"/>
+            <a:off x="321564" y="7461503"/>
+            <a:ext cx="2157984" cy="1783080"/>
           </a:xfrm>
           <a:prstGeom prst="rect">
             <a:avLst/>
@@ -4978,14 +4909,113 @@
       </p:pic>
       <p:sp>
         <p:nvSpPr>
-          <p:cNvPr id="46" name="Panel 7 caption"/>
+          <p:cNvPr id="43" name="Panel 8 card"/>
+          <p:cNvSpPr/>
+          <p:nvPr/>
+        </p:nvSpPr>
+        <p:spPr>
+          <a:xfrm>
+            <a:off x="2654808" y="7086599"/>
+            <a:ext cx="2252472" cy="2194560"/>
+          </a:xfrm>
+          <a:prstGeom prst="roundRect">
+            <a:avLst>
+              <a:gd name="adj" fmla="val 4000"/>
+            </a:avLst>
+          </a:prstGeom>
+          <a:solidFill>
+            <a:srgbClr val="F4F5F7"/>
+          </a:solidFill>
+          <a:ln>
+            <a:noFill/>
+          </a:ln>
+          <a:effectLst/>
+        </p:spPr>
+        <p:style>
+          <a:lnRef idx="1">
+            <a:schemeClr val="accent1"/>
+          </a:lnRef>
+          <a:fillRef idx="3">
+            <a:schemeClr val="accent1"/>
+          </a:fillRef>
+          <a:effectRef idx="2">
+            <a:schemeClr val="accent1"/>
+          </a:effectRef>
+          <a:fontRef idx="minor">
+            <a:schemeClr val="lt1"/>
+          </a:fontRef>
+        </p:style>
+        <p:txBody>
+          <a:bodyPr rtlCol="0" anchor="ctr"/>
+          <a:lstStyle/>
+          <a:p>
+            <a:pPr algn="ctr"/>
+          </a:p>
+        </p:txBody>
+      </p:sp>
+      <p:sp>
+        <p:nvSpPr>
+          <p:cNvPr id="44" name="Panel 8 number"/>
+          <p:cNvSpPr/>
+          <p:nvPr/>
+        </p:nvSpPr>
+        <p:spPr>
+          <a:xfrm>
+            <a:off x="2727960" y="7178039"/>
+            <a:ext cx="201168" cy="201168"/>
+          </a:xfrm>
+          <a:prstGeom prst="ellipse">
+            <a:avLst/>
+          </a:prstGeom>
+          <a:solidFill>
+            <a:srgbClr val="0D366B"/>
+          </a:solidFill>
+          <a:ln>
+            <a:noFill/>
+          </a:ln>
+          <a:effectLst/>
+        </p:spPr>
+        <p:style>
+          <a:lnRef idx="1">
+            <a:schemeClr val="accent1"/>
+          </a:lnRef>
+          <a:fillRef idx="3">
+            <a:schemeClr val="accent1"/>
+          </a:fillRef>
+          <a:effectRef idx="2">
+            <a:schemeClr val="accent1"/>
+          </a:effectRef>
+          <a:fontRef idx="minor">
+            <a:schemeClr val="lt1"/>
+          </a:fontRef>
+        </p:style>
+        <p:txBody>
+          <a:bodyPr rtlCol="0" anchor="ctr" lIns="0" rIns="0" tIns="0" bIns="0"/>
+          <a:lstStyle/>
+          <a:p>
+            <a:pPr algn="ctr"/>
+            <a:r>
+              <a:rPr sz="750" b="1">
+                <a:solidFill>
+                  <a:srgbClr val="FFFFFF"/>
+                </a:solidFill>
+                <a:latin typeface="Arial"/>
+              </a:rPr>
+              <a:t>8</a:t>
+            </a:r>
+          </a:p>
+        </p:txBody>
+      </p:sp>
+      <p:sp>
+        <p:nvSpPr>
+          <p:cNvPr id="45" name="Panel 8 takeaway"/>
           <p:cNvSpPr txBox="1"/>
           <p:nvPr/>
         </p:nvSpPr>
         <p:spPr>
           <a:xfrm>
-            <a:off x="356616" y="8778240"/>
-            <a:ext cx="2087880" cy="457199"/>
+            <a:off x="2993136" y="7132319"/>
+            <a:ext cx="1840991" cy="310896"/>
           </a:xfrm>
           <a:prstGeom prst="rect">
             <a:avLst/>
@@ -4993,12 +5023,12 @@
           <a:noFill/>
         </p:spPr>
         <p:txBody>
-          <a:bodyPr wrap="square" lIns="0" rIns="0" tIns="0" bIns="0" anchor="t">
+          <a:bodyPr wrap="square" lIns="0" rIns="0" tIns="0" bIns="0" anchor="ctr">
             <a:spAutoFit/>
           </a:bodyPr>
           <a:lstStyle/>
           <a:p>
-            <a:pPr algn="l">
+            <a:pPr>
               <a:lnSpc>
                 <a:spcPct val="105000"/>
               </a:lnSpc>
@@ -5007,161 +5037,20 @@
               </a:spcAft>
             </a:pPr>
             <a:r>
-              <a:rPr sz="570" b="0">
-                <a:solidFill>
-                  <a:srgbClr val="52514E"/>
+              <a:rPr sz="780" b="1">
+                <a:solidFill>
+                  <a:srgbClr val="0B0B0B"/>
                 </a:solidFill>
                 <a:latin typeface="Arial"/>
               </a:rPr>
-              <a:t>URA non-landed price index [2] ÷ median household income [3], against the 2001–25 average. Every year from 2007 to 2013 except 2009 was 6–18% less affordable than usual. Incomes then caught up, and by 2025 the ratio was near average.</a:t>
-            </a:r>
-          </a:p>
-        </p:txBody>
-      </p:sp>
-      <p:sp>
-        <p:nvSpPr>
-          <p:cNvPr id="47" name="Panel 8 card"/>
-          <p:cNvSpPr/>
-          <p:nvPr/>
-        </p:nvSpPr>
-        <p:spPr>
-          <a:xfrm>
-            <a:off x="2654808" y="6976871"/>
-            <a:ext cx="2252472" cy="2286000"/>
-          </a:xfrm>
-          <a:prstGeom prst="roundRect">
-            <a:avLst>
-              <a:gd name="adj" fmla="val 4000"/>
-            </a:avLst>
-          </a:prstGeom>
-          <a:solidFill>
-            <a:srgbClr val="F4F5F7"/>
-          </a:solidFill>
-          <a:ln>
-            <a:noFill/>
-          </a:ln>
-          <a:effectLst/>
-        </p:spPr>
-        <p:style>
-          <a:lnRef idx="1">
-            <a:schemeClr val="accent1"/>
-          </a:lnRef>
-          <a:fillRef idx="3">
-            <a:schemeClr val="accent1"/>
-          </a:fillRef>
-          <a:effectRef idx="2">
-            <a:schemeClr val="accent1"/>
-          </a:effectRef>
-          <a:fontRef idx="minor">
-            <a:schemeClr val="lt1"/>
-          </a:fontRef>
-        </p:style>
-        <p:txBody>
-          <a:bodyPr rtlCol="0" anchor="ctr"/>
-          <a:lstStyle/>
-          <a:p>
-            <a:pPr algn="ctr"/>
-          </a:p>
-        </p:txBody>
-      </p:sp>
-      <p:sp>
-        <p:nvSpPr>
-          <p:cNvPr id="48" name="Panel 8 number"/>
-          <p:cNvSpPr/>
-          <p:nvPr/>
-        </p:nvSpPr>
-        <p:spPr>
-          <a:xfrm>
-            <a:off x="2727960" y="7050023"/>
-            <a:ext cx="182880" cy="182880"/>
-          </a:xfrm>
-          <a:prstGeom prst="ellipse">
-            <a:avLst/>
-          </a:prstGeom>
-          <a:solidFill>
-            <a:srgbClr val="0D366B"/>
-          </a:solidFill>
-          <a:ln>
-            <a:noFill/>
-          </a:ln>
-          <a:effectLst/>
-        </p:spPr>
-        <p:style>
-          <a:lnRef idx="1">
-            <a:schemeClr val="accent1"/>
-          </a:lnRef>
-          <a:fillRef idx="3">
-            <a:schemeClr val="accent1"/>
-          </a:fillRef>
-          <a:effectRef idx="2">
-            <a:schemeClr val="accent1"/>
-          </a:effectRef>
-          <a:fontRef idx="minor">
-            <a:schemeClr val="lt1"/>
-          </a:fontRef>
-        </p:style>
-        <p:txBody>
-          <a:bodyPr rtlCol="0" anchor="ctr" lIns="0" rIns="0" tIns="0" bIns="0"/>
-          <a:lstStyle/>
-          <a:p>
-            <a:pPr algn="ctr"/>
-            <a:r>
-              <a:rPr sz="700" b="1">
-                <a:solidFill>
-                  <a:srgbClr val="FFFFFF"/>
-                </a:solidFill>
-                <a:latin typeface="Arial"/>
-              </a:rPr>
-              <a:t>8</a:t>
-            </a:r>
-          </a:p>
-        </p:txBody>
-      </p:sp>
-      <p:sp>
-        <p:nvSpPr>
-          <p:cNvPr id="49" name="Panel 8 headline"/>
-          <p:cNvSpPr txBox="1"/>
-          <p:nvPr/>
-        </p:nvSpPr>
-        <p:spPr>
-          <a:xfrm>
-            <a:off x="2965704" y="7031735"/>
-            <a:ext cx="1868424" cy="292608"/>
-          </a:xfrm>
-          <a:prstGeom prst="rect">
-            <a:avLst/>
-          </a:prstGeom>
-          <a:noFill/>
-        </p:spPr>
-        <p:txBody>
-          <a:bodyPr wrap="square" lIns="0" rIns="0" tIns="0" bIns="0" anchor="ctr">
-            <a:spAutoFit/>
-          </a:bodyPr>
-          <a:lstStyle/>
-          <a:p>
-            <a:pPr algn="l">
-              <a:lnSpc>
-                <a:spcPct val="105000"/>
-              </a:lnSpc>
-              <a:spcAft>
-                <a:spcPts val="0"/>
-              </a:spcAft>
-            </a:pPr>
-            <a:r>
-              <a:rPr sz="720" b="1">
-                <a:solidFill>
-                  <a:srgbClr val="0B0B0B"/>
-                </a:solidFill>
-                <a:latin typeface="Arial"/>
-              </a:rPr>
-              <a:t>At 2025 launch prices, the median household can borrow for 743 sq ft</a:t>
+              <a:t>The median household can borrow for under 800 sq ft</a:t>
             </a:r>
           </a:p>
         </p:txBody>
       </p:sp>
       <p:pic>
         <p:nvPicPr>
-          <p:cNvPr id="50" name="Panel 8 figure" descr="08_heatmap_tdsr.png"/>
+          <p:cNvPr id="46" name="Panel 8 figure" descr="08_heatmap_tdsr.png"/>
           <p:cNvPicPr>
             <a:picLocks noChangeAspect="1"/>
           </p:cNvPicPr>
@@ -5175,8 +5064,8 @@
         </p:blipFill>
         <p:spPr>
           <a:xfrm>
-            <a:off x="2729484" y="7333488"/>
-            <a:ext cx="2103120" cy="1417320"/>
+            <a:off x="2702052" y="7461503"/>
+            <a:ext cx="2157984" cy="1783080"/>
           </a:xfrm>
           <a:prstGeom prst="rect">
             <a:avLst/>
@@ -5185,14 +5074,113 @@
       </p:pic>
       <p:sp>
         <p:nvSpPr>
-          <p:cNvPr id="51" name="Panel 8 caption"/>
+          <p:cNvPr id="47" name="Panel 9 card"/>
+          <p:cNvSpPr/>
+          <p:nvPr/>
+        </p:nvSpPr>
+        <p:spPr>
+          <a:xfrm>
+            <a:off x="5035296" y="7086599"/>
+            <a:ext cx="2252472" cy="2194560"/>
+          </a:xfrm>
+          <a:prstGeom prst="roundRect">
+            <a:avLst>
+              <a:gd name="adj" fmla="val 4000"/>
+            </a:avLst>
+          </a:prstGeom>
+          <a:solidFill>
+            <a:srgbClr val="F4F5F7"/>
+          </a:solidFill>
+          <a:ln>
+            <a:noFill/>
+          </a:ln>
+          <a:effectLst/>
+        </p:spPr>
+        <p:style>
+          <a:lnRef idx="1">
+            <a:schemeClr val="accent1"/>
+          </a:lnRef>
+          <a:fillRef idx="3">
+            <a:schemeClr val="accent1"/>
+          </a:fillRef>
+          <a:effectRef idx="2">
+            <a:schemeClr val="accent1"/>
+          </a:effectRef>
+          <a:fontRef idx="minor">
+            <a:schemeClr val="lt1"/>
+          </a:fontRef>
+        </p:style>
+        <p:txBody>
+          <a:bodyPr rtlCol="0" anchor="ctr"/>
+          <a:lstStyle/>
+          <a:p>
+            <a:pPr algn="ctr"/>
+          </a:p>
+        </p:txBody>
+      </p:sp>
+      <p:sp>
+        <p:nvSpPr>
+          <p:cNvPr id="48" name="Panel 9 number"/>
+          <p:cNvSpPr/>
+          <p:nvPr/>
+        </p:nvSpPr>
+        <p:spPr>
+          <a:xfrm>
+            <a:off x="5108448" y="7178039"/>
+            <a:ext cx="201168" cy="201168"/>
+          </a:xfrm>
+          <a:prstGeom prst="ellipse">
+            <a:avLst/>
+          </a:prstGeom>
+          <a:solidFill>
+            <a:srgbClr val="0D366B"/>
+          </a:solidFill>
+          <a:ln>
+            <a:noFill/>
+          </a:ln>
+          <a:effectLst/>
+        </p:spPr>
+        <p:style>
+          <a:lnRef idx="1">
+            <a:schemeClr val="accent1"/>
+          </a:lnRef>
+          <a:fillRef idx="3">
+            <a:schemeClr val="accent1"/>
+          </a:fillRef>
+          <a:effectRef idx="2">
+            <a:schemeClr val="accent1"/>
+          </a:effectRef>
+          <a:fontRef idx="minor">
+            <a:schemeClr val="lt1"/>
+          </a:fontRef>
+        </p:style>
+        <p:txBody>
+          <a:bodyPr rtlCol="0" anchor="ctr" lIns="0" rIns="0" tIns="0" bIns="0"/>
+          <a:lstStyle/>
+          <a:p>
+            <a:pPr algn="ctr"/>
+            <a:r>
+              <a:rPr sz="750" b="1">
+                <a:solidFill>
+                  <a:srgbClr val="FFFFFF"/>
+                </a:solidFill>
+                <a:latin typeface="Arial"/>
+              </a:rPr>
+              <a:t>9</a:t>
+            </a:r>
+          </a:p>
+        </p:txBody>
+      </p:sp>
+      <p:sp>
+        <p:nvSpPr>
+          <p:cNvPr id="49" name="Panel 9 takeaway"/>
           <p:cNvSpPr txBox="1"/>
           <p:nvPr/>
         </p:nvSpPr>
         <p:spPr>
           <a:xfrm>
-            <a:off x="2737104" y="8778240"/>
-            <a:ext cx="2087880" cy="457199"/>
+            <a:off x="5373624" y="7132319"/>
+            <a:ext cx="1840991" cy="310896"/>
           </a:xfrm>
           <a:prstGeom prst="rect">
             <a:avLst/>
@@ -5200,12 +5188,12 @@
           <a:noFill/>
         </p:spPr>
         <p:txBody>
-          <a:bodyPr wrap="square" lIns="0" rIns="0" tIns="0" bIns="0" anchor="t">
+          <a:bodyPr wrap="square" lIns="0" rIns="0" tIns="0" bIns="0" anchor="ctr">
             <a:spAutoFit/>
           </a:bodyPr>
           <a:lstStyle/>
           <a:p>
-            <a:pPr algn="l">
+            <a:pPr>
               <a:lnSpc>
                 <a:spcPct val="105000"/>
               </a:lnSpc>
@@ -5214,161 +5202,20 @@
               </a:spcAft>
             </a:pPr>
             <a:r>
-              <a:rPr sz="570" b="0">
-                <a:solidFill>
-                  <a:srgbClr val="52514E"/>
+              <a:rPr sz="780" b="1">
+                <a:solidFill>
+                  <a:srgbClr val="0B0B0B"/>
                 </a:solidFill>
                 <a:latin typeface="Arial"/>
               </a:rPr>
-              <a:t>Affordable area = largest loan under MAS rules (repayments ≤55% of income at 4% [4]) ÷ 75% LTV ÷ PSF. Orange boxes miss the 797 sq ft median new unit. At median income (S$12,446 [3]) reach fell from 1,117 sq ft at 2020 PSF to 743. Rate cuts below 4% change nothing.</a:t>
-            </a:r>
-          </a:p>
-        </p:txBody>
-      </p:sp>
-      <p:sp>
-        <p:nvSpPr>
-          <p:cNvPr id="52" name="Panel 9 card"/>
-          <p:cNvSpPr/>
-          <p:nvPr/>
-        </p:nvSpPr>
-        <p:spPr>
-          <a:xfrm>
-            <a:off x="5035296" y="6976871"/>
-            <a:ext cx="2252472" cy="2286000"/>
-          </a:xfrm>
-          <a:prstGeom prst="roundRect">
-            <a:avLst>
-              <a:gd name="adj" fmla="val 4000"/>
-            </a:avLst>
-          </a:prstGeom>
-          <a:solidFill>
-            <a:srgbClr val="F4F5F7"/>
-          </a:solidFill>
-          <a:ln>
-            <a:noFill/>
-          </a:ln>
-          <a:effectLst/>
-        </p:spPr>
-        <p:style>
-          <a:lnRef idx="1">
-            <a:schemeClr val="accent1"/>
-          </a:lnRef>
-          <a:fillRef idx="3">
-            <a:schemeClr val="accent1"/>
-          </a:fillRef>
-          <a:effectRef idx="2">
-            <a:schemeClr val="accent1"/>
-          </a:effectRef>
-          <a:fontRef idx="minor">
-            <a:schemeClr val="lt1"/>
-          </a:fontRef>
-        </p:style>
-        <p:txBody>
-          <a:bodyPr rtlCol="0" anchor="ctr"/>
-          <a:lstStyle/>
-          <a:p>
-            <a:pPr algn="ctr"/>
-          </a:p>
-        </p:txBody>
-      </p:sp>
-      <p:sp>
-        <p:nvSpPr>
-          <p:cNvPr id="53" name="Panel 9 number"/>
-          <p:cNvSpPr/>
-          <p:nvPr/>
-        </p:nvSpPr>
-        <p:spPr>
-          <a:xfrm>
-            <a:off x="5108448" y="7050023"/>
-            <a:ext cx="182880" cy="182880"/>
-          </a:xfrm>
-          <a:prstGeom prst="ellipse">
-            <a:avLst/>
-          </a:prstGeom>
-          <a:solidFill>
-            <a:srgbClr val="0D366B"/>
-          </a:solidFill>
-          <a:ln>
-            <a:noFill/>
-          </a:ln>
-          <a:effectLst/>
-        </p:spPr>
-        <p:style>
-          <a:lnRef idx="1">
-            <a:schemeClr val="accent1"/>
-          </a:lnRef>
-          <a:fillRef idx="3">
-            <a:schemeClr val="accent1"/>
-          </a:fillRef>
-          <a:effectRef idx="2">
-            <a:schemeClr val="accent1"/>
-          </a:effectRef>
-          <a:fontRef idx="minor">
-            <a:schemeClr val="lt1"/>
-          </a:fontRef>
-        </p:style>
-        <p:txBody>
-          <a:bodyPr rtlCol="0" anchor="ctr" lIns="0" rIns="0" tIns="0" bIns="0"/>
-          <a:lstStyle/>
-          <a:p>
-            <a:pPr algn="ctr"/>
-            <a:r>
-              <a:rPr sz="700" b="1">
-                <a:solidFill>
-                  <a:srgbClr val="FFFFFF"/>
-                </a:solidFill>
-                <a:latin typeface="Arial"/>
-              </a:rPr>
-              <a:t>9</a:t>
-            </a:r>
-          </a:p>
-        </p:txBody>
-      </p:sp>
-      <p:sp>
-        <p:nvSpPr>
-          <p:cNvPr id="54" name="Panel 9 headline"/>
-          <p:cNvSpPr txBox="1"/>
-          <p:nvPr/>
-        </p:nvSpPr>
-        <p:spPr>
-          <a:xfrm>
-            <a:off x="5346192" y="7031735"/>
-            <a:ext cx="1868424" cy="292608"/>
-          </a:xfrm>
-          <a:prstGeom prst="rect">
-            <a:avLst/>
-          </a:prstGeom>
-          <a:noFill/>
-        </p:spPr>
-        <p:txBody>
-          <a:bodyPr wrap="square" lIns="0" rIns="0" tIns="0" bIns="0" anchor="ctr">
-            <a:spAutoFit/>
-          </a:bodyPr>
-          <a:lstStyle/>
-          <a:p>
-            <a:pPr algn="l">
-              <a:lnSpc>
-                <a:spcPct val="105000"/>
-              </a:lnSpc>
-              <a:spcAft>
-                <a:spcPts val="0"/>
-              </a:spcAft>
-            </a:pPr>
-            <a:r>
-              <a:rPr sz="720" b="1">
-                <a:solidFill>
-                  <a:srgbClr val="0B0B0B"/>
-                </a:solidFill>
-                <a:latin typeface="Arial"/>
-              </a:rPr>
-              <a:t>With shrinking capped, the new-launch price tag rose 49% in five years</a:t>
+              <a:t>Price tag S$1.46M → S$2.18M, driven by PSF (+39%)</a:t>
             </a:r>
           </a:p>
         </p:txBody>
       </p:sp>
       <p:pic>
         <p:nvPicPr>
-          <p:cNvPr id="55" name="Panel 9 figure" descr="09_waterfall.png"/>
+          <p:cNvPr id="50" name="Panel 9 figure" descr="09_waterfall.png"/>
           <p:cNvPicPr>
             <a:picLocks noChangeAspect="1"/>
           </p:cNvPicPr>
@@ -5382,8 +5229,8 @@
         </p:blipFill>
         <p:spPr>
           <a:xfrm>
-            <a:off x="5109972" y="7333488"/>
-            <a:ext cx="2103120" cy="1417320"/>
+            <a:off x="5082540" y="7461503"/>
+            <a:ext cx="2157984" cy="1783080"/>
           </a:xfrm>
           <a:prstGeom prst="rect">
             <a:avLst/>
@@ -5392,14 +5239,60 @@
       </p:pic>
       <p:sp>
         <p:nvSpPr>
-          <p:cNvPr id="56" name="Panel 9 caption"/>
+          <p:cNvPr id="51" name="Answer card"/>
+          <p:cNvSpPr/>
+          <p:nvPr/>
+        </p:nvSpPr>
+        <p:spPr>
+          <a:xfrm>
+            <a:off x="274320" y="9363455"/>
+            <a:ext cx="7013448" cy="896112"/>
+          </a:xfrm>
+          <a:prstGeom prst="roundRect">
+            <a:avLst>
+              <a:gd name="adj" fmla="val 4000"/>
+            </a:avLst>
+          </a:prstGeom>
+          <a:solidFill>
+            <a:srgbClr val="0D366B"/>
+          </a:solidFill>
+          <a:ln>
+            <a:noFill/>
+          </a:ln>
+          <a:effectLst/>
+        </p:spPr>
+        <p:style>
+          <a:lnRef idx="1">
+            <a:schemeClr val="accent1"/>
+          </a:lnRef>
+          <a:fillRef idx="3">
+            <a:schemeClr val="accent1"/>
+          </a:fillRef>
+          <a:effectRef idx="2">
+            <a:schemeClr val="accent1"/>
+          </a:effectRef>
+          <a:fontRef idx="minor">
+            <a:schemeClr val="lt1"/>
+          </a:fontRef>
+        </p:style>
+        <p:txBody>
+          <a:bodyPr rtlCol="0" anchor="ctr"/>
+          <a:lstStyle/>
+          <a:p>
+            <a:pPr algn="ctr"/>
+          </a:p>
+        </p:txBody>
+      </p:sp>
+      <p:sp>
+        <p:nvSpPr>
+          <p:cNvPr id="52" name="Answer line"/>
           <p:cNvSpPr txBox="1"/>
           <p:nvPr/>
         </p:nvSpPr>
         <p:spPr>
           <a:xfrm>
-            <a:off x="5117592" y="8778240"/>
-            <a:ext cx="2087880" cy="457199"/>
+            <a:off x="420623" y="9436607"/>
+            <a:ext cx="6720840" cy="310896"/>
           </a:xfrm>
           <a:prstGeom prst="rect">
             <a:avLst/>
@@ -5407,12 +5300,12 @@
           <a:noFill/>
         </p:spPr>
         <p:txBody>
-          <a:bodyPr wrap="square" lIns="0" rIns="0" tIns="0" bIns="0" anchor="t">
+          <a:bodyPr wrap="square" lIns="0" rIns="0" tIns="0" bIns="0" anchor="ctr">
             <a:spAutoFit/>
           </a:bodyPr>
           <a:lstStyle/>
           <a:p>
-            <a:pPr algn="l">
+            <a:pPr>
               <a:lnSpc>
                 <a:spcPct val="105000"/>
               </a:lnSpc>
@@ -5421,35 +5314,42 @@
               </a:spcAft>
             </a:pPr>
             <a:r>
-              <a:rPr sz="570" b="0">
-                <a:solidFill>
-                  <a:srgbClr val="52514E"/>
+              <a:rPr sz="919" b="1">
+                <a:solidFill>
+                  <a:srgbClr val="F7B89C"/>
                 </a:solidFill>
                 <a:latin typeface="Arial"/>
               </a:rPr>
-              <a:t>Typical new-launch price, late 2020 against 2025, split exactly into PSF and floor area (geometric means, each region against itself, 2025 weights). PSF added 39% and floor area 7%. Units no longer shrink, so buyers now pay the whole PSF rise.</a:t>
-            </a:r>
-          </a:p>
-        </p:txBody>
-      </p:sp>
-      <p:sp>
-        <p:nvSpPr>
-          <p:cNvPr id="57" name="Conclusion card"/>
+              <a:t>Answer: </a:t>
+            </a:r>
+            <a:r>
+              <a:rPr sz="919" b="1">
+                <a:solidFill>
+                  <a:srgbClr val="FFFFFF"/>
+                </a:solidFill>
+                <a:latin typeface="Arial"/>
+              </a:rPr>
+              <a:t>yes, until URA stopped it. Homes shrank about 40% to hold the price tag down. Now that shrinking is capped, the price tag rises instead.</a:t>
+            </a:r>
+          </a:p>
+        </p:txBody>
+      </p:sp>
+      <p:sp>
+        <p:nvSpPr>
+          <p:cNvPr id="53" name="Finding 1 number"/>
           <p:cNvSpPr/>
           <p:nvPr/>
         </p:nvSpPr>
         <p:spPr>
           <a:xfrm>
-            <a:off x="274320" y="9326879"/>
-            <a:ext cx="7013448" cy="850392"/>
-          </a:xfrm>
-          <a:prstGeom prst="roundRect">
-            <a:avLst>
-              <a:gd name="adj" fmla="val 4000"/>
-            </a:avLst>
+            <a:off x="420623" y="9848087"/>
+            <a:ext cx="182880" cy="182880"/>
+          </a:xfrm>
+          <a:prstGeom prst="ellipse">
+            <a:avLst/>
           </a:prstGeom>
           <a:solidFill>
-            <a:srgbClr val="0D366B"/>
+            <a:srgbClr val="EB6834"/>
           </a:solidFill>
           <a:ln>
             <a:noFill/>
@@ -5471,23 +5371,32 @@
           </a:fontRef>
         </p:style>
         <p:txBody>
-          <a:bodyPr rtlCol="0" anchor="ctr"/>
+          <a:bodyPr rtlCol="0" anchor="ctr" lIns="0" rIns="0" tIns="0" bIns="0"/>
           <a:lstStyle/>
           <a:p>
             <a:pPr algn="ctr"/>
-          </a:p>
-        </p:txBody>
-      </p:sp>
-      <p:sp>
-        <p:nvSpPr>
-          <p:cNvPr id="58" name="Answer text"/>
+            <a:r>
+              <a:rPr sz="700" b="1">
+                <a:solidFill>
+                  <a:srgbClr val="FFFFFF"/>
+                </a:solidFill>
+                <a:latin typeface="Arial"/>
+              </a:rPr>
+              <a:t>1</a:t>
+            </a:r>
+          </a:p>
+        </p:txBody>
+      </p:sp>
+      <p:sp>
+        <p:nvSpPr>
+          <p:cNvPr id="54" name="Finding 1"/>
           <p:cNvSpPr txBox="1"/>
           <p:nvPr/>
         </p:nvSpPr>
         <p:spPr>
           <a:xfrm>
-            <a:off x="384048" y="9400031"/>
-            <a:ext cx="3253709" cy="722376"/>
+            <a:off x="676656" y="9820655"/>
+            <a:ext cx="1862327" cy="402336"/>
           </a:xfrm>
           <a:prstGeom prst="rect">
             <a:avLst/>
@@ -5500,55 +5409,184 @@
           </a:bodyPr>
           <a:lstStyle/>
           <a:p>
-            <a:pPr algn="l">
+            <a:pPr>
               <a:lnSpc>
                 <a:spcPct val="105000"/>
               </a:lnSpc>
               <a:spcAft>
-                <a:spcPts val="150"/>
+                <a:spcPts val="0"/>
               </a:spcAft>
             </a:pPr>
             <a:r>
-              <a:rPr sz="750" b="1">
+              <a:rPr sz="720" b="0">
                 <a:solidFill>
                   <a:srgbClr val="FFFFFF"/>
                 </a:solidFill>
                 <a:latin typeface="Arial"/>
               </a:rPr>
-              <a:t>Answer</a:t>
-            </a:r>
-          </a:p>
-          <a:p>
-            <a:pPr algn="l">
+              <a:t>Homes on land sold after 2008 are about 40% smaller, and big homes all but disappeared</a:t>
+            </a:r>
+          </a:p>
+        </p:txBody>
+      </p:sp>
+      <p:sp>
+        <p:nvSpPr>
+          <p:cNvPr id="55" name="Finding 2 number"/>
+          <p:cNvSpPr/>
+          <p:nvPr/>
+        </p:nvSpPr>
+        <p:spPr>
+          <a:xfrm>
+            <a:off x="2721864" y="9848087"/>
+            <a:ext cx="182880" cy="182880"/>
+          </a:xfrm>
+          <a:prstGeom prst="ellipse">
+            <a:avLst/>
+          </a:prstGeom>
+          <a:solidFill>
+            <a:srgbClr val="EB6834"/>
+          </a:solidFill>
+          <a:ln>
+            <a:noFill/>
+          </a:ln>
+          <a:effectLst/>
+        </p:spPr>
+        <p:style>
+          <a:lnRef idx="1">
+            <a:schemeClr val="accent1"/>
+          </a:lnRef>
+          <a:fillRef idx="3">
+            <a:schemeClr val="accent1"/>
+          </a:fillRef>
+          <a:effectRef idx="2">
+            <a:schemeClr val="accent1"/>
+          </a:effectRef>
+          <a:fontRef idx="minor">
+            <a:schemeClr val="lt1"/>
+          </a:fontRef>
+        </p:style>
+        <p:txBody>
+          <a:bodyPr rtlCol="0" anchor="ctr" lIns="0" rIns="0" tIns="0" bIns="0"/>
+          <a:lstStyle/>
+          <a:p>
+            <a:pPr algn="ctr"/>
+            <a:r>
+              <a:rPr sz="700" b="1">
+                <a:solidFill>
+                  <a:srgbClr val="FFFFFF"/>
+                </a:solidFill>
+                <a:latin typeface="Arial"/>
+              </a:rPr>
+              <a:t>2</a:t>
+            </a:r>
+          </a:p>
+        </p:txBody>
+      </p:sp>
+      <p:sp>
+        <p:nvSpPr>
+          <p:cNvPr id="56" name="Finding 2"/>
+          <p:cNvSpPr txBox="1"/>
+          <p:nvPr/>
+        </p:nvSpPr>
+        <p:spPr>
+          <a:xfrm>
+            <a:off x="2977896" y="9820655"/>
+            <a:ext cx="1862327" cy="402336"/>
+          </a:xfrm>
+          <a:prstGeom prst="rect">
+            <a:avLst/>
+          </a:prstGeom>
+          <a:noFill/>
+        </p:spPr>
+        <p:txBody>
+          <a:bodyPr wrap="square" lIns="0" rIns="0" tIns="0" bIns="0" anchor="t">
+            <a:spAutoFit/>
+          </a:bodyPr>
+          <a:lstStyle/>
+          <a:p>
+            <a:pPr>
               <a:lnSpc>
                 <a:spcPct val="105000"/>
               </a:lnSpc>
               <a:spcAft>
-                <a:spcPts val="150"/>
+                <a:spcPts val="0"/>
               </a:spcAft>
             </a:pPr>
             <a:r>
-              <a:rPr sz="630" b="0">
+              <a:rPr sz="720" b="0">
                 <a:solidFill>
                   <a:srgbClr val="FFFFFF"/>
                 </a:solidFill>
                 <a:latin typeface="Arial"/>
               </a:rPr>
-              <a:t>Yes, until URA stopped it. Homes on land sold in 2009–13, when prices ran furthest ahead of incomes, are about 40% smaller than earlier homes in the same districts, and that kept their price tags down. Launches are priced per sq ft, so cutting floor area was the only way. URA's unit caps put a floor under sizes near 750 sq ft. Since then the PSF rise has gone straight into the price tag (+49% from late 2020 to 2025), which now sits at the edge of what a median household can borrow.</a:t>
-            </a:r>
-          </a:p>
-        </p:txBody>
-      </p:sp>
-      <p:sp>
-        <p:nvSpPr>
-          <p:cNvPr id="59" name="Recommendations text"/>
+              <a:t>It is not location. It works because a launch is priced per sq ft, so fewer sq ft means a lower price tag</a:t>
+            </a:r>
+          </a:p>
+        </p:txBody>
+      </p:sp>
+      <p:sp>
+        <p:nvSpPr>
+          <p:cNvPr id="57" name="Finding 3 number"/>
+          <p:cNvSpPr/>
+          <p:nvPr/>
+        </p:nvSpPr>
+        <p:spPr>
+          <a:xfrm>
+            <a:off x="5023104" y="9848087"/>
+            <a:ext cx="182880" cy="182880"/>
+          </a:xfrm>
+          <a:prstGeom prst="ellipse">
+            <a:avLst/>
+          </a:prstGeom>
+          <a:solidFill>
+            <a:srgbClr val="EB6834"/>
+          </a:solidFill>
+          <a:ln>
+            <a:noFill/>
+          </a:ln>
+          <a:effectLst/>
+        </p:spPr>
+        <p:style>
+          <a:lnRef idx="1">
+            <a:schemeClr val="accent1"/>
+          </a:lnRef>
+          <a:fillRef idx="3">
+            <a:schemeClr val="accent1"/>
+          </a:fillRef>
+          <a:effectRef idx="2">
+            <a:schemeClr val="accent1"/>
+          </a:effectRef>
+          <a:fontRef idx="minor">
+            <a:schemeClr val="lt1"/>
+          </a:fontRef>
+        </p:style>
+        <p:txBody>
+          <a:bodyPr rtlCol="0" anchor="ctr" lIns="0" rIns="0" tIns="0" bIns="0"/>
+          <a:lstStyle/>
+          <a:p>
+            <a:pPr algn="ctr"/>
+            <a:r>
+              <a:rPr sz="700" b="1">
+                <a:solidFill>
+                  <a:srgbClr val="FFFFFF"/>
+                </a:solidFill>
+                <a:latin typeface="Arial"/>
+              </a:rPr>
+              <a:t>3</a:t>
+            </a:r>
+          </a:p>
+        </p:txBody>
+      </p:sp>
+      <p:sp>
+        <p:nvSpPr>
+          <p:cNvPr id="58" name="Finding 3"/>
           <p:cNvSpPr txBox="1"/>
           <p:nvPr/>
         </p:nvSpPr>
         <p:spPr>
           <a:xfrm>
-            <a:off x="3756629" y="9400031"/>
-            <a:ext cx="3421410" cy="722376"/>
+            <a:off x="5279136" y="9820655"/>
+            <a:ext cx="1862327" cy="402336"/>
           </a:xfrm>
           <a:prstGeom prst="rect">
             <a:avLst/>
@@ -5561,120 +5599,36 @@
           </a:bodyPr>
           <a:lstStyle/>
           <a:p>
-            <a:pPr algn="l">
+            <a:pPr>
               <a:lnSpc>
                 <a:spcPct val="105000"/>
               </a:lnSpc>
               <a:spcAft>
-                <a:spcPts val="120"/>
+                <a:spcPts val="0"/>
               </a:spcAft>
             </a:pPr>
             <a:r>
-              <a:rPr sz="750" b="1">
+              <a:rPr sz="720" b="0">
                 <a:solidFill>
                   <a:srgbClr val="FFFFFF"/>
                 </a:solidFill>
                 <a:latin typeface="Arial"/>
               </a:rPr>
-              <a:t>Recommendations</a:t>
-            </a:r>
-          </a:p>
-          <a:p>
-            <a:pPr algn="l">
-              <a:lnSpc>
-                <a:spcPct val="105000"/>
-              </a:lnSpc>
-              <a:spcAft>
-                <a:spcPts val="120"/>
-              </a:spcAft>
-            </a:pPr>
-            <a:r>
-              <a:rPr sz="620" b="1">
-                <a:solidFill>
-                  <a:srgbClr val="FFFFFF"/>
-                </a:solidFill>
-                <a:latin typeface="Arial"/>
-              </a:rPr>
-              <a:t>Buyers: </a:t>
-            </a:r>
-            <a:r>
-              <a:rPr sz="620" b="0">
-                <a:solidFill>
-                  <a:srgbClr val="FFFFFF"/>
-                </a:solidFill>
-                <a:latin typeface="Arial"/>
-              </a:rPr>
-              <a:t>compare PSF and space, not the price tag. A 2025 resale home gives 47% more floor area per dollar than a new launch (S$1,747 against S$2,572 PSF), in exchange for age and a shorter lease.</a:t>
-            </a:r>
-          </a:p>
-          <a:p>
-            <a:pPr algn="l">
-              <a:lnSpc>
-                <a:spcPct val="105000"/>
-              </a:lnSpc>
-              <a:spcAft>
-                <a:spcPts val="120"/>
-              </a:spcAft>
-            </a:pPr>
-            <a:r>
-              <a:rPr sz="620" b="1">
-                <a:solidFill>
-                  <a:srgbClr val="FFFFFF"/>
-                </a:solidFill>
-                <a:latin typeface="Arial"/>
-              </a:rPr>
-              <a:t>Developers: </a:t>
-            </a:r>
-            <a:r>
-              <a:rPr sz="620" b="0">
-                <a:solidFill>
-                  <a:srgbClr val="FFFFFF"/>
-                </a:solidFill>
-                <a:latin typeface="Arial"/>
-              </a:rPr>
-              <a:t>with shrinking capped, layouts that waste less space are what is left to compete on.</a:t>
-            </a:r>
-          </a:p>
-          <a:p>
-            <a:pPr algn="l">
-              <a:lnSpc>
-                <a:spcPct val="105000"/>
-              </a:lnSpc>
-              <a:spcAft>
-                <a:spcPts val="120"/>
-              </a:spcAft>
-            </a:pPr>
-            <a:r>
-              <a:rPr sz="620" b="1">
-                <a:solidFill>
-                  <a:srgbClr val="FFFFFF"/>
-                </a:solidFill>
-                <a:latin typeface="Arial"/>
-              </a:rPr>
-              <a:t>Policymakers: </a:t>
-            </a:r>
-            <a:r>
-              <a:rPr sz="620" b="0">
-                <a:solidFill>
-                  <a:srgbClr val="FFFFFF"/>
-                </a:solidFill>
-                <a:latin typeface="Arial"/>
-              </a:rPr>
-              <a:t>the cap protects living space but moves the pressure onto price. Affordability now rests on land supply and income growth.</a:t>
-            </a:r>
-          </a:p>
-        </p:txBody>
-      </p:sp>
-      <p:sp>
-        <p:nvSpPr>
-          <p:cNvPr id="60" name="Limitations and references"/>
+              <a:t>Prices outran incomes when that land was sold. Since the 2019 cap the new-launch price tag is up 49%</a:t>
+            </a:r>
+          </a:p>
+        </p:txBody>
+      </p:sp>
+      <p:sp>
+        <p:nvSpPr>
+          <p:cNvPr id="59" name="Footnote"/>
           <p:cNvSpPr txBox="1"/>
           <p:nvPr/>
         </p:nvSpPr>
         <p:spPr>
           <a:xfrm>
-            <a:off x="274320" y="10222991"/>
-            <a:ext cx="7013448" cy="393192"/>
+            <a:off x="274320" y="10314432"/>
+            <a:ext cx="7013448" cy="265176"/>
           </a:xfrm>
           <a:prstGeom prst="rect">
             <a:avLst/>
@@ -5687,7 +5641,7 @@
           </a:bodyPr>
           <a:lstStyle/>
           <a:p>
-            <a:pPr algn="l">
+            <a:pPr>
               <a:lnSpc>
                 <a:spcPct val="105000"/>
               </a:lnSpc>
@@ -5696,26 +5650,44 @@
               </a:spcAft>
             </a:pPr>
             <a:r>
-              <a:rPr sz="520" b="1">
+              <a:rPr sz="500" b="1">
                 <a:solidFill>
                   <a:srgbClr val="6F6E69"/>
                 </a:solidFill>
                 <a:latin typeface="Arial"/>
               </a:rPr>
-              <a:t>Limitations. </a:t>
-            </a:r>
-            <a:r>
-              <a:rPr sz="520" b="0">
+              <a:t>Data and method: </a:t>
+            </a:r>
+            <a:r>
+              <a:rPr sz="500" b="0">
                 <a:solidFill>
                   <a:srgbClr val="6F6E69"/>
                 </a:solidFill>
                 <a:latin typeface="Arial"/>
               </a:rPr>
-              <a:t>Eras are compared at 2025 prices, not their launch prices, and older homes are also cheaper per sq ft because of age and lease decay. No bedroom count; strata-area rules changed in June 2023 [6]; 2024 is missing; income includes employer CPF, so true borrowing power is a little lower. All results are associations, not causal effects.</a:t>
-            </a:r>
-          </a:p>
-          <a:p>
-            <a:pPr algn="l">
+              <a:t>24,131 URA private home sales in 2025 and 74,436 from Aug 2020 to Dec 2023 [1]; 155 rows outside 200–5,000 sq ft removed. Charts 2–5 use 99-year leaseholds grouped by lease-start year. Chart 7 uses the URA price index [2] and SingStat household income [3]; chart 8 applies MAS loan rules [4]. </a:t>
+            </a:r>
+            <a:r>
+              <a:rPr sz="500" b="1">
+                <a:solidFill>
+                  <a:srgbClr val="6F6E69"/>
+                </a:solidFill>
+                <a:latin typeface="Arial"/>
+              </a:rPr>
+              <a:t>Limitations: </a:t>
+            </a:r>
+            <a:r>
+              <a:rPr sz="500" b="0">
+                <a:solidFill>
+                  <a:srgbClr val="6F6E69"/>
+                </a:solidFill>
+                <a:latin typeface="Arial"/>
+              </a:rPr>
+              <a:t>eras are compared at 2025 prices, so older homes also carry age and lease decay; no bedroom count; 2024 missing; associations, not causal effects.</a:t>
+            </a:r>
+          </a:p>
+          <a:p>
+            <a:pPr>
               <a:lnSpc>
                 <a:spcPct val="105000"/>
               </a:lnSpc>
@@ -5724,22 +5696,22 @@
               </a:spcAft>
             </a:pPr>
             <a:r>
-              <a:rPr sz="520" b="1">
+              <a:rPr sz="500" b="1">
                 <a:solidFill>
                   <a:srgbClr val="6F6E69"/>
                 </a:solidFill>
                 <a:latin typeface="Arial"/>
               </a:rPr>
-              <a:t>References. </a:t>
-            </a:r>
-            <a:r>
-              <a:rPr sz="520" b="0">
+              <a:t>Sources: </a:t>
+            </a:r>
+            <a:r>
+              <a:rPr sz="500" b="0">
                 <a:solidFill>
                   <a:srgbClr val="6F6E69"/>
                 </a:solidFill>
                 <a:latin typeface="Arial"/>
               </a:rPr>
-              <a:t>[1] URA REALIS via DAO2702 (properties2025.csv; Lecture 6 properties23.csv). [2] URA Private Residential Property Price Index, data.gov.sg. [3] SingStat household employment income, data.gov.sg; Key Household Income Trends 2025. [4] MAS: TDSR 55% (Dec 2021) and 4% rate floor (Sep 2022), via DBS. [5] URA circular DC18-06 (2018). [6] Huttons via EdgeProp (2025), Are home sizes in Singapore shrinking? [7] ONS (2019), The impact of shrinkflation on CPIH. Code: shrinkflation.ipynb.</a:t>
+              <a:t>[1] URA REALIS via DAO2702 (2025; Lecture 6, 2020–23). [2] URA Private Residential Price Index, data.gov.sg. [3] SingStat household income, data.gov.sg. [4] MAS: TDSR 55%, 4% stress rate. [5] URA circular DC18-06 (2018). [6] ONS (2019), shrinkflation and CPIH. Code: shrinkflation.ipynb.</a:t>
             </a:r>
           </a:p>
         </p:txBody>

</xml_diff>

<commit_message>
Grey terms line, taller charts, team names, fuller guide
Header is now the question plus two light-grey lines with the terms
needed to read the charts; the freed space makes every chart taller.
Adds Team Jupyter and member names, extends the presenting guide
(hand-in rules, background, the URA unit cap in detail, statistics in
plain words, key numbers, spoken lines) and the Poster_Jupyter.zip
submission file.

Co-Authored-By: Claude Opus 5.5 <noreply@anthropic.com>
</commit_message>
<xml_diff>
--- a/shrinkflation_poster.pptx
+++ b/shrinkflation_poster.pptx
@@ -3132,14 +3132,14 @@
       </p:sp>
       <p:sp>
         <p:nvSpPr>
-          <p:cNvPr id="3" name="Question"/>
+          <p:cNvPr id="3" name="Team line"/>
           <p:cNvSpPr txBox="1"/>
           <p:nvPr/>
         </p:nvSpPr>
         <p:spPr>
           <a:xfrm>
-            <a:off x="274320" y="566928"/>
-            <a:ext cx="7013448" cy="201168"/>
+            <a:off x="274320" y="548640"/>
+            <a:ext cx="7013448" cy="128016"/>
           </a:xfrm>
           <a:prstGeom prst="rect">
             <a:avLst/>
@@ -3161,27 +3161,27 @@
               </a:spcAft>
             </a:pPr>
             <a:r>
-              <a:rPr sz="1250" b="0">
-                <a:solidFill>
-                  <a:srgbClr val="0B0B0B"/>
+              <a:rPr sz="650" b="0">
+                <a:solidFill>
+                  <a:srgbClr val="6F6E69"/>
                 </a:solidFill>
                 <a:latin typeface="Arial"/>
               </a:rPr>
-              <a:t>Did homes shrink to keep the price tag within reach, and is it still happening in 2025?</a:t>
-            </a:r>
-          </a:p>
-        </p:txBody>
-      </p:sp>
-      <p:sp>
-        <p:nvSpPr>
-          <p:cNvPr id="4" name="Team line"/>
+              <a:t>DAO2702 Group Assignment  ·  Team Jupyter  ·  Martin, Huaitao (Aizen) Yu, Manan, Linda, Midhvan Agarwal, Hoyoung Hwang</a:t>
+            </a:r>
+          </a:p>
+        </p:txBody>
+      </p:sp>
+      <p:sp>
+        <p:nvSpPr>
+          <p:cNvPr id="4" name="Question"/>
           <p:cNvSpPr txBox="1"/>
           <p:nvPr/>
         </p:nvSpPr>
         <p:spPr>
           <a:xfrm>
-            <a:off x="274320" y="804672"/>
-            <a:ext cx="7013448" cy="128016"/>
+            <a:off x="274320" y="731520"/>
+            <a:ext cx="7013448" cy="219456"/>
           </a:xfrm>
           <a:prstGeom prst="rect">
             <a:avLst/>
@@ -3203,73 +3203,27 @@
               </a:spcAft>
             </a:pPr>
             <a:r>
-              <a:rPr sz="650" b="0">
-                <a:solidFill>
-                  <a:srgbClr val="6F6E69"/>
+              <a:rPr sz="1300" b="0">
+                <a:solidFill>
+                  <a:srgbClr val="0B0B0B"/>
                 </a:solidFill>
                 <a:latin typeface="Arial"/>
               </a:rPr>
-              <a:t>DAO2702 Group Assignment  ·  Team [team name]  ·  [member names]</a:t>
-            </a:r>
-          </a:p>
-        </p:txBody>
-      </p:sp>
-      <p:sp>
-        <p:nvSpPr>
-          <p:cNvPr id="5" name="Key terms card"/>
-          <p:cNvSpPr/>
-          <p:nvPr/>
-        </p:nvSpPr>
-        <p:spPr>
-          <a:xfrm>
-            <a:off x="274320" y="969264"/>
-            <a:ext cx="7013448" cy="978408"/>
-          </a:xfrm>
-          <a:prstGeom prst="roundRect">
-            <a:avLst>
-              <a:gd name="adj" fmla="val 4000"/>
-            </a:avLst>
-          </a:prstGeom>
-          <a:solidFill>
-            <a:srgbClr val="EEF4FC"/>
-          </a:solidFill>
-          <a:ln>
-            <a:noFill/>
-          </a:ln>
-          <a:effectLst/>
-        </p:spPr>
-        <p:style>
-          <a:lnRef idx="1">
-            <a:schemeClr val="accent1"/>
-          </a:lnRef>
-          <a:fillRef idx="3">
-            <a:schemeClr val="accent1"/>
-          </a:fillRef>
-          <a:effectRef idx="2">
-            <a:schemeClr val="accent1"/>
-          </a:effectRef>
-          <a:fontRef idx="minor">
-            <a:schemeClr val="lt1"/>
-          </a:fontRef>
-        </p:style>
-        <p:txBody>
-          <a:bodyPr rtlCol="0" anchor="ctr"/>
-          <a:lstStyle/>
-          <a:p>
-            <a:pPr algn="ctr"/>
-          </a:p>
-        </p:txBody>
-      </p:sp>
-      <p:sp>
-        <p:nvSpPr>
-          <p:cNvPr id="6" name="Term Shrinkflation"/>
+              <a:t>Did homes shrink to keep the price tag within reach, and is it still happening in 2025?</a:t>
+            </a:r>
+          </a:p>
+        </p:txBody>
+      </p:sp>
+      <p:sp>
+        <p:nvSpPr>
+          <p:cNvPr id="5" name="Terms line"/>
           <p:cNvSpPr txBox="1"/>
           <p:nvPr/>
         </p:nvSpPr>
         <p:spPr>
           <a:xfrm>
-            <a:off x="393192" y="1051560"/>
-            <a:ext cx="2124456" cy="402336"/>
+            <a:off x="274320" y="1005840"/>
+            <a:ext cx="7013448" cy="201168"/>
           </a:xfrm>
           <a:prstGeom prst="rect">
             <a:avLst/>
@@ -3278,372 +3232,6 @@
         </p:spPr>
         <p:txBody>
           <a:bodyPr wrap="square" lIns="0" rIns="0" tIns="0" bIns="0" anchor="t">
-            <a:spAutoFit/>
-          </a:bodyPr>
-          <a:lstStyle/>
-          <a:p>
-            <a:pPr>
-              <a:lnSpc>
-                <a:spcPct val="105000"/>
-              </a:lnSpc>
-              <a:spcAft>
-                <a:spcPts val="80"/>
-              </a:spcAft>
-            </a:pPr>
-            <a:r>
-              <a:rPr sz="760" b="1">
-                <a:solidFill>
-                  <a:srgbClr val="0D366B"/>
-                </a:solidFill>
-                <a:latin typeface="Arial"/>
-              </a:rPr>
-              <a:t>Shrinkflation</a:t>
-            </a:r>
-          </a:p>
-          <a:p>
-            <a:pPr>
-              <a:lnSpc>
-                <a:spcPct val="105000"/>
-              </a:lnSpc>
-              <a:spcAft>
-                <a:spcPts val="80"/>
-              </a:spcAft>
-            </a:pPr>
-            <a:r>
-              <a:rPr sz="680" b="0">
-                <a:solidFill>
-                  <a:srgbClr val="0B0B0B"/>
-                </a:solidFill>
-                <a:latin typeface="Arial"/>
-              </a:rPr>
-              <a:t>Less product for the same price tag. For a home: fewer sq ft for the same total price [6].</a:t>
-            </a:r>
-          </a:p>
-        </p:txBody>
-      </p:sp>
-      <p:sp>
-        <p:nvSpPr>
-          <p:cNvPr id="7" name="Term Price tag = floor area × PSF"/>
-          <p:cNvSpPr txBox="1"/>
-          <p:nvPr/>
-        </p:nvSpPr>
-        <p:spPr>
-          <a:xfrm>
-            <a:off x="2718816" y="1051560"/>
-            <a:ext cx="2124456" cy="402336"/>
-          </a:xfrm>
-          <a:prstGeom prst="rect">
-            <a:avLst/>
-          </a:prstGeom>
-          <a:noFill/>
-        </p:spPr>
-        <p:txBody>
-          <a:bodyPr wrap="square" lIns="0" rIns="0" tIns="0" bIns="0" anchor="t">
-            <a:spAutoFit/>
-          </a:bodyPr>
-          <a:lstStyle/>
-          <a:p>
-            <a:pPr>
-              <a:lnSpc>
-                <a:spcPct val="105000"/>
-              </a:lnSpc>
-              <a:spcAft>
-                <a:spcPts val="80"/>
-              </a:spcAft>
-            </a:pPr>
-            <a:r>
-              <a:rPr sz="760" b="1">
-                <a:solidFill>
-                  <a:srgbClr val="0D366B"/>
-                </a:solidFill>
-                <a:latin typeface="Arial"/>
-              </a:rPr>
-              <a:t>Price tag = floor area × PSF</a:t>
-            </a:r>
-          </a:p>
-          <a:p>
-            <a:pPr>
-              <a:lnSpc>
-                <a:spcPct val="105000"/>
-              </a:lnSpc>
-              <a:spcAft>
-                <a:spcPts val="80"/>
-              </a:spcAft>
-            </a:pPr>
-            <a:r>
-              <a:rPr sz="680" b="0">
-                <a:solidFill>
-                  <a:srgbClr val="0B0B0B"/>
-                </a:solidFill>
-                <a:latin typeface="Arial"/>
-              </a:rPr>
-              <a:t>PSF is the price per square foot. When PSF rises, a smaller unit keeps the price tag flat.</a:t>
-            </a:r>
-          </a:p>
-        </p:txBody>
-      </p:sp>
-      <p:sp>
-        <p:nvSpPr>
-          <p:cNvPr id="8" name="Term New launch vs resale"/>
-          <p:cNvSpPr txBox="1"/>
-          <p:nvPr/>
-        </p:nvSpPr>
-        <p:spPr>
-          <a:xfrm>
-            <a:off x="5044440" y="1051560"/>
-            <a:ext cx="2124456" cy="402336"/>
-          </a:xfrm>
-          <a:prstGeom prst="rect">
-            <a:avLst/>
-          </a:prstGeom>
-          <a:noFill/>
-        </p:spPr>
-        <p:txBody>
-          <a:bodyPr wrap="square" lIns="0" rIns="0" tIns="0" bIns="0" anchor="t">
-            <a:spAutoFit/>
-          </a:bodyPr>
-          <a:lstStyle/>
-          <a:p>
-            <a:pPr>
-              <a:lnSpc>
-                <a:spcPct val="105000"/>
-              </a:lnSpc>
-              <a:spcAft>
-                <a:spcPts val="80"/>
-              </a:spcAft>
-            </a:pPr>
-            <a:r>
-              <a:rPr sz="760" b="1">
-                <a:solidFill>
-                  <a:srgbClr val="0D366B"/>
-                </a:solidFill>
-                <a:latin typeface="Arial"/>
-              </a:rPr>
-              <a:t>New launch vs resale</a:t>
-            </a:r>
-          </a:p>
-          <a:p>
-            <a:pPr>
-              <a:lnSpc>
-                <a:spcPct val="105000"/>
-              </a:lnSpc>
-              <a:spcAft>
-                <a:spcPts val="80"/>
-              </a:spcAft>
-            </a:pPr>
-            <a:r>
-              <a:rPr sz="680" b="0">
-                <a:solidFill>
-                  <a:srgbClr val="0B0B0B"/>
-                </a:solidFill>
-                <a:latin typeface="Arial"/>
-              </a:rPr>
-              <a:t>A new launch is bought from the developer. A resale home is second-hand.</a:t>
-            </a:r>
-          </a:p>
-        </p:txBody>
-      </p:sp>
-      <p:sp>
-        <p:nvSpPr>
-          <p:cNvPr id="9" name="Term Lease-start year"/>
-          <p:cNvSpPr txBox="1"/>
-          <p:nvPr/>
-        </p:nvSpPr>
-        <p:spPr>
-          <a:xfrm>
-            <a:off x="393192" y="1472184"/>
-            <a:ext cx="2124456" cy="402336"/>
-          </a:xfrm>
-          <a:prstGeom prst="rect">
-            <a:avLst/>
-          </a:prstGeom>
-          <a:noFill/>
-        </p:spPr>
-        <p:txBody>
-          <a:bodyPr wrap="square" lIns="0" rIns="0" tIns="0" bIns="0" anchor="t">
-            <a:spAutoFit/>
-          </a:bodyPr>
-          <a:lstStyle/>
-          <a:p>
-            <a:pPr>
-              <a:lnSpc>
-                <a:spcPct val="105000"/>
-              </a:lnSpc>
-              <a:spcAft>
-                <a:spcPts val="80"/>
-              </a:spcAft>
-            </a:pPr>
-            <a:r>
-              <a:rPr sz="760" b="1">
-                <a:solidFill>
-                  <a:srgbClr val="0D366B"/>
-                </a:solidFill>
-                <a:latin typeface="Arial"/>
-              </a:rPr>
-              <a:t>Lease-start year</a:t>
-            </a:r>
-          </a:p>
-          <a:p>
-            <a:pPr>
-              <a:lnSpc>
-                <a:spcPct val="105000"/>
-              </a:lnSpc>
-              <a:spcAft>
-                <a:spcPts val="80"/>
-              </a:spcAft>
-            </a:pPr>
-            <a:r>
-              <a:rPr sz="680" b="0">
-                <a:solidFill>
-                  <a:srgbClr val="0B0B0B"/>
-                </a:solidFill>
-                <a:latin typeface="Arial"/>
-              </a:rPr>
-              <a:t>When a 99-year lease began, roughly the year the land was sold and the unit sizes were planned.</a:t>
-            </a:r>
-          </a:p>
-        </p:txBody>
-      </p:sp>
-      <p:sp>
-        <p:nvSpPr>
-          <p:cNvPr id="10" name="Term URA unit cap"/>
-          <p:cNvSpPr txBox="1"/>
-          <p:nvPr/>
-        </p:nvSpPr>
-        <p:spPr>
-          <a:xfrm>
-            <a:off x="2718816" y="1472184"/>
-            <a:ext cx="2124456" cy="402336"/>
-          </a:xfrm>
-          <a:prstGeom prst="rect">
-            <a:avLst/>
-          </a:prstGeom>
-          <a:noFill/>
-        </p:spPr>
-        <p:txBody>
-          <a:bodyPr wrap="square" lIns="0" rIns="0" tIns="0" bIns="0" anchor="t">
-            <a:spAutoFit/>
-          </a:bodyPr>
-          <a:lstStyle/>
-          <a:p>
-            <a:pPr>
-              <a:lnSpc>
-                <a:spcPct val="105000"/>
-              </a:lnSpc>
-              <a:spcAft>
-                <a:spcPts val="80"/>
-              </a:spcAft>
-            </a:pPr>
-            <a:r>
-              <a:rPr sz="760" b="1">
-                <a:solidFill>
-                  <a:srgbClr val="0D366B"/>
-                </a:solidFill>
-                <a:latin typeface="Arial"/>
-              </a:rPr>
-              <a:t>URA unit cap</a:t>
-            </a:r>
-          </a:p>
-          <a:p>
-            <a:pPr>
-              <a:lnSpc>
-                <a:spcPct val="105000"/>
-              </a:lnSpc>
-              <a:spcAft>
-                <a:spcPts val="80"/>
-              </a:spcAft>
-            </a:pPr>
-            <a:r>
-              <a:rPr sz="680" b="0">
-                <a:solidFill>
-                  <a:srgbClr val="0B0B0B"/>
-                </a:solidFill>
-                <a:latin typeface="Arial"/>
-              </a:rPr>
-              <a:t>Since 2012 a project's unit count is capped at floor area ÷ 70 m² (85 m² since 2019), which sets a floor under unit sizes [5].</a:t>
-            </a:r>
-          </a:p>
-        </p:txBody>
-      </p:sp>
-      <p:sp>
-        <p:nvSpPr>
-          <p:cNvPr id="11" name="Term MAS loan limit"/>
-          <p:cNvSpPr txBox="1"/>
-          <p:nvPr/>
-        </p:nvSpPr>
-        <p:spPr>
-          <a:xfrm>
-            <a:off x="5044440" y="1472184"/>
-            <a:ext cx="2124456" cy="402336"/>
-          </a:xfrm>
-          <a:prstGeom prst="rect">
-            <a:avLst/>
-          </a:prstGeom>
-          <a:noFill/>
-        </p:spPr>
-        <p:txBody>
-          <a:bodyPr wrap="square" lIns="0" rIns="0" tIns="0" bIns="0" anchor="t">
-            <a:spAutoFit/>
-          </a:bodyPr>
-          <a:lstStyle/>
-          <a:p>
-            <a:pPr>
-              <a:lnSpc>
-                <a:spcPct val="105000"/>
-              </a:lnSpc>
-              <a:spcAft>
-                <a:spcPts val="80"/>
-              </a:spcAft>
-            </a:pPr>
-            <a:r>
-              <a:rPr sz="760" b="1">
-                <a:solidFill>
-                  <a:srgbClr val="0D366B"/>
-                </a:solidFill>
-                <a:latin typeface="Arial"/>
-              </a:rPr>
-              <a:t>MAS loan limit</a:t>
-            </a:r>
-          </a:p>
-          <a:p>
-            <a:pPr>
-              <a:lnSpc>
-                <a:spcPct val="105000"/>
-              </a:lnSpc>
-              <a:spcAft>
-                <a:spcPts val="80"/>
-              </a:spcAft>
-            </a:pPr>
-            <a:r>
-              <a:rPr sz="680" b="0">
-                <a:solidFill>
-                  <a:srgbClr val="0B0B0B"/>
-                </a:solidFill>
-                <a:latin typeface="Arial"/>
-              </a:rPr>
-              <a:t>Loan repayments can take at most 55% of income, tested at 4% interest or more [4].</a:t>
-            </a:r>
-          </a:p>
-        </p:txBody>
-      </p:sp>
-      <p:sp>
-        <p:nvSpPr>
-          <p:cNvPr id="12" name="Row 1 label"/>
-          <p:cNvSpPr txBox="1"/>
-          <p:nvPr/>
-        </p:nvSpPr>
-        <p:spPr>
-          <a:xfrm>
-            <a:off x="274320" y="2011679"/>
-            <a:ext cx="7013448" cy="164592"/>
-          </a:xfrm>
-          <a:prstGeom prst="rect">
-            <a:avLst/>
-          </a:prstGeom>
-          <a:noFill/>
-        </p:spPr>
-        <p:txBody>
-          <a:bodyPr wrap="square" lIns="0" rIns="0" tIns="0" bIns="0" anchor="ctr">
             <a:spAutoFit/>
           </a:bodyPr>
           <a:lstStyle/>
@@ -3657,6 +3245,67 @@
               </a:spcAft>
             </a:pPr>
             <a:r>
+              <a:rPr sz="620" b="0">
+                <a:solidFill>
+                  <a:srgbClr val="8F8E89"/>
+                </a:solidFill>
+                <a:latin typeface="Arial"/>
+              </a:rPr>
+              <a:t>Shrinkflation: less product for the same price tag [6]   ·   PSF: price per sq ft, so price tag = floor area × PSF   ·   Lease-start year ≈ year the land was sold</a:t>
+            </a:r>
+          </a:p>
+          <a:p>
+            <a:pPr>
+              <a:lnSpc>
+                <a:spcPct val="105000"/>
+              </a:lnSpc>
+              <a:spcAft>
+                <a:spcPts val="0"/>
+              </a:spcAft>
+            </a:pPr>
+            <a:r>
+              <a:rPr sz="620" b="0">
+                <a:solidFill>
+                  <a:srgbClr val="8F8E89"/>
+                </a:solidFill>
+                <a:latin typeface="Arial"/>
+              </a:rPr>
+              <a:t>URA unit cap: units ≤ floor area ÷ 70 m² (85 m² from 2019) [5]   ·   MAS limit: loan repayments ≤ 55% of income, tested at 4% [4]</a:t>
+            </a:r>
+          </a:p>
+        </p:txBody>
+      </p:sp>
+      <p:sp>
+        <p:nvSpPr>
+          <p:cNvPr id="6" name="Row 1 label"/>
+          <p:cNvSpPr txBox="1"/>
+          <p:nvPr/>
+        </p:nvSpPr>
+        <p:spPr>
+          <a:xfrm>
+            <a:off x="274320" y="1289304"/>
+            <a:ext cx="7013448" cy="164592"/>
+          </a:xfrm>
+          <a:prstGeom prst="rect">
+            <a:avLst/>
+          </a:prstGeom>
+          <a:noFill/>
+        </p:spPr>
+        <p:txBody>
+          <a:bodyPr wrap="square" lIns="0" rIns="0" tIns="0" bIns="0" anchor="ctr">
+            <a:spAutoFit/>
+          </a:bodyPr>
+          <a:lstStyle/>
+          <a:p>
+            <a:pPr>
+              <a:lnSpc>
+                <a:spcPct val="105000"/>
+              </a:lnSpc>
+              <a:spcAft>
+                <a:spcPts val="0"/>
+              </a:spcAft>
+            </a:pPr>
+            <a:r>
               <a:rPr sz="700" b="1">
                 <a:solidFill>
                   <a:srgbClr val="1C5CAB"/>
@@ -3670,14 +3319,14 @@
       </p:sp>
       <p:sp>
         <p:nvSpPr>
-          <p:cNvPr id="13" name="Panel 1 card"/>
+          <p:cNvPr id="7" name="Panel 1 card"/>
           <p:cNvSpPr/>
           <p:nvPr/>
         </p:nvSpPr>
         <p:spPr>
           <a:xfrm>
-            <a:off x="274320" y="2203703"/>
-            <a:ext cx="2252472" cy="2194560"/>
+            <a:off x="274320" y="1481328"/>
+            <a:ext cx="2252472" cy="2423160"/>
           </a:xfrm>
           <a:prstGeom prst="roundRect">
             <a:avLst>
@@ -3716,13 +3365,13 @@
       </p:sp>
       <p:sp>
         <p:nvSpPr>
-          <p:cNvPr id="14" name="Panel 1 number"/>
+          <p:cNvPr id="8" name="Panel 1 number"/>
           <p:cNvSpPr/>
           <p:nvPr/>
         </p:nvSpPr>
         <p:spPr>
           <a:xfrm>
-            <a:off x="347472" y="2295144"/>
+            <a:off x="347472" y="1572768"/>
             <a:ext cx="201168" cy="201168"/>
           </a:xfrm>
           <a:prstGeom prst="ellipse">
@@ -3769,13 +3418,13 @@
       </p:sp>
       <p:sp>
         <p:nvSpPr>
-          <p:cNvPr id="15" name="Panel 1 takeaway"/>
+          <p:cNvPr id="9" name="Panel 1 takeaway"/>
           <p:cNvSpPr txBox="1"/>
           <p:nvPr/>
         </p:nvSpPr>
         <p:spPr>
           <a:xfrm>
-            <a:off x="612647" y="2249423"/>
+            <a:off x="612647" y="1527048"/>
             <a:ext cx="1840991" cy="310896"/>
           </a:xfrm>
           <a:prstGeom prst="rect">
@@ -3811,7 +3460,7 @@
       </p:sp>
       <p:pic>
         <p:nvPicPr>
-          <p:cNvPr id="16" name="Panel 1 figure" descr="01_histogram.png"/>
+          <p:cNvPr id="10" name="Panel 1 figure" descr="01_histogram.png"/>
           <p:cNvPicPr>
             <a:picLocks noChangeAspect="1"/>
           </p:cNvPicPr>
@@ -3825,8 +3474,8 @@
         </p:blipFill>
         <p:spPr>
           <a:xfrm>
-            <a:off x="321564" y="2578607"/>
-            <a:ext cx="2157984" cy="1783080"/>
+            <a:off x="321564" y="1856232"/>
+            <a:ext cx="2157984" cy="2011680"/>
           </a:xfrm>
           <a:prstGeom prst="rect">
             <a:avLst/>
@@ -3835,14 +3484,14 @@
       </p:pic>
       <p:sp>
         <p:nvSpPr>
-          <p:cNvPr id="17" name="Panel 2 card"/>
+          <p:cNvPr id="11" name="Panel 2 card"/>
           <p:cNvSpPr/>
           <p:nvPr/>
         </p:nvSpPr>
         <p:spPr>
           <a:xfrm>
-            <a:off x="2654808" y="2203703"/>
-            <a:ext cx="2252472" cy="2194560"/>
+            <a:off x="2654808" y="1481328"/>
+            <a:ext cx="2252472" cy="2423160"/>
           </a:xfrm>
           <a:prstGeom prst="roundRect">
             <a:avLst>
@@ -3881,13 +3530,13 @@
       </p:sp>
       <p:sp>
         <p:nvSpPr>
-          <p:cNvPr id="18" name="Panel 2 number"/>
+          <p:cNvPr id="12" name="Panel 2 number"/>
           <p:cNvSpPr/>
           <p:nvPr/>
         </p:nvSpPr>
         <p:spPr>
           <a:xfrm>
-            <a:off x="2727960" y="2295144"/>
+            <a:off x="2727960" y="1572768"/>
             <a:ext cx="201168" cy="201168"/>
           </a:xfrm>
           <a:prstGeom prst="ellipse">
@@ -3934,13 +3583,13 @@
       </p:sp>
       <p:sp>
         <p:nvSpPr>
-          <p:cNvPr id="19" name="Panel 2 takeaway"/>
+          <p:cNvPr id="13" name="Panel 2 takeaway"/>
           <p:cNvSpPr txBox="1"/>
           <p:nvPr/>
         </p:nvSpPr>
         <p:spPr>
           <a:xfrm>
-            <a:off x="2993136" y="2249423"/>
+            <a:off x="2993136" y="1527048"/>
             <a:ext cx="1840991" cy="310896"/>
           </a:xfrm>
           <a:prstGeom prst="rect">
@@ -3976,7 +3625,7 @@
       </p:sp>
       <p:pic>
         <p:nvPicPr>
-          <p:cNvPr id="20" name="Panel 2 figure" descr="02_line_vintage.png"/>
+          <p:cNvPr id="14" name="Panel 2 figure" descr="02_line_vintage.png"/>
           <p:cNvPicPr>
             <a:picLocks noChangeAspect="1"/>
           </p:cNvPicPr>
@@ -3990,8 +3639,8 @@
         </p:blipFill>
         <p:spPr>
           <a:xfrm>
-            <a:off x="2702052" y="2578607"/>
-            <a:ext cx="2157984" cy="1783080"/>
+            <a:off x="2702052" y="1856232"/>
+            <a:ext cx="2157984" cy="2011680"/>
           </a:xfrm>
           <a:prstGeom prst="rect">
             <a:avLst/>
@@ -4000,14 +3649,14 @@
       </p:pic>
       <p:sp>
         <p:nvSpPr>
-          <p:cNvPr id="21" name="Panel 3 card"/>
+          <p:cNvPr id="15" name="Panel 3 card"/>
           <p:cNvSpPr/>
           <p:nvPr/>
         </p:nvSpPr>
         <p:spPr>
           <a:xfrm>
-            <a:off x="5035296" y="2203703"/>
-            <a:ext cx="2252472" cy="2194560"/>
+            <a:off x="5035296" y="1481328"/>
+            <a:ext cx="2252472" cy="2423160"/>
           </a:xfrm>
           <a:prstGeom prst="roundRect">
             <a:avLst>
@@ -4046,13 +3695,13 @@
       </p:sp>
       <p:sp>
         <p:nvSpPr>
-          <p:cNvPr id="22" name="Panel 3 number"/>
+          <p:cNvPr id="16" name="Panel 3 number"/>
           <p:cNvSpPr/>
           <p:nvPr/>
         </p:nvSpPr>
         <p:spPr>
           <a:xfrm>
-            <a:off x="5108448" y="2295144"/>
+            <a:off x="5108448" y="1572768"/>
             <a:ext cx="201168" cy="201168"/>
           </a:xfrm>
           <a:prstGeom prst="ellipse">
@@ -4099,13 +3748,13 @@
       </p:sp>
       <p:sp>
         <p:nvSpPr>
-          <p:cNvPr id="23" name="Panel 3 takeaway"/>
+          <p:cNvPr id="17" name="Panel 3 takeaway"/>
           <p:cNvSpPr txBox="1"/>
           <p:nvPr/>
         </p:nvSpPr>
         <p:spPr>
           <a:xfrm>
-            <a:off x="5373624" y="2249423"/>
+            <a:off x="5373624" y="1527048"/>
             <a:ext cx="1840991" cy="310896"/>
           </a:xfrm>
           <a:prstGeom prst="rect">
@@ -4141,7 +3790,7 @@
       </p:sp>
       <p:pic>
         <p:nvPicPr>
-          <p:cNvPr id="24" name="Panel 3 figure" descr="03_stacked_mix.png"/>
+          <p:cNvPr id="18" name="Panel 3 figure" descr="03_stacked_mix.png"/>
           <p:cNvPicPr>
             <a:picLocks noChangeAspect="1"/>
           </p:cNvPicPr>
@@ -4155,8 +3804,8 @@
         </p:blipFill>
         <p:spPr>
           <a:xfrm>
-            <a:off x="5082540" y="2578607"/>
-            <a:ext cx="2157984" cy="1783080"/>
+            <a:off x="5082540" y="1856232"/>
+            <a:ext cx="2157984" cy="2011680"/>
           </a:xfrm>
           <a:prstGeom prst="rect">
             <a:avLst/>
@@ -4165,13 +3814,13 @@
       </p:pic>
       <p:sp>
         <p:nvSpPr>
-          <p:cNvPr id="25" name="Row 2 label"/>
+          <p:cNvPr id="19" name="Row 2 label"/>
           <p:cNvSpPr txBox="1"/>
           <p:nvPr/>
         </p:nvSpPr>
         <p:spPr>
           <a:xfrm>
-            <a:off x="274320" y="4453127"/>
+            <a:off x="274320" y="3959351"/>
             <a:ext cx="7013448" cy="164592"/>
           </a:xfrm>
           <a:prstGeom prst="rect">
@@ -4207,14 +3856,14 @@
       </p:sp>
       <p:sp>
         <p:nvSpPr>
-          <p:cNvPr id="26" name="Panel 4 card"/>
+          <p:cNvPr id="20" name="Panel 4 card"/>
           <p:cNvSpPr/>
           <p:nvPr/>
         </p:nvSpPr>
         <p:spPr>
           <a:xfrm>
-            <a:off x="274320" y="4645151"/>
-            <a:ext cx="2252472" cy="2194560"/>
+            <a:off x="274320" y="4151375"/>
+            <a:ext cx="2252472" cy="2423160"/>
           </a:xfrm>
           <a:prstGeom prst="roundRect">
             <a:avLst>
@@ -4253,13 +3902,13 @@
       </p:sp>
       <p:sp>
         <p:nvSpPr>
-          <p:cNvPr id="27" name="Panel 4 number"/>
+          <p:cNvPr id="21" name="Panel 4 number"/>
           <p:cNvSpPr/>
           <p:nvPr/>
         </p:nvSpPr>
         <p:spPr>
           <a:xfrm>
-            <a:off x="347472" y="4736591"/>
+            <a:off x="347472" y="4242815"/>
             <a:ext cx="201168" cy="201168"/>
           </a:xfrm>
           <a:prstGeom prst="ellipse">
@@ -4306,13 +3955,13 @@
       </p:sp>
       <p:sp>
         <p:nvSpPr>
-          <p:cNvPr id="28" name="Panel 4 takeaway"/>
+          <p:cNvPr id="22" name="Panel 4 takeaway"/>
           <p:cNvSpPr txBox="1"/>
           <p:nvPr/>
         </p:nvSpPr>
         <p:spPr>
           <a:xfrm>
-            <a:off x="612647" y="4690871"/>
+            <a:off x="612647" y="4197095"/>
             <a:ext cx="1840991" cy="310896"/>
           </a:xfrm>
           <a:prstGeom prst="rect">
@@ -4348,7 +3997,7 @@
       </p:sp>
       <p:pic>
         <p:nvPicPr>
-          <p:cNvPr id="29" name="Panel 4 figure" descr="04_coefficients.png"/>
+          <p:cNvPr id="23" name="Panel 4 figure" descr="04_coefficients.png"/>
           <p:cNvPicPr>
             <a:picLocks noChangeAspect="1"/>
           </p:cNvPicPr>
@@ -4362,8 +4011,8 @@
         </p:blipFill>
         <p:spPr>
           <a:xfrm>
-            <a:off x="321564" y="5020055"/>
-            <a:ext cx="2157984" cy="1783080"/>
+            <a:off x="321564" y="4526279"/>
+            <a:ext cx="2157984" cy="2011680"/>
           </a:xfrm>
           <a:prstGeom prst="rect">
             <a:avLst/>
@@ -4372,14 +4021,14 @@
       </p:pic>
       <p:sp>
         <p:nvSpPr>
-          <p:cNvPr id="30" name="Panel 5 card"/>
+          <p:cNvPr id="24" name="Panel 5 card"/>
           <p:cNvSpPr/>
           <p:nvPr/>
         </p:nvSpPr>
         <p:spPr>
           <a:xfrm>
-            <a:off x="2654808" y="4645151"/>
-            <a:ext cx="2252472" cy="2194560"/>
+            <a:off x="2654808" y="4151375"/>
+            <a:ext cx="2252472" cy="2423160"/>
           </a:xfrm>
           <a:prstGeom prst="roundRect">
             <a:avLst>
@@ -4418,13 +4067,13 @@
       </p:sp>
       <p:sp>
         <p:nvSpPr>
-          <p:cNvPr id="31" name="Panel 5 number"/>
+          <p:cNvPr id="25" name="Panel 5 number"/>
           <p:cNvSpPr/>
           <p:nvPr/>
         </p:nvSpPr>
         <p:spPr>
           <a:xfrm>
-            <a:off x="2727960" y="4736591"/>
+            <a:off x="2727960" y="4242815"/>
             <a:ext cx="201168" cy="201168"/>
           </a:xfrm>
           <a:prstGeom prst="ellipse">
@@ -4471,13 +4120,13 @@
       </p:sp>
       <p:sp>
         <p:nvSpPr>
-          <p:cNvPr id="32" name="Panel 5 takeaway"/>
+          <p:cNvPr id="26" name="Panel 5 takeaway"/>
           <p:cNvSpPr txBox="1"/>
           <p:nvPr/>
         </p:nvSpPr>
         <p:spPr>
           <a:xfrm>
-            <a:off x="2993136" y="4690871"/>
+            <a:off x="2993136" y="4197095"/>
             <a:ext cx="1840991" cy="310896"/>
           </a:xfrm>
           <a:prstGeom prst="rect">
@@ -4513,7 +4162,7 @@
       </p:sp>
       <p:pic>
         <p:nvPicPr>
-          <p:cNvPr id="33" name="Panel 5 figure" descr="05_scatter_isoprice.png"/>
+          <p:cNvPr id="27" name="Panel 5 figure" descr="05_scatter_isoprice.png"/>
           <p:cNvPicPr>
             <a:picLocks noChangeAspect="1"/>
           </p:cNvPicPr>
@@ -4527,8 +4176,8 @@
         </p:blipFill>
         <p:spPr>
           <a:xfrm>
-            <a:off x="2702052" y="5020055"/>
-            <a:ext cx="2157984" cy="1783080"/>
+            <a:off x="2702052" y="4526279"/>
+            <a:ext cx="2157984" cy="2011680"/>
           </a:xfrm>
           <a:prstGeom prst="rect">
             <a:avLst/>
@@ -4537,14 +4186,14 @@
       </p:pic>
       <p:sp>
         <p:nvSpPr>
-          <p:cNvPr id="34" name="Panel 6 card"/>
+          <p:cNvPr id="28" name="Panel 6 card"/>
           <p:cNvSpPr/>
           <p:nvPr/>
         </p:nvSpPr>
         <p:spPr>
           <a:xfrm>
-            <a:off x="5035296" y="4645151"/>
-            <a:ext cx="2252472" cy="2194560"/>
+            <a:off x="5035296" y="4151375"/>
+            <a:ext cx="2252472" cy="2423160"/>
           </a:xfrm>
           <a:prstGeom prst="roundRect">
             <a:avLst>
@@ -4583,13 +4232,13 @@
       </p:sp>
       <p:sp>
         <p:nvSpPr>
-          <p:cNvPr id="35" name="Panel 6 number"/>
+          <p:cNvPr id="29" name="Panel 6 number"/>
           <p:cNvSpPr/>
           <p:nvPr/>
         </p:nvSpPr>
         <p:spPr>
           <a:xfrm>
-            <a:off x="5108448" y="4736591"/>
+            <a:off x="5108448" y="4242815"/>
             <a:ext cx="201168" cy="201168"/>
           </a:xfrm>
           <a:prstGeom prst="ellipse">
@@ -4636,13 +4285,13 @@
       </p:sp>
       <p:sp>
         <p:nvSpPr>
-          <p:cNvPr id="36" name="Panel 6 takeaway"/>
+          <p:cNvPr id="30" name="Panel 6 takeaway"/>
           <p:cNvSpPr txBox="1"/>
           <p:nvPr/>
         </p:nvSpPr>
         <p:spPr>
           <a:xfrm>
-            <a:off x="5373624" y="4690871"/>
+            <a:off x="5373624" y="4197095"/>
             <a:ext cx="1840991" cy="310896"/>
           </a:xfrm>
           <a:prstGeom prst="rect">
@@ -4678,7 +4327,7 @@
       </p:sp>
       <p:pic>
         <p:nvPicPr>
-          <p:cNvPr id="37" name="Panel 6 figure" descr="06_violin_pricing.png"/>
+          <p:cNvPr id="31" name="Panel 6 figure" descr="06_violin_pricing.png"/>
           <p:cNvPicPr>
             <a:picLocks noChangeAspect="1"/>
           </p:cNvPicPr>
@@ -4692,8 +4341,8 @@
         </p:blipFill>
         <p:spPr>
           <a:xfrm>
-            <a:off x="5082540" y="5020055"/>
-            <a:ext cx="2157984" cy="1783080"/>
+            <a:off x="5082540" y="4526279"/>
+            <a:ext cx="2157984" cy="2011680"/>
           </a:xfrm>
           <a:prstGeom prst="rect">
             <a:avLst/>
@@ -4702,13 +4351,13 @@
       </p:pic>
       <p:sp>
         <p:nvSpPr>
-          <p:cNvPr id="38" name="Row 3 label"/>
+          <p:cNvPr id="32" name="Row 3 label"/>
           <p:cNvSpPr txBox="1"/>
           <p:nvPr/>
         </p:nvSpPr>
         <p:spPr>
           <a:xfrm>
-            <a:off x="274320" y="6894575"/>
+            <a:off x="274320" y="6629399"/>
             <a:ext cx="7013448" cy="164592"/>
           </a:xfrm>
           <a:prstGeom prst="rect">
@@ -4744,14 +4393,14 @@
       </p:sp>
       <p:sp>
         <p:nvSpPr>
-          <p:cNvPr id="39" name="Panel 7 card"/>
+          <p:cNvPr id="33" name="Panel 7 card"/>
           <p:cNvSpPr/>
           <p:nvPr/>
         </p:nvSpPr>
         <p:spPr>
           <a:xfrm>
-            <a:off x="274320" y="7086599"/>
-            <a:ext cx="2252472" cy="2194560"/>
+            <a:off x="274320" y="6821423"/>
+            <a:ext cx="2252472" cy="2423160"/>
           </a:xfrm>
           <a:prstGeom prst="roundRect">
             <a:avLst>
@@ -4790,13 +4439,13 @@
       </p:sp>
       <p:sp>
         <p:nvSpPr>
-          <p:cNvPr id="40" name="Panel 7 number"/>
+          <p:cNvPr id="34" name="Panel 7 number"/>
           <p:cNvSpPr/>
           <p:nvPr/>
         </p:nvSpPr>
         <p:spPr>
           <a:xfrm>
-            <a:off x="347472" y="7178039"/>
+            <a:off x="347472" y="6912863"/>
             <a:ext cx="201168" cy="201168"/>
           </a:xfrm>
           <a:prstGeom prst="ellipse">
@@ -4843,13 +4492,13 @@
       </p:sp>
       <p:sp>
         <p:nvSpPr>
-          <p:cNvPr id="41" name="Panel 7 takeaway"/>
+          <p:cNvPr id="35" name="Panel 7 takeaway"/>
           <p:cNvSpPr txBox="1"/>
           <p:nvPr/>
         </p:nvSpPr>
         <p:spPr>
           <a:xfrm>
-            <a:off x="612647" y="7132319"/>
+            <a:off x="612647" y="6867143"/>
             <a:ext cx="1840991" cy="310896"/>
           </a:xfrm>
           <a:prstGeom prst="rect">
@@ -4885,7 +4534,7 @@
       </p:sp>
       <p:pic>
         <p:nvPicPr>
-          <p:cNvPr id="42" name="Panel 7 figure" descr="07_lollipop_macro.png"/>
+          <p:cNvPr id="36" name="Panel 7 figure" descr="07_lollipop_macro.png"/>
           <p:cNvPicPr>
             <a:picLocks noChangeAspect="1"/>
           </p:cNvPicPr>
@@ -4899,8 +4548,8 @@
         </p:blipFill>
         <p:spPr>
           <a:xfrm>
-            <a:off x="321564" y="7461503"/>
-            <a:ext cx="2157984" cy="1783080"/>
+            <a:off x="321564" y="7196327"/>
+            <a:ext cx="2157984" cy="2011680"/>
           </a:xfrm>
           <a:prstGeom prst="rect">
             <a:avLst/>
@@ -4909,14 +4558,14 @@
       </p:pic>
       <p:sp>
         <p:nvSpPr>
-          <p:cNvPr id="43" name="Panel 8 card"/>
+          <p:cNvPr id="37" name="Panel 8 card"/>
           <p:cNvSpPr/>
           <p:nvPr/>
         </p:nvSpPr>
         <p:spPr>
           <a:xfrm>
-            <a:off x="2654808" y="7086599"/>
-            <a:ext cx="2252472" cy="2194560"/>
+            <a:off x="2654808" y="6821423"/>
+            <a:ext cx="2252472" cy="2423160"/>
           </a:xfrm>
           <a:prstGeom prst="roundRect">
             <a:avLst>
@@ -4955,13 +4604,13 @@
       </p:sp>
       <p:sp>
         <p:nvSpPr>
-          <p:cNvPr id="44" name="Panel 8 number"/>
+          <p:cNvPr id="38" name="Panel 8 number"/>
           <p:cNvSpPr/>
           <p:nvPr/>
         </p:nvSpPr>
         <p:spPr>
           <a:xfrm>
-            <a:off x="2727960" y="7178039"/>
+            <a:off x="2727960" y="6912863"/>
             <a:ext cx="201168" cy="201168"/>
           </a:xfrm>
           <a:prstGeom prst="ellipse">
@@ -5008,13 +4657,13 @@
       </p:sp>
       <p:sp>
         <p:nvSpPr>
-          <p:cNvPr id="45" name="Panel 8 takeaway"/>
+          <p:cNvPr id="39" name="Panel 8 takeaway"/>
           <p:cNvSpPr txBox="1"/>
           <p:nvPr/>
         </p:nvSpPr>
         <p:spPr>
           <a:xfrm>
-            <a:off x="2993136" y="7132319"/>
+            <a:off x="2993136" y="6867143"/>
             <a:ext cx="1840991" cy="310896"/>
           </a:xfrm>
           <a:prstGeom prst="rect">
@@ -5050,7 +4699,7 @@
       </p:sp>
       <p:pic>
         <p:nvPicPr>
-          <p:cNvPr id="46" name="Panel 8 figure" descr="08_heatmap_tdsr.png"/>
+          <p:cNvPr id="40" name="Panel 8 figure" descr="08_heatmap_tdsr.png"/>
           <p:cNvPicPr>
             <a:picLocks noChangeAspect="1"/>
           </p:cNvPicPr>
@@ -5064,8 +4713,8 @@
         </p:blipFill>
         <p:spPr>
           <a:xfrm>
-            <a:off x="2702052" y="7461503"/>
-            <a:ext cx="2157984" cy="1783080"/>
+            <a:off x="2702052" y="7196327"/>
+            <a:ext cx="2157984" cy="2011680"/>
           </a:xfrm>
           <a:prstGeom prst="rect">
             <a:avLst/>
@@ -5074,14 +4723,14 @@
       </p:pic>
       <p:sp>
         <p:nvSpPr>
-          <p:cNvPr id="47" name="Panel 9 card"/>
+          <p:cNvPr id="41" name="Panel 9 card"/>
           <p:cNvSpPr/>
           <p:nvPr/>
         </p:nvSpPr>
         <p:spPr>
           <a:xfrm>
-            <a:off x="5035296" y="7086599"/>
-            <a:ext cx="2252472" cy="2194560"/>
+            <a:off x="5035296" y="6821423"/>
+            <a:ext cx="2252472" cy="2423160"/>
           </a:xfrm>
           <a:prstGeom prst="roundRect">
             <a:avLst>
@@ -5120,13 +4769,13 @@
       </p:sp>
       <p:sp>
         <p:nvSpPr>
-          <p:cNvPr id="48" name="Panel 9 number"/>
+          <p:cNvPr id="42" name="Panel 9 number"/>
           <p:cNvSpPr/>
           <p:nvPr/>
         </p:nvSpPr>
         <p:spPr>
           <a:xfrm>
-            <a:off x="5108448" y="7178039"/>
+            <a:off x="5108448" y="6912863"/>
             <a:ext cx="201168" cy="201168"/>
           </a:xfrm>
           <a:prstGeom prst="ellipse">
@@ -5173,13 +4822,13 @@
       </p:sp>
       <p:sp>
         <p:nvSpPr>
-          <p:cNvPr id="49" name="Panel 9 takeaway"/>
+          <p:cNvPr id="43" name="Panel 9 takeaway"/>
           <p:cNvSpPr txBox="1"/>
           <p:nvPr/>
         </p:nvSpPr>
         <p:spPr>
           <a:xfrm>
-            <a:off x="5373624" y="7132319"/>
+            <a:off x="5373624" y="6867143"/>
             <a:ext cx="1840991" cy="310896"/>
           </a:xfrm>
           <a:prstGeom prst="rect">
@@ -5215,7 +4864,7 @@
       </p:sp>
       <p:pic>
         <p:nvPicPr>
-          <p:cNvPr id="50" name="Panel 9 figure" descr="09_waterfall.png"/>
+          <p:cNvPr id="44" name="Panel 9 figure" descr="09_waterfall.png"/>
           <p:cNvPicPr>
             <a:picLocks noChangeAspect="1"/>
           </p:cNvPicPr>
@@ -5229,8 +4878,8 @@
         </p:blipFill>
         <p:spPr>
           <a:xfrm>
-            <a:off x="5082540" y="7461503"/>
-            <a:ext cx="2157984" cy="1783080"/>
+            <a:off x="5082540" y="7196327"/>
+            <a:ext cx="2157984" cy="2011680"/>
           </a:xfrm>
           <a:prstGeom prst="rect">
             <a:avLst/>
@@ -5239,13 +4888,13 @@
       </p:pic>
       <p:sp>
         <p:nvSpPr>
-          <p:cNvPr id="51" name="Answer card"/>
+          <p:cNvPr id="45" name="Answer card"/>
           <p:cNvSpPr/>
           <p:nvPr/>
         </p:nvSpPr>
         <p:spPr>
           <a:xfrm>
-            <a:off x="274320" y="9363455"/>
+            <a:off x="274320" y="9326880"/>
             <a:ext cx="7013448" cy="896112"/>
           </a:xfrm>
           <a:prstGeom prst="roundRect">
@@ -5285,13 +4934,13 @@
       </p:sp>
       <p:sp>
         <p:nvSpPr>
-          <p:cNvPr id="52" name="Answer line"/>
+          <p:cNvPr id="46" name="Answer line"/>
           <p:cNvSpPr txBox="1"/>
           <p:nvPr/>
         </p:nvSpPr>
         <p:spPr>
           <a:xfrm>
-            <a:off x="420623" y="9436607"/>
+            <a:off x="420623" y="9400032"/>
             <a:ext cx="6720840" cy="310896"/>
           </a:xfrm>
           <a:prstGeom prst="rect">
@@ -5336,13 +4985,13 @@
       </p:sp>
       <p:sp>
         <p:nvSpPr>
-          <p:cNvPr id="53" name="Finding 1 number"/>
+          <p:cNvPr id="47" name="Finding 1 number"/>
           <p:cNvSpPr/>
           <p:nvPr/>
         </p:nvSpPr>
         <p:spPr>
           <a:xfrm>
-            <a:off x="420623" y="9848087"/>
+            <a:off x="420623" y="9811511"/>
             <a:ext cx="182880" cy="182880"/>
           </a:xfrm>
           <a:prstGeom prst="ellipse">
@@ -5389,13 +5038,13 @@
       </p:sp>
       <p:sp>
         <p:nvSpPr>
-          <p:cNvPr id="54" name="Finding 1"/>
+          <p:cNvPr id="48" name="Finding 1"/>
           <p:cNvSpPr txBox="1"/>
           <p:nvPr/>
         </p:nvSpPr>
         <p:spPr>
           <a:xfrm>
-            <a:off x="676656" y="9820655"/>
+            <a:off x="676656" y="9784080"/>
             <a:ext cx="1862327" cy="402336"/>
           </a:xfrm>
           <a:prstGeom prst="rect">
@@ -5431,13 +5080,13 @@
       </p:sp>
       <p:sp>
         <p:nvSpPr>
-          <p:cNvPr id="55" name="Finding 2 number"/>
+          <p:cNvPr id="49" name="Finding 2 number"/>
           <p:cNvSpPr/>
           <p:nvPr/>
         </p:nvSpPr>
         <p:spPr>
           <a:xfrm>
-            <a:off x="2721864" y="9848087"/>
+            <a:off x="2721864" y="9811511"/>
             <a:ext cx="182880" cy="182880"/>
           </a:xfrm>
           <a:prstGeom prst="ellipse">
@@ -5484,13 +5133,13 @@
       </p:sp>
       <p:sp>
         <p:nvSpPr>
-          <p:cNvPr id="56" name="Finding 2"/>
+          <p:cNvPr id="50" name="Finding 2"/>
           <p:cNvSpPr txBox="1"/>
           <p:nvPr/>
         </p:nvSpPr>
         <p:spPr>
           <a:xfrm>
-            <a:off x="2977896" y="9820655"/>
+            <a:off x="2977896" y="9784080"/>
             <a:ext cx="1862327" cy="402336"/>
           </a:xfrm>
           <a:prstGeom prst="rect">
@@ -5526,13 +5175,13 @@
       </p:sp>
       <p:sp>
         <p:nvSpPr>
-          <p:cNvPr id="57" name="Finding 3 number"/>
+          <p:cNvPr id="51" name="Finding 3 number"/>
           <p:cNvSpPr/>
           <p:nvPr/>
         </p:nvSpPr>
         <p:spPr>
           <a:xfrm>
-            <a:off x="5023104" y="9848087"/>
+            <a:off x="5023104" y="9811511"/>
             <a:ext cx="182880" cy="182880"/>
           </a:xfrm>
           <a:prstGeom prst="ellipse">
@@ -5579,13 +5228,13 @@
       </p:sp>
       <p:sp>
         <p:nvSpPr>
-          <p:cNvPr id="58" name="Finding 3"/>
+          <p:cNvPr id="52" name="Finding 3"/>
           <p:cNvSpPr txBox="1"/>
           <p:nvPr/>
         </p:nvSpPr>
         <p:spPr>
           <a:xfrm>
-            <a:off x="5279136" y="9820655"/>
+            <a:off x="5279136" y="9784080"/>
             <a:ext cx="1862327" cy="402336"/>
           </a:xfrm>
           <a:prstGeom prst="rect">
@@ -5621,14 +5270,14 @@
       </p:sp>
       <p:sp>
         <p:nvSpPr>
-          <p:cNvPr id="59" name="Footnote"/>
+          <p:cNvPr id="53" name="Footnote"/>
           <p:cNvSpPr txBox="1"/>
           <p:nvPr/>
         </p:nvSpPr>
         <p:spPr>
           <a:xfrm>
-            <a:off x="274320" y="10314432"/>
-            <a:ext cx="7013448" cy="265176"/>
+            <a:off x="274320" y="10277856"/>
+            <a:ext cx="7013448" cy="301751"/>
           </a:xfrm>
           <a:prstGeom prst="rect">
             <a:avLst/>

</xml_diff>

<commit_message>
Make the interpretation version the only poster; Jialin replaces Linda
Each chart keeps its takeaway line above and a short comment below. The
version without comments, the --insights flag and the insights files are
removed; figs_insight/ is now figs_poster/. Zip and guide rebuilt to match.

Co-Authored-By: Claude Opus 5.5 <noreply@anthropic.com>
</commit_message>
<xml_diff>
--- a/shrinkflation_poster.pptx
+++ b/shrinkflation_poster.pptx
@@ -3167,7 +3167,7 @@
                 </a:solidFill>
                 <a:latin typeface="Arial"/>
               </a:rPr>
-              <a:t>DAO2702 Group Assignment  ·  Team Jupyter  ·  Martin, Huaitao, Manan, Linda, Midhvan, Hoyoung</a:t>
+              <a:t>DAO2702 Group Assignment  ·  Team Jupyter  ·  Martin, Huaitao, Manan, Jialin, Midhvan, Hoyoung</a:t>
             </a:r>
           </a:p>
         </p:txBody>
@@ -3326,7 +3326,7 @@
         <p:spPr>
           <a:xfrm>
             <a:off x="274320" y="1481328"/>
-            <a:ext cx="2252472" cy="2423160"/>
+            <a:ext cx="2252472" cy="2414016"/>
           </a:xfrm>
           <a:prstGeom prst="roundRect">
             <a:avLst>
@@ -3475,7 +3475,7 @@
         <p:spPr>
           <a:xfrm>
             <a:off x="321564" y="1856232"/>
-            <a:ext cx="2157984" cy="2011680"/>
+            <a:ext cx="2157984" cy="1554480"/>
           </a:xfrm>
           <a:prstGeom prst="rect">
             <a:avLst/>
@@ -3484,113 +3484,14 @@
       </p:pic>
       <p:sp>
         <p:nvSpPr>
-          <p:cNvPr id="11" name="Panel 2 card"/>
-          <p:cNvSpPr/>
-          <p:nvPr/>
-        </p:nvSpPr>
-        <p:spPr>
-          <a:xfrm>
-            <a:off x="2654808" y="1481328"/>
-            <a:ext cx="2252472" cy="2423160"/>
-          </a:xfrm>
-          <a:prstGeom prst="roundRect">
-            <a:avLst>
-              <a:gd name="adj" fmla="val 4000"/>
-            </a:avLst>
-          </a:prstGeom>
-          <a:solidFill>
-            <a:srgbClr val="F4F5F7"/>
-          </a:solidFill>
-          <a:ln>
-            <a:noFill/>
-          </a:ln>
-          <a:effectLst/>
-        </p:spPr>
-        <p:style>
-          <a:lnRef idx="1">
-            <a:schemeClr val="accent1"/>
-          </a:lnRef>
-          <a:fillRef idx="3">
-            <a:schemeClr val="accent1"/>
-          </a:fillRef>
-          <a:effectRef idx="2">
-            <a:schemeClr val="accent1"/>
-          </a:effectRef>
-          <a:fontRef idx="minor">
-            <a:schemeClr val="lt1"/>
-          </a:fontRef>
-        </p:style>
-        <p:txBody>
-          <a:bodyPr rtlCol="0" anchor="ctr"/>
-          <a:lstStyle/>
-          <a:p>
-            <a:pPr algn="ctr"/>
-          </a:p>
-        </p:txBody>
-      </p:sp>
-      <p:sp>
-        <p:nvSpPr>
-          <p:cNvPr id="12" name="Panel 2 number"/>
-          <p:cNvSpPr/>
-          <p:nvPr/>
-        </p:nvSpPr>
-        <p:spPr>
-          <a:xfrm>
-            <a:off x="2727960" y="1572768"/>
-            <a:ext cx="201168" cy="201168"/>
-          </a:xfrm>
-          <a:prstGeom prst="ellipse">
-            <a:avLst/>
-          </a:prstGeom>
-          <a:solidFill>
-            <a:srgbClr val="0D366B"/>
-          </a:solidFill>
-          <a:ln>
-            <a:noFill/>
-          </a:ln>
-          <a:effectLst/>
-        </p:spPr>
-        <p:style>
-          <a:lnRef idx="1">
-            <a:schemeClr val="accent1"/>
-          </a:lnRef>
-          <a:fillRef idx="3">
-            <a:schemeClr val="accent1"/>
-          </a:fillRef>
-          <a:effectRef idx="2">
-            <a:schemeClr val="accent1"/>
-          </a:effectRef>
-          <a:fontRef idx="minor">
-            <a:schemeClr val="lt1"/>
-          </a:fontRef>
-        </p:style>
-        <p:txBody>
-          <a:bodyPr rtlCol="0" anchor="ctr" lIns="0" rIns="0" tIns="0" bIns="0"/>
-          <a:lstStyle/>
-          <a:p>
-            <a:pPr algn="ctr"/>
-            <a:r>
-              <a:rPr sz="750" b="1">
-                <a:solidFill>
-                  <a:srgbClr val="FFFFFF"/>
-                </a:solidFill>
-                <a:latin typeface="Arial"/>
-              </a:rPr>
-              <a:t>2</a:t>
-            </a:r>
-          </a:p>
-        </p:txBody>
-      </p:sp>
-      <p:sp>
-        <p:nvSpPr>
-          <p:cNvPr id="13" name="Panel 2 takeaway"/>
+          <p:cNvPr id="11" name="Panel 1 insight"/>
           <p:cNvSpPr txBox="1"/>
           <p:nvPr/>
         </p:nvSpPr>
         <p:spPr>
           <a:xfrm>
-            <a:off x="2993136" y="1527048"/>
-            <a:ext cx="1840991" cy="310896"/>
+            <a:off x="384048" y="3438144"/>
+            <a:ext cx="2033016" cy="429768"/>
           </a:xfrm>
           <a:prstGeom prst="rect">
             <a:avLst/>
@@ -3598,7 +3499,7 @@
           <a:noFill/>
         </p:spPr>
         <p:txBody>
-          <a:bodyPr wrap="square" lIns="0" rIns="0" tIns="0" bIns="0" anchor="ctr">
+          <a:bodyPr wrap="square" lIns="0" rIns="0" tIns="0" bIns="0" anchor="t">
             <a:spAutoFit/>
           </a:bodyPr>
           <a:lstStyle/>
@@ -3612,6 +3513,147 @@
               </a:spcAft>
             </a:pPr>
             <a:r>
+              <a:rPr sz="690" b="0">
+                <a:solidFill>
+                  <a:srgbClr val="52514E"/>
+                </a:solidFill>
+                <a:latin typeface="Arial"/>
+              </a:rPr>
+              <a:t>New launches crowd into 500–900 sq ft. A buyer who wants a family-sized home now mostly has to look at resale.</a:t>
+            </a:r>
+          </a:p>
+        </p:txBody>
+      </p:sp>
+      <p:sp>
+        <p:nvSpPr>
+          <p:cNvPr id="12" name="Panel 2 card"/>
+          <p:cNvSpPr/>
+          <p:nvPr/>
+        </p:nvSpPr>
+        <p:spPr>
+          <a:xfrm>
+            <a:off x="2654808" y="1481328"/>
+            <a:ext cx="2252472" cy="2414016"/>
+          </a:xfrm>
+          <a:prstGeom prst="roundRect">
+            <a:avLst>
+              <a:gd name="adj" fmla="val 4000"/>
+            </a:avLst>
+          </a:prstGeom>
+          <a:solidFill>
+            <a:srgbClr val="F4F5F7"/>
+          </a:solidFill>
+          <a:ln>
+            <a:noFill/>
+          </a:ln>
+          <a:effectLst/>
+        </p:spPr>
+        <p:style>
+          <a:lnRef idx="1">
+            <a:schemeClr val="accent1"/>
+          </a:lnRef>
+          <a:fillRef idx="3">
+            <a:schemeClr val="accent1"/>
+          </a:fillRef>
+          <a:effectRef idx="2">
+            <a:schemeClr val="accent1"/>
+          </a:effectRef>
+          <a:fontRef idx="minor">
+            <a:schemeClr val="lt1"/>
+          </a:fontRef>
+        </p:style>
+        <p:txBody>
+          <a:bodyPr rtlCol="0" anchor="ctr"/>
+          <a:lstStyle/>
+          <a:p>
+            <a:pPr algn="ctr"/>
+          </a:p>
+        </p:txBody>
+      </p:sp>
+      <p:sp>
+        <p:nvSpPr>
+          <p:cNvPr id="13" name="Panel 2 number"/>
+          <p:cNvSpPr/>
+          <p:nvPr/>
+        </p:nvSpPr>
+        <p:spPr>
+          <a:xfrm>
+            <a:off x="2727960" y="1572768"/>
+            <a:ext cx="201168" cy="201168"/>
+          </a:xfrm>
+          <a:prstGeom prst="ellipse">
+            <a:avLst/>
+          </a:prstGeom>
+          <a:solidFill>
+            <a:srgbClr val="0D366B"/>
+          </a:solidFill>
+          <a:ln>
+            <a:noFill/>
+          </a:ln>
+          <a:effectLst/>
+        </p:spPr>
+        <p:style>
+          <a:lnRef idx="1">
+            <a:schemeClr val="accent1"/>
+          </a:lnRef>
+          <a:fillRef idx="3">
+            <a:schemeClr val="accent1"/>
+          </a:fillRef>
+          <a:effectRef idx="2">
+            <a:schemeClr val="accent1"/>
+          </a:effectRef>
+          <a:fontRef idx="minor">
+            <a:schemeClr val="lt1"/>
+          </a:fontRef>
+        </p:style>
+        <p:txBody>
+          <a:bodyPr rtlCol="0" anchor="ctr" lIns="0" rIns="0" tIns="0" bIns="0"/>
+          <a:lstStyle/>
+          <a:p>
+            <a:pPr algn="ctr"/>
+            <a:r>
+              <a:rPr sz="750" b="1">
+                <a:solidFill>
+                  <a:srgbClr val="FFFFFF"/>
+                </a:solidFill>
+                <a:latin typeface="Arial"/>
+              </a:rPr>
+              <a:t>2</a:t>
+            </a:r>
+          </a:p>
+        </p:txBody>
+      </p:sp>
+      <p:sp>
+        <p:nvSpPr>
+          <p:cNvPr id="14" name="Panel 2 takeaway"/>
+          <p:cNvSpPr txBox="1"/>
+          <p:nvPr/>
+        </p:nvSpPr>
+        <p:spPr>
+          <a:xfrm>
+            <a:off x="2993136" y="1527048"/>
+            <a:ext cx="1840991" cy="310896"/>
+          </a:xfrm>
+          <a:prstGeom prst="rect">
+            <a:avLst/>
+          </a:prstGeom>
+          <a:noFill/>
+        </p:spPr>
+        <p:txBody>
+          <a:bodyPr wrap="square" lIns="0" rIns="0" tIns="0" bIns="0" anchor="ctr">
+            <a:spAutoFit/>
+          </a:bodyPr>
+          <a:lstStyle/>
+          <a:p>
+            <a:pPr>
+              <a:lnSpc>
+                <a:spcPct val="105000"/>
+              </a:lnSpc>
+              <a:spcAft>
+                <a:spcPts val="0"/>
+              </a:spcAft>
+            </a:pPr>
+            <a:r>
               <a:rPr sz="780" b="1">
                 <a:solidFill>
                   <a:srgbClr val="0B0B0B"/>
@@ -3625,7 +3667,7 @@
       </p:sp>
       <p:pic>
         <p:nvPicPr>
-          <p:cNvPr id="14" name="Panel 2 figure" descr="02_line_vintage.png"/>
+          <p:cNvPr id="15" name="Panel 2 figure" descr="02_line_vintage.png"/>
           <p:cNvPicPr>
             <a:picLocks noChangeAspect="1"/>
           </p:cNvPicPr>
@@ -3640,7 +3682,7 @@
         <p:spPr>
           <a:xfrm>
             <a:off x="2702052" y="1856232"/>
-            <a:ext cx="2157984" cy="2011680"/>
+            <a:ext cx="2157984" cy="1554480"/>
           </a:xfrm>
           <a:prstGeom prst="rect">
             <a:avLst/>
@@ -3649,113 +3691,14 @@
       </p:pic>
       <p:sp>
         <p:nvSpPr>
-          <p:cNvPr id="15" name="Panel 3 card"/>
-          <p:cNvSpPr/>
-          <p:nvPr/>
-        </p:nvSpPr>
-        <p:spPr>
-          <a:xfrm>
-            <a:off x="5035296" y="1481328"/>
-            <a:ext cx="2252472" cy="2423160"/>
-          </a:xfrm>
-          <a:prstGeom prst="roundRect">
-            <a:avLst>
-              <a:gd name="adj" fmla="val 4000"/>
-            </a:avLst>
-          </a:prstGeom>
-          <a:solidFill>
-            <a:srgbClr val="F4F5F7"/>
-          </a:solidFill>
-          <a:ln>
-            <a:noFill/>
-          </a:ln>
-          <a:effectLst/>
-        </p:spPr>
-        <p:style>
-          <a:lnRef idx="1">
-            <a:schemeClr val="accent1"/>
-          </a:lnRef>
-          <a:fillRef idx="3">
-            <a:schemeClr val="accent1"/>
-          </a:fillRef>
-          <a:effectRef idx="2">
-            <a:schemeClr val="accent1"/>
-          </a:effectRef>
-          <a:fontRef idx="minor">
-            <a:schemeClr val="lt1"/>
-          </a:fontRef>
-        </p:style>
-        <p:txBody>
-          <a:bodyPr rtlCol="0" anchor="ctr"/>
-          <a:lstStyle/>
-          <a:p>
-            <a:pPr algn="ctr"/>
-          </a:p>
-        </p:txBody>
-      </p:sp>
-      <p:sp>
-        <p:nvSpPr>
-          <p:cNvPr id="16" name="Panel 3 number"/>
-          <p:cNvSpPr/>
-          <p:nvPr/>
-        </p:nvSpPr>
-        <p:spPr>
-          <a:xfrm>
-            <a:off x="5108448" y="1572768"/>
-            <a:ext cx="201168" cy="201168"/>
-          </a:xfrm>
-          <a:prstGeom prst="ellipse">
-            <a:avLst/>
-          </a:prstGeom>
-          <a:solidFill>
-            <a:srgbClr val="0D366B"/>
-          </a:solidFill>
-          <a:ln>
-            <a:noFill/>
-          </a:ln>
-          <a:effectLst/>
-        </p:spPr>
-        <p:style>
-          <a:lnRef idx="1">
-            <a:schemeClr val="accent1"/>
-          </a:lnRef>
-          <a:fillRef idx="3">
-            <a:schemeClr val="accent1"/>
-          </a:fillRef>
-          <a:effectRef idx="2">
-            <a:schemeClr val="accent1"/>
-          </a:effectRef>
-          <a:fontRef idx="minor">
-            <a:schemeClr val="lt1"/>
-          </a:fontRef>
-        </p:style>
-        <p:txBody>
-          <a:bodyPr rtlCol="0" anchor="ctr" lIns="0" rIns="0" tIns="0" bIns="0"/>
-          <a:lstStyle/>
-          <a:p>
-            <a:pPr algn="ctr"/>
-            <a:r>
-              <a:rPr sz="750" b="1">
-                <a:solidFill>
-                  <a:srgbClr val="FFFFFF"/>
-                </a:solidFill>
-                <a:latin typeface="Arial"/>
-              </a:rPr>
-              <a:t>3</a:t>
-            </a:r>
-          </a:p>
-        </p:txBody>
-      </p:sp>
-      <p:sp>
-        <p:nvSpPr>
-          <p:cNvPr id="17" name="Panel 3 takeaway"/>
+          <p:cNvPr id="16" name="Panel 2 insight"/>
           <p:cNvSpPr txBox="1"/>
           <p:nvPr/>
         </p:nvSpPr>
         <p:spPr>
           <a:xfrm>
-            <a:off x="5373624" y="1527048"/>
-            <a:ext cx="1840991" cy="310896"/>
+            <a:off x="2764536" y="3438144"/>
+            <a:ext cx="2033016" cy="429768"/>
           </a:xfrm>
           <a:prstGeom prst="rect">
             <a:avLst/>
@@ -3763,7 +3706,7 @@
           <a:noFill/>
         </p:spPr>
         <p:txBody>
-          <a:bodyPr wrap="square" lIns="0" rIns="0" tIns="0" bIns="0" anchor="ctr">
+          <a:bodyPr wrap="square" lIns="0" rIns="0" tIns="0" bIns="0" anchor="t">
             <a:spAutoFit/>
           </a:bodyPr>
           <a:lstStyle/>
@@ -3777,6 +3720,147 @@
               </a:spcAft>
             </a:pPr>
             <a:r>
+              <a:rPr sz="690" b="0">
+                <a:solidFill>
+                  <a:srgbClr val="52514E"/>
+                </a:solidFill>
+                <a:latin typeface="Arial"/>
+              </a:rPr>
+              <a:t>A 43% drop in five years is too fast for slowly changing tastes. It lines up with the least affordable years (chart 7) and stops at URA's line.</a:t>
+            </a:r>
+          </a:p>
+        </p:txBody>
+      </p:sp>
+      <p:sp>
+        <p:nvSpPr>
+          <p:cNvPr id="17" name="Panel 3 card"/>
+          <p:cNvSpPr/>
+          <p:nvPr/>
+        </p:nvSpPr>
+        <p:spPr>
+          <a:xfrm>
+            <a:off x="5035296" y="1481328"/>
+            <a:ext cx="2252472" cy="2414016"/>
+          </a:xfrm>
+          <a:prstGeom prst="roundRect">
+            <a:avLst>
+              <a:gd name="adj" fmla="val 4000"/>
+            </a:avLst>
+          </a:prstGeom>
+          <a:solidFill>
+            <a:srgbClr val="F4F5F7"/>
+          </a:solidFill>
+          <a:ln>
+            <a:noFill/>
+          </a:ln>
+          <a:effectLst/>
+        </p:spPr>
+        <p:style>
+          <a:lnRef idx="1">
+            <a:schemeClr val="accent1"/>
+          </a:lnRef>
+          <a:fillRef idx="3">
+            <a:schemeClr val="accent1"/>
+          </a:fillRef>
+          <a:effectRef idx="2">
+            <a:schemeClr val="accent1"/>
+          </a:effectRef>
+          <a:fontRef idx="minor">
+            <a:schemeClr val="lt1"/>
+          </a:fontRef>
+        </p:style>
+        <p:txBody>
+          <a:bodyPr rtlCol="0" anchor="ctr"/>
+          <a:lstStyle/>
+          <a:p>
+            <a:pPr algn="ctr"/>
+          </a:p>
+        </p:txBody>
+      </p:sp>
+      <p:sp>
+        <p:nvSpPr>
+          <p:cNvPr id="18" name="Panel 3 number"/>
+          <p:cNvSpPr/>
+          <p:nvPr/>
+        </p:nvSpPr>
+        <p:spPr>
+          <a:xfrm>
+            <a:off x="5108448" y="1572768"/>
+            <a:ext cx="201168" cy="201168"/>
+          </a:xfrm>
+          <a:prstGeom prst="ellipse">
+            <a:avLst/>
+          </a:prstGeom>
+          <a:solidFill>
+            <a:srgbClr val="0D366B"/>
+          </a:solidFill>
+          <a:ln>
+            <a:noFill/>
+          </a:ln>
+          <a:effectLst/>
+        </p:spPr>
+        <p:style>
+          <a:lnRef idx="1">
+            <a:schemeClr val="accent1"/>
+          </a:lnRef>
+          <a:fillRef idx="3">
+            <a:schemeClr val="accent1"/>
+          </a:fillRef>
+          <a:effectRef idx="2">
+            <a:schemeClr val="accent1"/>
+          </a:effectRef>
+          <a:fontRef idx="minor">
+            <a:schemeClr val="lt1"/>
+          </a:fontRef>
+        </p:style>
+        <p:txBody>
+          <a:bodyPr rtlCol="0" anchor="ctr" lIns="0" rIns="0" tIns="0" bIns="0"/>
+          <a:lstStyle/>
+          <a:p>
+            <a:pPr algn="ctr"/>
+            <a:r>
+              <a:rPr sz="750" b="1">
+                <a:solidFill>
+                  <a:srgbClr val="FFFFFF"/>
+                </a:solidFill>
+                <a:latin typeface="Arial"/>
+              </a:rPr>
+              <a:t>3</a:t>
+            </a:r>
+          </a:p>
+        </p:txBody>
+      </p:sp>
+      <p:sp>
+        <p:nvSpPr>
+          <p:cNvPr id="19" name="Panel 3 takeaway"/>
+          <p:cNvSpPr txBox="1"/>
+          <p:nvPr/>
+        </p:nvSpPr>
+        <p:spPr>
+          <a:xfrm>
+            <a:off x="5373624" y="1527048"/>
+            <a:ext cx="1840991" cy="310896"/>
+          </a:xfrm>
+          <a:prstGeom prst="rect">
+            <a:avLst/>
+          </a:prstGeom>
+          <a:noFill/>
+        </p:spPr>
+        <p:txBody>
+          <a:bodyPr wrap="square" lIns="0" rIns="0" tIns="0" bIns="0" anchor="ctr">
+            <a:spAutoFit/>
+          </a:bodyPr>
+          <a:lstStyle/>
+          <a:p>
+            <a:pPr>
+              <a:lnSpc>
+                <a:spcPct val="105000"/>
+              </a:lnSpc>
+              <a:spcAft>
+                <a:spcPts val="0"/>
+              </a:spcAft>
+            </a:pPr>
+            <a:r>
               <a:rPr sz="780" b="1">
                 <a:solidFill>
                   <a:srgbClr val="0B0B0B"/>
@@ -3790,7 +3874,7 @@
       </p:sp>
       <p:pic>
         <p:nvPicPr>
-          <p:cNvPr id="18" name="Panel 3 figure" descr="03_stacked_mix.png"/>
+          <p:cNvPr id="20" name="Panel 3 figure" descr="03_stacked_mix.png"/>
           <p:cNvPicPr>
             <a:picLocks noChangeAspect="1"/>
           </p:cNvPicPr>
@@ -3805,7 +3889,7 @@
         <p:spPr>
           <a:xfrm>
             <a:off x="5082540" y="1856232"/>
-            <a:ext cx="2157984" cy="2011680"/>
+            <a:ext cx="2157984" cy="1554480"/>
           </a:xfrm>
           <a:prstGeom prst="rect">
             <a:avLst/>
@@ -3814,14 +3898,14 @@
       </p:pic>
       <p:sp>
         <p:nvSpPr>
-          <p:cNvPr id="19" name="Row 2 label"/>
+          <p:cNvPr id="21" name="Panel 3 insight"/>
           <p:cNvSpPr txBox="1"/>
           <p:nvPr/>
         </p:nvSpPr>
         <p:spPr>
           <a:xfrm>
-            <a:off x="274320" y="3959351"/>
-            <a:ext cx="7013448" cy="164592"/>
+            <a:off x="5145024" y="3438144"/>
+            <a:ext cx="2033016" cy="429768"/>
           </a:xfrm>
           <a:prstGeom prst="rect">
             <a:avLst/>
@@ -3829,7 +3913,7 @@
           <a:noFill/>
         </p:spPr>
         <p:txBody>
-          <a:bodyPr wrap="square" lIns="0" rIns="0" tIns="0" bIns="0" anchor="ctr">
+          <a:bodyPr wrap="square" lIns="0" rIns="0" tIns="0" bIns="0" anchor="t">
             <a:spAutoFit/>
           </a:bodyPr>
           <a:lstStyle/>
@@ -3843,126 +3927,27 @@
               </a:spcAft>
             </a:pPr>
             <a:r>
-              <a:rPr sz="700" b="1">
-                <a:solidFill>
-                  <a:srgbClr val="1C5CAB"/>
+              <a:rPr sz="690" b="0">
+                <a:solidFill>
+                  <a:srgbClr val="52514E"/>
                 </a:solidFill>
                 <a:latin typeface="Arial"/>
               </a:rPr>
-              <a:t>2   IS IT REAL, AND HOW DOES IT WORK?</a:t>
-            </a:r>
-          </a:p>
-        </p:txBody>
-      </p:sp>
-      <p:sp>
-        <p:nvSpPr>
-          <p:cNvPr id="20" name="Panel 4 card"/>
-          <p:cNvSpPr/>
-          <p:nvPr/>
-        </p:nvSpPr>
-        <p:spPr>
-          <a:xfrm>
-            <a:off x="274320" y="4151375"/>
-            <a:ext cx="2252472" cy="2423160"/>
-          </a:xfrm>
-          <a:prstGeom prst="roundRect">
-            <a:avLst>
-              <a:gd name="adj" fmla="val 4000"/>
-            </a:avLst>
-          </a:prstGeom>
-          <a:solidFill>
-            <a:srgbClr val="F4F5F7"/>
-          </a:solidFill>
-          <a:ln>
-            <a:noFill/>
-          </a:ln>
-          <a:effectLst/>
-        </p:spPr>
-        <p:style>
-          <a:lnRef idx="1">
-            <a:schemeClr val="accent1"/>
-          </a:lnRef>
-          <a:fillRef idx="3">
-            <a:schemeClr val="accent1"/>
-          </a:fillRef>
-          <a:effectRef idx="2">
-            <a:schemeClr val="accent1"/>
-          </a:effectRef>
-          <a:fontRef idx="minor">
-            <a:schemeClr val="lt1"/>
-          </a:fontRef>
-        </p:style>
-        <p:txBody>
-          <a:bodyPr rtlCol="0" anchor="ctr"/>
-          <a:lstStyle/>
-          <a:p>
-            <a:pPr algn="ctr"/>
-          </a:p>
-        </p:txBody>
-      </p:sp>
-      <p:sp>
-        <p:nvSpPr>
-          <p:cNvPr id="21" name="Panel 4 number"/>
-          <p:cNvSpPr/>
-          <p:nvPr/>
-        </p:nvSpPr>
-        <p:spPr>
-          <a:xfrm>
-            <a:off x="347472" y="4242815"/>
-            <a:ext cx="201168" cy="201168"/>
-          </a:xfrm>
-          <a:prstGeom prst="ellipse">
-            <a:avLst/>
-          </a:prstGeom>
-          <a:solidFill>
-            <a:srgbClr val="0D366B"/>
-          </a:solidFill>
-          <a:ln>
-            <a:noFill/>
-          </a:ln>
-          <a:effectLst/>
-        </p:spPr>
-        <p:style>
-          <a:lnRef idx="1">
-            <a:schemeClr val="accent1"/>
-          </a:lnRef>
-          <a:fillRef idx="3">
-            <a:schemeClr val="accent1"/>
-          </a:fillRef>
-          <a:effectRef idx="2">
-            <a:schemeClr val="accent1"/>
-          </a:effectRef>
-          <a:fontRef idx="minor">
-            <a:schemeClr val="lt1"/>
-          </a:fontRef>
-        </p:style>
-        <p:txBody>
-          <a:bodyPr rtlCol="0" anchor="ctr" lIns="0" rIns="0" tIns="0" bIns="0"/>
-          <a:lstStyle/>
-          <a:p>
-            <a:pPr algn="ctr"/>
-            <a:r>
-              <a:rPr sz="750" b="1">
-                <a:solidFill>
-                  <a:srgbClr val="FFFFFF"/>
-                </a:solidFill>
-                <a:latin typeface="Arial"/>
-              </a:rPr>
-              <a:t>4</a:t>
-            </a:r>
-          </a:p>
-        </p:txBody>
-      </p:sp>
-      <p:sp>
-        <p:nvSpPr>
-          <p:cNvPr id="22" name="Panel 4 takeaway"/>
+              <a:t>The cap cut shoeboxes, yet big homes never returned. Developers moved to compact one- and two-bedders instead.</a:t>
+            </a:r>
+          </a:p>
+        </p:txBody>
+      </p:sp>
+      <p:sp>
+        <p:nvSpPr>
+          <p:cNvPr id="22" name="Row 2 label"/>
           <p:cNvSpPr txBox="1"/>
           <p:nvPr/>
         </p:nvSpPr>
         <p:spPr>
           <a:xfrm>
-            <a:off x="612647" y="4197095"/>
-            <a:ext cx="1840991" cy="310896"/>
+            <a:off x="274320" y="3941063"/>
+            <a:ext cx="7013448" cy="164592"/>
           </a:xfrm>
           <a:prstGeom prst="rect">
             <a:avLst/>
@@ -3984,6 +3969,147 @@
               </a:spcAft>
             </a:pPr>
             <a:r>
+              <a:rPr sz="700" b="1">
+                <a:solidFill>
+                  <a:srgbClr val="1C5CAB"/>
+                </a:solidFill>
+                <a:latin typeface="Arial"/>
+              </a:rPr>
+              <a:t>2   IS IT REAL, AND HOW DOES IT WORK?</a:t>
+            </a:r>
+          </a:p>
+        </p:txBody>
+      </p:sp>
+      <p:sp>
+        <p:nvSpPr>
+          <p:cNvPr id="23" name="Panel 4 card"/>
+          <p:cNvSpPr/>
+          <p:nvPr/>
+        </p:nvSpPr>
+        <p:spPr>
+          <a:xfrm>
+            <a:off x="274320" y="4133087"/>
+            <a:ext cx="2252472" cy="2414016"/>
+          </a:xfrm>
+          <a:prstGeom prst="roundRect">
+            <a:avLst>
+              <a:gd name="adj" fmla="val 4000"/>
+            </a:avLst>
+          </a:prstGeom>
+          <a:solidFill>
+            <a:srgbClr val="F4F5F7"/>
+          </a:solidFill>
+          <a:ln>
+            <a:noFill/>
+          </a:ln>
+          <a:effectLst/>
+        </p:spPr>
+        <p:style>
+          <a:lnRef idx="1">
+            <a:schemeClr val="accent1"/>
+          </a:lnRef>
+          <a:fillRef idx="3">
+            <a:schemeClr val="accent1"/>
+          </a:fillRef>
+          <a:effectRef idx="2">
+            <a:schemeClr val="accent1"/>
+          </a:effectRef>
+          <a:fontRef idx="minor">
+            <a:schemeClr val="lt1"/>
+          </a:fontRef>
+        </p:style>
+        <p:txBody>
+          <a:bodyPr rtlCol="0" anchor="ctr"/>
+          <a:lstStyle/>
+          <a:p>
+            <a:pPr algn="ctr"/>
+          </a:p>
+        </p:txBody>
+      </p:sp>
+      <p:sp>
+        <p:nvSpPr>
+          <p:cNvPr id="24" name="Panel 4 number"/>
+          <p:cNvSpPr/>
+          <p:nvPr/>
+        </p:nvSpPr>
+        <p:spPr>
+          <a:xfrm>
+            <a:off x="347472" y="4224527"/>
+            <a:ext cx="201168" cy="201168"/>
+          </a:xfrm>
+          <a:prstGeom prst="ellipse">
+            <a:avLst/>
+          </a:prstGeom>
+          <a:solidFill>
+            <a:srgbClr val="0D366B"/>
+          </a:solidFill>
+          <a:ln>
+            <a:noFill/>
+          </a:ln>
+          <a:effectLst/>
+        </p:spPr>
+        <p:style>
+          <a:lnRef idx="1">
+            <a:schemeClr val="accent1"/>
+          </a:lnRef>
+          <a:fillRef idx="3">
+            <a:schemeClr val="accent1"/>
+          </a:fillRef>
+          <a:effectRef idx="2">
+            <a:schemeClr val="accent1"/>
+          </a:effectRef>
+          <a:fontRef idx="minor">
+            <a:schemeClr val="lt1"/>
+          </a:fontRef>
+        </p:style>
+        <p:txBody>
+          <a:bodyPr rtlCol="0" anchor="ctr" lIns="0" rIns="0" tIns="0" bIns="0"/>
+          <a:lstStyle/>
+          <a:p>
+            <a:pPr algn="ctr"/>
+            <a:r>
+              <a:rPr sz="750" b="1">
+                <a:solidFill>
+                  <a:srgbClr val="FFFFFF"/>
+                </a:solidFill>
+                <a:latin typeface="Arial"/>
+              </a:rPr>
+              <a:t>4</a:t>
+            </a:r>
+          </a:p>
+        </p:txBody>
+      </p:sp>
+      <p:sp>
+        <p:nvSpPr>
+          <p:cNvPr id="25" name="Panel 4 takeaway"/>
+          <p:cNvSpPr txBox="1"/>
+          <p:nvPr/>
+        </p:nvSpPr>
+        <p:spPr>
+          <a:xfrm>
+            <a:off x="612647" y="4178807"/>
+            <a:ext cx="1840991" cy="310896"/>
+          </a:xfrm>
+          <a:prstGeom prst="rect">
+            <a:avLst/>
+          </a:prstGeom>
+          <a:noFill/>
+        </p:spPr>
+        <p:txBody>
+          <a:bodyPr wrap="square" lIns="0" rIns="0" tIns="0" bIns="0" anchor="ctr">
+            <a:spAutoFit/>
+          </a:bodyPr>
+          <a:lstStyle/>
+          <a:p>
+            <a:pPr>
+              <a:lnSpc>
+                <a:spcPct val="105000"/>
+              </a:lnSpc>
+              <a:spcAft>
+                <a:spcPts val="0"/>
+              </a:spcAft>
+            </a:pPr>
+            <a:r>
               <a:rPr sz="780" b="1">
                 <a:solidFill>
                   <a:srgbClr val="0B0B0B"/>
@@ -3997,7 +4123,7 @@
       </p:sp>
       <p:pic>
         <p:nvPicPr>
-          <p:cNvPr id="23" name="Panel 4 figure" descr="04_coefficients.png"/>
+          <p:cNvPr id="26" name="Panel 4 figure" descr="04_coefficients.png"/>
           <p:cNvPicPr>
             <a:picLocks noChangeAspect="1"/>
           </p:cNvPicPr>
@@ -4011,8 +4137,8 @@
         </p:blipFill>
         <p:spPr>
           <a:xfrm>
-            <a:off x="321564" y="4526279"/>
-            <a:ext cx="2157984" cy="2011680"/>
+            <a:off x="321564" y="4507991"/>
+            <a:ext cx="2157984" cy="1554480"/>
           </a:xfrm>
           <a:prstGeom prst="rect">
             <a:avLst/>
@@ -4021,113 +4147,14 @@
       </p:pic>
       <p:sp>
         <p:nvSpPr>
-          <p:cNvPr id="24" name="Panel 5 card"/>
-          <p:cNvSpPr/>
-          <p:nvPr/>
-        </p:nvSpPr>
-        <p:spPr>
-          <a:xfrm>
-            <a:off x="2654808" y="4151375"/>
-            <a:ext cx="2252472" cy="2423160"/>
-          </a:xfrm>
-          <a:prstGeom prst="roundRect">
-            <a:avLst>
-              <a:gd name="adj" fmla="val 4000"/>
-            </a:avLst>
-          </a:prstGeom>
-          <a:solidFill>
-            <a:srgbClr val="F4F5F7"/>
-          </a:solidFill>
-          <a:ln>
-            <a:noFill/>
-          </a:ln>
-          <a:effectLst/>
-        </p:spPr>
-        <p:style>
-          <a:lnRef idx="1">
-            <a:schemeClr val="accent1"/>
-          </a:lnRef>
-          <a:fillRef idx="3">
-            <a:schemeClr val="accent1"/>
-          </a:fillRef>
-          <a:effectRef idx="2">
-            <a:schemeClr val="accent1"/>
-          </a:effectRef>
-          <a:fontRef idx="minor">
-            <a:schemeClr val="lt1"/>
-          </a:fontRef>
-        </p:style>
-        <p:txBody>
-          <a:bodyPr rtlCol="0" anchor="ctr"/>
-          <a:lstStyle/>
-          <a:p>
-            <a:pPr algn="ctr"/>
-          </a:p>
-        </p:txBody>
-      </p:sp>
-      <p:sp>
-        <p:nvSpPr>
-          <p:cNvPr id="25" name="Panel 5 number"/>
-          <p:cNvSpPr/>
-          <p:nvPr/>
-        </p:nvSpPr>
-        <p:spPr>
-          <a:xfrm>
-            <a:off x="2727960" y="4242815"/>
-            <a:ext cx="201168" cy="201168"/>
-          </a:xfrm>
-          <a:prstGeom prst="ellipse">
-            <a:avLst/>
-          </a:prstGeom>
-          <a:solidFill>
-            <a:srgbClr val="0D366B"/>
-          </a:solidFill>
-          <a:ln>
-            <a:noFill/>
-          </a:ln>
-          <a:effectLst/>
-        </p:spPr>
-        <p:style>
-          <a:lnRef idx="1">
-            <a:schemeClr val="accent1"/>
-          </a:lnRef>
-          <a:fillRef idx="3">
-            <a:schemeClr val="accent1"/>
-          </a:fillRef>
-          <a:effectRef idx="2">
-            <a:schemeClr val="accent1"/>
-          </a:effectRef>
-          <a:fontRef idx="minor">
-            <a:schemeClr val="lt1"/>
-          </a:fontRef>
-        </p:style>
-        <p:txBody>
-          <a:bodyPr rtlCol="0" anchor="ctr" lIns="0" rIns="0" tIns="0" bIns="0"/>
-          <a:lstStyle/>
-          <a:p>
-            <a:pPr algn="ctr"/>
-            <a:r>
-              <a:rPr sz="750" b="1">
-                <a:solidFill>
-                  <a:srgbClr val="FFFFFF"/>
-                </a:solidFill>
-                <a:latin typeface="Arial"/>
-              </a:rPr>
-              <a:t>5</a:t>
-            </a:r>
-          </a:p>
-        </p:txBody>
-      </p:sp>
-      <p:sp>
-        <p:nvSpPr>
-          <p:cNvPr id="26" name="Panel 5 takeaway"/>
+          <p:cNvPr id="27" name="Panel 4 insight"/>
           <p:cNvSpPr txBox="1"/>
           <p:nvPr/>
         </p:nvSpPr>
         <p:spPr>
           <a:xfrm>
-            <a:off x="2993136" y="4197095"/>
-            <a:ext cx="1840991" cy="310896"/>
+            <a:off x="384048" y="6089903"/>
+            <a:ext cx="2033016" cy="429768"/>
           </a:xfrm>
           <a:prstGeom prst="rect">
             <a:avLst/>
@@ -4135,7 +4162,7 @@
           <a:noFill/>
         </p:spPr>
         <p:txBody>
-          <a:bodyPr wrap="square" lIns="0" rIns="0" tIns="0" bIns="0" anchor="ctr">
+          <a:bodyPr wrap="square" lIns="0" rIns="0" tIns="0" bIns="0" anchor="t">
             <a:spAutoFit/>
           </a:bodyPr>
           <a:lstStyle/>
@@ -4149,6 +4176,147 @@
               </a:spcAft>
             </a:pPr>
             <a:r>
+              <a:rPr sz="690" b="0">
+                <a:solidFill>
+                  <a:srgbClr val="52514E"/>
+                </a:solidFill>
+                <a:latin typeface="Arial"/>
+              </a:rPr>
+              <a:t>The raw and controlled gaps are almost identical, so units shrank everywhere, in cheap suburbs and prime districts alike.</a:t>
+            </a:r>
+          </a:p>
+        </p:txBody>
+      </p:sp>
+      <p:sp>
+        <p:nvSpPr>
+          <p:cNvPr id="28" name="Panel 5 card"/>
+          <p:cNvSpPr/>
+          <p:nvPr/>
+        </p:nvSpPr>
+        <p:spPr>
+          <a:xfrm>
+            <a:off x="2654808" y="4133087"/>
+            <a:ext cx="2252472" cy="2414016"/>
+          </a:xfrm>
+          <a:prstGeom prst="roundRect">
+            <a:avLst>
+              <a:gd name="adj" fmla="val 4000"/>
+            </a:avLst>
+          </a:prstGeom>
+          <a:solidFill>
+            <a:srgbClr val="F4F5F7"/>
+          </a:solidFill>
+          <a:ln>
+            <a:noFill/>
+          </a:ln>
+          <a:effectLst/>
+        </p:spPr>
+        <p:style>
+          <a:lnRef idx="1">
+            <a:schemeClr val="accent1"/>
+          </a:lnRef>
+          <a:fillRef idx="3">
+            <a:schemeClr val="accent1"/>
+          </a:fillRef>
+          <a:effectRef idx="2">
+            <a:schemeClr val="accent1"/>
+          </a:effectRef>
+          <a:fontRef idx="minor">
+            <a:schemeClr val="lt1"/>
+          </a:fontRef>
+        </p:style>
+        <p:txBody>
+          <a:bodyPr rtlCol="0" anchor="ctr"/>
+          <a:lstStyle/>
+          <a:p>
+            <a:pPr algn="ctr"/>
+          </a:p>
+        </p:txBody>
+      </p:sp>
+      <p:sp>
+        <p:nvSpPr>
+          <p:cNvPr id="29" name="Panel 5 number"/>
+          <p:cNvSpPr/>
+          <p:nvPr/>
+        </p:nvSpPr>
+        <p:spPr>
+          <a:xfrm>
+            <a:off x="2727960" y="4224527"/>
+            <a:ext cx="201168" cy="201168"/>
+          </a:xfrm>
+          <a:prstGeom prst="ellipse">
+            <a:avLst/>
+          </a:prstGeom>
+          <a:solidFill>
+            <a:srgbClr val="0D366B"/>
+          </a:solidFill>
+          <a:ln>
+            <a:noFill/>
+          </a:ln>
+          <a:effectLst/>
+        </p:spPr>
+        <p:style>
+          <a:lnRef idx="1">
+            <a:schemeClr val="accent1"/>
+          </a:lnRef>
+          <a:fillRef idx="3">
+            <a:schemeClr val="accent1"/>
+          </a:fillRef>
+          <a:effectRef idx="2">
+            <a:schemeClr val="accent1"/>
+          </a:effectRef>
+          <a:fontRef idx="minor">
+            <a:schemeClr val="lt1"/>
+          </a:fontRef>
+        </p:style>
+        <p:txBody>
+          <a:bodyPr rtlCol="0" anchor="ctr" lIns="0" rIns="0" tIns="0" bIns="0"/>
+          <a:lstStyle/>
+          <a:p>
+            <a:pPr algn="ctr"/>
+            <a:r>
+              <a:rPr sz="750" b="1">
+                <a:solidFill>
+                  <a:srgbClr val="FFFFFF"/>
+                </a:solidFill>
+                <a:latin typeface="Arial"/>
+              </a:rPr>
+              <a:t>5</a:t>
+            </a:r>
+          </a:p>
+        </p:txBody>
+      </p:sp>
+      <p:sp>
+        <p:nvSpPr>
+          <p:cNvPr id="30" name="Panel 5 takeaway"/>
+          <p:cNvSpPr txBox="1"/>
+          <p:nvPr/>
+        </p:nvSpPr>
+        <p:spPr>
+          <a:xfrm>
+            <a:off x="2993136" y="4178807"/>
+            <a:ext cx="1840991" cy="310896"/>
+          </a:xfrm>
+          <a:prstGeom prst="rect">
+            <a:avLst/>
+          </a:prstGeom>
+          <a:noFill/>
+        </p:spPr>
+        <p:txBody>
+          <a:bodyPr wrap="square" lIns="0" rIns="0" tIns="0" bIns="0" anchor="ctr">
+            <a:spAutoFit/>
+          </a:bodyPr>
+          <a:lstStyle/>
+          <a:p>
+            <a:pPr>
+              <a:lnSpc>
+                <a:spcPct val="105000"/>
+              </a:lnSpc>
+              <a:spcAft>
+                <a:spcPts val="0"/>
+              </a:spcAft>
+            </a:pPr>
+            <a:r>
               <a:rPr sz="780" b="1">
                 <a:solidFill>
                   <a:srgbClr val="0B0B0B"/>
@@ -4162,7 +4330,7 @@
       </p:sp>
       <p:pic>
         <p:nvPicPr>
-          <p:cNvPr id="27" name="Panel 5 figure" descr="05_scatter_isoprice.png"/>
+          <p:cNvPr id="31" name="Panel 5 figure" descr="05_scatter_isoprice.png"/>
           <p:cNvPicPr>
             <a:picLocks noChangeAspect="1"/>
           </p:cNvPicPr>
@@ -4176,8 +4344,8 @@
         </p:blipFill>
         <p:spPr>
           <a:xfrm>
-            <a:off x="2702052" y="4526279"/>
-            <a:ext cx="2157984" cy="2011680"/>
+            <a:off x="2702052" y="4507991"/>
+            <a:ext cx="2157984" cy="1554480"/>
           </a:xfrm>
           <a:prstGeom prst="rect">
             <a:avLst/>
@@ -4186,113 +4354,14 @@
       </p:pic>
       <p:sp>
         <p:nvSpPr>
-          <p:cNvPr id="28" name="Panel 6 card"/>
-          <p:cNvSpPr/>
-          <p:nvPr/>
-        </p:nvSpPr>
-        <p:spPr>
-          <a:xfrm>
-            <a:off x="5035296" y="4151375"/>
-            <a:ext cx="2252472" cy="2423160"/>
-          </a:xfrm>
-          <a:prstGeom prst="roundRect">
-            <a:avLst>
-              <a:gd name="adj" fmla="val 4000"/>
-            </a:avLst>
-          </a:prstGeom>
-          <a:solidFill>
-            <a:srgbClr val="F4F5F7"/>
-          </a:solidFill>
-          <a:ln>
-            <a:noFill/>
-          </a:ln>
-          <a:effectLst/>
-        </p:spPr>
-        <p:style>
-          <a:lnRef idx="1">
-            <a:schemeClr val="accent1"/>
-          </a:lnRef>
-          <a:fillRef idx="3">
-            <a:schemeClr val="accent1"/>
-          </a:fillRef>
-          <a:effectRef idx="2">
-            <a:schemeClr val="accent1"/>
-          </a:effectRef>
-          <a:fontRef idx="minor">
-            <a:schemeClr val="lt1"/>
-          </a:fontRef>
-        </p:style>
-        <p:txBody>
-          <a:bodyPr rtlCol="0" anchor="ctr"/>
-          <a:lstStyle/>
-          <a:p>
-            <a:pPr algn="ctr"/>
-          </a:p>
-        </p:txBody>
-      </p:sp>
-      <p:sp>
-        <p:nvSpPr>
-          <p:cNvPr id="29" name="Panel 6 number"/>
-          <p:cNvSpPr/>
-          <p:nvPr/>
-        </p:nvSpPr>
-        <p:spPr>
-          <a:xfrm>
-            <a:off x="5108448" y="4242815"/>
-            <a:ext cx="201168" cy="201168"/>
-          </a:xfrm>
-          <a:prstGeom prst="ellipse">
-            <a:avLst/>
-          </a:prstGeom>
-          <a:solidFill>
-            <a:srgbClr val="0D366B"/>
-          </a:solidFill>
-          <a:ln>
-            <a:noFill/>
-          </a:ln>
-          <a:effectLst/>
-        </p:spPr>
-        <p:style>
-          <a:lnRef idx="1">
-            <a:schemeClr val="accent1"/>
-          </a:lnRef>
-          <a:fillRef idx="3">
-            <a:schemeClr val="accent1"/>
-          </a:fillRef>
-          <a:effectRef idx="2">
-            <a:schemeClr val="accent1"/>
-          </a:effectRef>
-          <a:fontRef idx="minor">
-            <a:schemeClr val="lt1"/>
-          </a:fontRef>
-        </p:style>
-        <p:txBody>
-          <a:bodyPr rtlCol="0" anchor="ctr" lIns="0" rIns="0" tIns="0" bIns="0"/>
-          <a:lstStyle/>
-          <a:p>
-            <a:pPr algn="ctr"/>
-            <a:r>
-              <a:rPr sz="750" b="1">
-                <a:solidFill>
-                  <a:srgbClr val="FFFFFF"/>
-                </a:solidFill>
-                <a:latin typeface="Arial"/>
-              </a:rPr>
-              <a:t>6</a:t>
-            </a:r>
-          </a:p>
-        </p:txBody>
-      </p:sp>
-      <p:sp>
-        <p:nvSpPr>
-          <p:cNvPr id="30" name="Panel 6 takeaway"/>
+          <p:cNvPr id="32" name="Panel 5 insight"/>
           <p:cNvSpPr txBox="1"/>
           <p:nvPr/>
         </p:nvSpPr>
         <p:spPr>
           <a:xfrm>
-            <a:off x="5373624" y="4197095"/>
-            <a:ext cx="1840991" cy="310896"/>
+            <a:off x="2764536" y="6089903"/>
+            <a:ext cx="2033016" cy="429768"/>
           </a:xfrm>
           <a:prstGeom prst="rect">
             <a:avLst/>
@@ -4300,7 +4369,7 @@
           <a:noFill/>
         </p:spPr>
         <p:txBody>
-          <a:bodyPr wrap="square" lIns="0" rIns="0" tIns="0" bIns="0" anchor="ctr">
+          <a:bodyPr wrap="square" lIns="0" rIns="0" tIns="0" bIns="0" anchor="t">
             <a:spAutoFit/>
           </a:bodyPr>
           <a:lstStyle/>
@@ -4314,6 +4383,147 @@
               </a:spcAft>
             </a:pPr>
             <a:r>
+              <a:rPr sz="690" b="0">
+                <a:solidFill>
+                  <a:srgbClr val="52514E"/>
+                </a:solidFill>
+                <a:latin typeface="Arial"/>
+              </a:rPr>
+              <a:t>Smaller homes stayed cheaper despite a higher PSF, the trade shrinkflation relies on. Once the shrink stopped, the price tag rose by S$0.6M.</a:t>
+            </a:r>
+          </a:p>
+        </p:txBody>
+      </p:sp>
+      <p:sp>
+        <p:nvSpPr>
+          <p:cNvPr id="33" name="Panel 6 card"/>
+          <p:cNvSpPr/>
+          <p:nvPr/>
+        </p:nvSpPr>
+        <p:spPr>
+          <a:xfrm>
+            <a:off x="5035296" y="4133087"/>
+            <a:ext cx="2252472" cy="2414016"/>
+          </a:xfrm>
+          <a:prstGeom prst="roundRect">
+            <a:avLst>
+              <a:gd name="adj" fmla="val 4000"/>
+            </a:avLst>
+          </a:prstGeom>
+          <a:solidFill>
+            <a:srgbClr val="F4F5F7"/>
+          </a:solidFill>
+          <a:ln>
+            <a:noFill/>
+          </a:ln>
+          <a:effectLst/>
+        </p:spPr>
+        <p:style>
+          <a:lnRef idx="1">
+            <a:schemeClr val="accent1"/>
+          </a:lnRef>
+          <a:fillRef idx="3">
+            <a:schemeClr val="accent1"/>
+          </a:fillRef>
+          <a:effectRef idx="2">
+            <a:schemeClr val="accent1"/>
+          </a:effectRef>
+          <a:fontRef idx="minor">
+            <a:schemeClr val="lt1"/>
+          </a:fontRef>
+        </p:style>
+        <p:txBody>
+          <a:bodyPr rtlCol="0" anchor="ctr"/>
+          <a:lstStyle/>
+          <a:p>
+            <a:pPr algn="ctr"/>
+          </a:p>
+        </p:txBody>
+      </p:sp>
+      <p:sp>
+        <p:nvSpPr>
+          <p:cNvPr id="34" name="Panel 6 number"/>
+          <p:cNvSpPr/>
+          <p:nvPr/>
+        </p:nvSpPr>
+        <p:spPr>
+          <a:xfrm>
+            <a:off x="5108448" y="4224527"/>
+            <a:ext cx="201168" cy="201168"/>
+          </a:xfrm>
+          <a:prstGeom prst="ellipse">
+            <a:avLst/>
+          </a:prstGeom>
+          <a:solidFill>
+            <a:srgbClr val="0D366B"/>
+          </a:solidFill>
+          <a:ln>
+            <a:noFill/>
+          </a:ln>
+          <a:effectLst/>
+        </p:spPr>
+        <p:style>
+          <a:lnRef idx="1">
+            <a:schemeClr val="accent1"/>
+          </a:lnRef>
+          <a:fillRef idx="3">
+            <a:schemeClr val="accent1"/>
+          </a:fillRef>
+          <a:effectRef idx="2">
+            <a:schemeClr val="accent1"/>
+          </a:effectRef>
+          <a:fontRef idx="minor">
+            <a:schemeClr val="lt1"/>
+          </a:fontRef>
+        </p:style>
+        <p:txBody>
+          <a:bodyPr rtlCol="0" anchor="ctr" lIns="0" rIns="0" tIns="0" bIns="0"/>
+          <a:lstStyle/>
+          <a:p>
+            <a:pPr algn="ctr"/>
+            <a:r>
+              <a:rPr sz="750" b="1">
+                <a:solidFill>
+                  <a:srgbClr val="FFFFFF"/>
+                </a:solidFill>
+                <a:latin typeface="Arial"/>
+              </a:rPr>
+              <a:t>6</a:t>
+            </a:r>
+          </a:p>
+        </p:txBody>
+      </p:sp>
+      <p:sp>
+        <p:nvSpPr>
+          <p:cNvPr id="35" name="Panel 6 takeaway"/>
+          <p:cNvSpPr txBox="1"/>
+          <p:nvPr/>
+        </p:nvSpPr>
+        <p:spPr>
+          <a:xfrm>
+            <a:off x="5373624" y="4178807"/>
+            <a:ext cx="1840991" cy="310896"/>
+          </a:xfrm>
+          <a:prstGeom prst="rect">
+            <a:avLst/>
+          </a:prstGeom>
+          <a:noFill/>
+        </p:spPr>
+        <p:txBody>
+          <a:bodyPr wrap="square" lIns="0" rIns="0" tIns="0" bIns="0" anchor="ctr">
+            <a:spAutoFit/>
+          </a:bodyPr>
+          <a:lstStyle/>
+          <a:p>
+            <a:pPr>
+              <a:lnSpc>
+                <a:spcPct val="105000"/>
+              </a:lnSpc>
+              <a:spcAft>
+                <a:spcPts val="0"/>
+              </a:spcAft>
+            </a:pPr>
+            <a:r>
               <a:rPr sz="780" b="1">
                 <a:solidFill>
                   <a:srgbClr val="0B0B0B"/>
@@ -4327,7 +4537,7 @@
       </p:sp>
       <p:pic>
         <p:nvPicPr>
-          <p:cNvPr id="31" name="Panel 6 figure" descr="06_violin_pricing.png"/>
+          <p:cNvPr id="36" name="Panel 6 figure" descr="06_violin_pricing.png"/>
           <p:cNvPicPr>
             <a:picLocks noChangeAspect="1"/>
           </p:cNvPicPr>
@@ -4341,8 +4551,8 @@
         </p:blipFill>
         <p:spPr>
           <a:xfrm>
-            <a:off x="5082540" y="4526279"/>
-            <a:ext cx="2157984" cy="2011680"/>
+            <a:off x="5082540" y="4507991"/>
+            <a:ext cx="2157984" cy="1554480"/>
           </a:xfrm>
           <a:prstGeom prst="rect">
             <a:avLst/>
@@ -4351,14 +4561,14 @@
       </p:pic>
       <p:sp>
         <p:nvSpPr>
-          <p:cNvPr id="32" name="Row 3 label"/>
+          <p:cNvPr id="37" name="Panel 6 insight"/>
           <p:cNvSpPr txBox="1"/>
           <p:nvPr/>
         </p:nvSpPr>
         <p:spPr>
           <a:xfrm>
-            <a:off x="274320" y="6629399"/>
-            <a:ext cx="7013448" cy="164592"/>
+            <a:off x="5145024" y="6089903"/>
+            <a:ext cx="2033016" cy="429768"/>
           </a:xfrm>
           <a:prstGeom prst="rect">
             <a:avLst/>
@@ -4366,7 +4576,7 @@
           <a:noFill/>
         </p:spPr>
         <p:txBody>
-          <a:bodyPr wrap="square" lIns="0" rIns="0" tIns="0" bIns="0" anchor="ctr">
+          <a:bodyPr wrap="square" lIns="0" rIns="0" tIns="0" bIns="0" anchor="t">
             <a:spAutoFit/>
           </a:bodyPr>
           <a:lstStyle/>
@@ -4380,126 +4590,27 @@
               </a:spcAft>
             </a:pPr>
             <a:r>
-              <a:rPr sz="700" b="1">
-                <a:solidFill>
-                  <a:srgbClr val="1C5CAB"/>
+              <a:rPr sz="690" b="0">
+                <a:solidFill>
+                  <a:srgbClr val="52514E"/>
                 </a:solidFill>
                 <a:latin typeface="Arial"/>
               </a:rPr>
-              <a:t>3   WHY IT HAPPENED, AND WHAT CHANGED</a:t>
-            </a:r>
-          </a:p>
-        </p:txBody>
-      </p:sp>
-      <p:sp>
-        <p:nvSpPr>
-          <p:cNvPr id="33" name="Panel 7 card"/>
-          <p:cNvSpPr/>
-          <p:nvPr/>
-        </p:nvSpPr>
-        <p:spPr>
-          <a:xfrm>
-            <a:off x="274320" y="6821423"/>
-            <a:ext cx="2252472" cy="2423160"/>
-          </a:xfrm>
-          <a:prstGeom prst="roundRect">
-            <a:avLst>
-              <a:gd name="adj" fmla="val 4000"/>
-            </a:avLst>
-          </a:prstGeom>
-          <a:solidFill>
-            <a:srgbClr val="F4F5F7"/>
-          </a:solidFill>
-          <a:ln>
-            <a:noFill/>
-          </a:ln>
-          <a:effectLst/>
-        </p:spPr>
-        <p:style>
-          <a:lnRef idx="1">
-            <a:schemeClr val="accent1"/>
-          </a:lnRef>
-          <a:fillRef idx="3">
-            <a:schemeClr val="accent1"/>
-          </a:fillRef>
-          <a:effectRef idx="2">
-            <a:schemeClr val="accent1"/>
-          </a:effectRef>
-          <a:fontRef idx="minor">
-            <a:schemeClr val="lt1"/>
-          </a:fontRef>
-        </p:style>
-        <p:txBody>
-          <a:bodyPr rtlCol="0" anchor="ctr"/>
-          <a:lstStyle/>
-          <a:p>
-            <a:pPr algn="ctr"/>
-          </a:p>
-        </p:txBody>
-      </p:sp>
-      <p:sp>
-        <p:nvSpPr>
-          <p:cNvPr id="34" name="Panel 7 number"/>
-          <p:cNvSpPr/>
-          <p:nvPr/>
-        </p:nvSpPr>
-        <p:spPr>
-          <a:xfrm>
-            <a:off x="347472" y="6912863"/>
-            <a:ext cx="201168" cy="201168"/>
-          </a:xfrm>
-          <a:prstGeom prst="ellipse">
-            <a:avLst/>
-          </a:prstGeom>
-          <a:solidFill>
-            <a:srgbClr val="0D366B"/>
-          </a:solidFill>
-          <a:ln>
-            <a:noFill/>
-          </a:ln>
-          <a:effectLst/>
-        </p:spPr>
-        <p:style>
-          <a:lnRef idx="1">
-            <a:schemeClr val="accent1"/>
-          </a:lnRef>
-          <a:fillRef idx="3">
-            <a:schemeClr val="accent1"/>
-          </a:fillRef>
-          <a:effectRef idx="2">
-            <a:schemeClr val="accent1"/>
-          </a:effectRef>
-          <a:fontRef idx="minor">
-            <a:schemeClr val="lt1"/>
-          </a:fontRef>
-        </p:style>
-        <p:txBody>
-          <a:bodyPr rtlCol="0" anchor="ctr" lIns="0" rIns="0" tIns="0" bIns="0"/>
-          <a:lstStyle/>
-          <a:p>
-            <a:pPr algn="ctr"/>
-            <a:r>
-              <a:rPr sz="750" b="1">
-                <a:solidFill>
-                  <a:srgbClr val="FFFFFF"/>
-                </a:solidFill>
-                <a:latin typeface="Arial"/>
-              </a:rPr>
-              <a:t>7</a:t>
-            </a:r>
-          </a:p>
-        </p:txBody>
-      </p:sp>
-      <p:sp>
-        <p:nvSpPr>
-          <p:cNvPr id="35" name="Panel 7 takeaway"/>
+              <a:t>Small units carry no premium inside a launch, so every sq ft cut comes straight off the price tag. That made shrinking the easiest lever.</a:t>
+            </a:r>
+          </a:p>
+        </p:txBody>
+      </p:sp>
+      <p:sp>
+        <p:nvSpPr>
+          <p:cNvPr id="38" name="Row 3 label"/>
           <p:cNvSpPr txBox="1"/>
           <p:nvPr/>
         </p:nvSpPr>
         <p:spPr>
           <a:xfrm>
-            <a:off x="612647" y="6867143"/>
-            <a:ext cx="1840991" cy="310896"/>
+            <a:off x="274320" y="6592824"/>
+            <a:ext cx="7013448" cy="164592"/>
           </a:xfrm>
           <a:prstGeom prst="rect">
             <a:avLst/>
@@ -4521,6 +4632,147 @@
               </a:spcAft>
             </a:pPr>
             <a:r>
+              <a:rPr sz="700" b="1">
+                <a:solidFill>
+                  <a:srgbClr val="1C5CAB"/>
+                </a:solidFill>
+                <a:latin typeface="Arial"/>
+              </a:rPr>
+              <a:t>3   WHY IT HAPPENED, AND WHAT CHANGED</a:t>
+            </a:r>
+          </a:p>
+        </p:txBody>
+      </p:sp>
+      <p:sp>
+        <p:nvSpPr>
+          <p:cNvPr id="39" name="Panel 7 card"/>
+          <p:cNvSpPr/>
+          <p:nvPr/>
+        </p:nvSpPr>
+        <p:spPr>
+          <a:xfrm>
+            <a:off x="274320" y="6784848"/>
+            <a:ext cx="2252472" cy="2414016"/>
+          </a:xfrm>
+          <a:prstGeom prst="roundRect">
+            <a:avLst>
+              <a:gd name="adj" fmla="val 4000"/>
+            </a:avLst>
+          </a:prstGeom>
+          <a:solidFill>
+            <a:srgbClr val="F4F5F7"/>
+          </a:solidFill>
+          <a:ln>
+            <a:noFill/>
+          </a:ln>
+          <a:effectLst/>
+        </p:spPr>
+        <p:style>
+          <a:lnRef idx="1">
+            <a:schemeClr val="accent1"/>
+          </a:lnRef>
+          <a:fillRef idx="3">
+            <a:schemeClr val="accent1"/>
+          </a:fillRef>
+          <a:effectRef idx="2">
+            <a:schemeClr val="accent1"/>
+          </a:effectRef>
+          <a:fontRef idx="minor">
+            <a:schemeClr val="lt1"/>
+          </a:fontRef>
+        </p:style>
+        <p:txBody>
+          <a:bodyPr rtlCol="0" anchor="ctr"/>
+          <a:lstStyle/>
+          <a:p>
+            <a:pPr algn="ctr"/>
+          </a:p>
+        </p:txBody>
+      </p:sp>
+      <p:sp>
+        <p:nvSpPr>
+          <p:cNvPr id="40" name="Panel 7 number"/>
+          <p:cNvSpPr/>
+          <p:nvPr/>
+        </p:nvSpPr>
+        <p:spPr>
+          <a:xfrm>
+            <a:off x="347472" y="6876288"/>
+            <a:ext cx="201168" cy="201168"/>
+          </a:xfrm>
+          <a:prstGeom prst="ellipse">
+            <a:avLst/>
+          </a:prstGeom>
+          <a:solidFill>
+            <a:srgbClr val="0D366B"/>
+          </a:solidFill>
+          <a:ln>
+            <a:noFill/>
+          </a:ln>
+          <a:effectLst/>
+        </p:spPr>
+        <p:style>
+          <a:lnRef idx="1">
+            <a:schemeClr val="accent1"/>
+          </a:lnRef>
+          <a:fillRef idx="3">
+            <a:schemeClr val="accent1"/>
+          </a:fillRef>
+          <a:effectRef idx="2">
+            <a:schemeClr val="accent1"/>
+          </a:effectRef>
+          <a:fontRef idx="minor">
+            <a:schemeClr val="lt1"/>
+          </a:fontRef>
+        </p:style>
+        <p:txBody>
+          <a:bodyPr rtlCol="0" anchor="ctr" lIns="0" rIns="0" tIns="0" bIns="0"/>
+          <a:lstStyle/>
+          <a:p>
+            <a:pPr algn="ctr"/>
+            <a:r>
+              <a:rPr sz="750" b="1">
+                <a:solidFill>
+                  <a:srgbClr val="FFFFFF"/>
+                </a:solidFill>
+                <a:latin typeface="Arial"/>
+              </a:rPr>
+              <a:t>7</a:t>
+            </a:r>
+          </a:p>
+        </p:txBody>
+      </p:sp>
+      <p:sp>
+        <p:nvSpPr>
+          <p:cNvPr id="41" name="Panel 7 takeaway"/>
+          <p:cNvSpPr txBox="1"/>
+          <p:nvPr/>
+        </p:nvSpPr>
+        <p:spPr>
+          <a:xfrm>
+            <a:off x="612647" y="6830568"/>
+            <a:ext cx="1840991" cy="310896"/>
+          </a:xfrm>
+          <a:prstGeom prst="rect">
+            <a:avLst/>
+          </a:prstGeom>
+          <a:noFill/>
+        </p:spPr>
+        <p:txBody>
+          <a:bodyPr wrap="square" lIns="0" rIns="0" tIns="0" bIns="0" anchor="ctr">
+            <a:spAutoFit/>
+          </a:bodyPr>
+          <a:lstStyle/>
+          <a:p>
+            <a:pPr>
+              <a:lnSpc>
+                <a:spcPct val="105000"/>
+              </a:lnSpc>
+              <a:spcAft>
+                <a:spcPts val="0"/>
+              </a:spcAft>
+            </a:pPr>
+            <a:r>
               <a:rPr sz="780" b="1">
                 <a:solidFill>
                   <a:srgbClr val="0B0B0B"/>
@@ -4534,7 +4786,7 @@
       </p:sp>
       <p:pic>
         <p:nvPicPr>
-          <p:cNvPr id="36" name="Panel 7 figure" descr="07_lollipop_macro.png"/>
+          <p:cNvPr id="42" name="Panel 7 figure" descr="07_lollipop_macro.png"/>
           <p:cNvPicPr>
             <a:picLocks noChangeAspect="1"/>
           </p:cNvPicPr>
@@ -4548,8 +4800,8 @@
         </p:blipFill>
         <p:spPr>
           <a:xfrm>
-            <a:off x="321564" y="7196327"/>
-            <a:ext cx="2157984" cy="2011680"/>
+            <a:off x="321564" y="7159751"/>
+            <a:ext cx="2157984" cy="1554480"/>
           </a:xfrm>
           <a:prstGeom prst="rect">
             <a:avLst/>
@@ -4558,113 +4810,14 @@
       </p:pic>
       <p:sp>
         <p:nvSpPr>
-          <p:cNvPr id="37" name="Panel 8 card"/>
-          <p:cNvSpPr/>
-          <p:nvPr/>
-        </p:nvSpPr>
-        <p:spPr>
-          <a:xfrm>
-            <a:off x="2654808" y="6821423"/>
-            <a:ext cx="2252472" cy="2423160"/>
-          </a:xfrm>
-          <a:prstGeom prst="roundRect">
-            <a:avLst>
-              <a:gd name="adj" fmla="val 4000"/>
-            </a:avLst>
-          </a:prstGeom>
-          <a:solidFill>
-            <a:srgbClr val="F4F5F7"/>
-          </a:solidFill>
-          <a:ln>
-            <a:noFill/>
-          </a:ln>
-          <a:effectLst/>
-        </p:spPr>
-        <p:style>
-          <a:lnRef idx="1">
-            <a:schemeClr val="accent1"/>
-          </a:lnRef>
-          <a:fillRef idx="3">
-            <a:schemeClr val="accent1"/>
-          </a:fillRef>
-          <a:effectRef idx="2">
-            <a:schemeClr val="accent1"/>
-          </a:effectRef>
-          <a:fontRef idx="minor">
-            <a:schemeClr val="lt1"/>
-          </a:fontRef>
-        </p:style>
-        <p:txBody>
-          <a:bodyPr rtlCol="0" anchor="ctr"/>
-          <a:lstStyle/>
-          <a:p>
-            <a:pPr algn="ctr"/>
-          </a:p>
-        </p:txBody>
-      </p:sp>
-      <p:sp>
-        <p:nvSpPr>
-          <p:cNvPr id="38" name="Panel 8 number"/>
-          <p:cNvSpPr/>
-          <p:nvPr/>
-        </p:nvSpPr>
-        <p:spPr>
-          <a:xfrm>
-            <a:off x="2727960" y="6912863"/>
-            <a:ext cx="201168" cy="201168"/>
-          </a:xfrm>
-          <a:prstGeom prst="ellipse">
-            <a:avLst/>
-          </a:prstGeom>
-          <a:solidFill>
-            <a:srgbClr val="0D366B"/>
-          </a:solidFill>
-          <a:ln>
-            <a:noFill/>
-          </a:ln>
-          <a:effectLst/>
-        </p:spPr>
-        <p:style>
-          <a:lnRef idx="1">
-            <a:schemeClr val="accent1"/>
-          </a:lnRef>
-          <a:fillRef idx="3">
-            <a:schemeClr val="accent1"/>
-          </a:fillRef>
-          <a:effectRef idx="2">
-            <a:schemeClr val="accent1"/>
-          </a:effectRef>
-          <a:fontRef idx="minor">
-            <a:schemeClr val="lt1"/>
-          </a:fontRef>
-        </p:style>
-        <p:txBody>
-          <a:bodyPr rtlCol="0" anchor="ctr" lIns="0" rIns="0" tIns="0" bIns="0"/>
-          <a:lstStyle/>
-          <a:p>
-            <a:pPr algn="ctr"/>
-            <a:r>
-              <a:rPr sz="750" b="1">
-                <a:solidFill>
-                  <a:srgbClr val="FFFFFF"/>
-                </a:solidFill>
-                <a:latin typeface="Arial"/>
-              </a:rPr>
-              <a:t>8</a:t>
-            </a:r>
-          </a:p>
-        </p:txBody>
-      </p:sp>
-      <p:sp>
-        <p:nvSpPr>
-          <p:cNvPr id="39" name="Panel 8 takeaway"/>
+          <p:cNvPr id="43" name="Panel 7 insight"/>
           <p:cNvSpPr txBox="1"/>
           <p:nvPr/>
         </p:nvSpPr>
         <p:spPr>
           <a:xfrm>
-            <a:off x="2993136" y="6867143"/>
-            <a:ext cx="1840991" cy="310896"/>
+            <a:off x="384048" y="8741663"/>
+            <a:ext cx="2033016" cy="429768"/>
           </a:xfrm>
           <a:prstGeom prst="rect">
             <a:avLst/>
@@ -4672,7 +4825,7 @@
           <a:noFill/>
         </p:spPr>
         <p:txBody>
-          <a:bodyPr wrap="square" lIns="0" rIns="0" tIns="0" bIns="0" anchor="ctr">
+          <a:bodyPr wrap="square" lIns="0" rIns="0" tIns="0" bIns="0" anchor="t">
             <a:spAutoFit/>
           </a:bodyPr>
           <a:lstStyle/>
@@ -4686,6 +4839,147 @@
               </a:spcAft>
             </a:pPr>
             <a:r>
+              <a:rPr sz="690" b="0">
+                <a:solidFill>
+                  <a:srgbClr val="52514E"/>
+                </a:solidFill>
+                <a:latin typeface="Arial"/>
+              </a:rPr>
+              <a:t>When prices ran ahead of incomes, developers cut the size of the product instead of its price per sq ft.</a:t>
+            </a:r>
+          </a:p>
+        </p:txBody>
+      </p:sp>
+      <p:sp>
+        <p:nvSpPr>
+          <p:cNvPr id="44" name="Panel 8 card"/>
+          <p:cNvSpPr/>
+          <p:nvPr/>
+        </p:nvSpPr>
+        <p:spPr>
+          <a:xfrm>
+            <a:off x="2654808" y="6784848"/>
+            <a:ext cx="2252472" cy="2414016"/>
+          </a:xfrm>
+          <a:prstGeom prst="roundRect">
+            <a:avLst>
+              <a:gd name="adj" fmla="val 4000"/>
+            </a:avLst>
+          </a:prstGeom>
+          <a:solidFill>
+            <a:srgbClr val="F4F5F7"/>
+          </a:solidFill>
+          <a:ln>
+            <a:noFill/>
+          </a:ln>
+          <a:effectLst/>
+        </p:spPr>
+        <p:style>
+          <a:lnRef idx="1">
+            <a:schemeClr val="accent1"/>
+          </a:lnRef>
+          <a:fillRef idx="3">
+            <a:schemeClr val="accent1"/>
+          </a:fillRef>
+          <a:effectRef idx="2">
+            <a:schemeClr val="accent1"/>
+          </a:effectRef>
+          <a:fontRef idx="minor">
+            <a:schemeClr val="lt1"/>
+          </a:fontRef>
+        </p:style>
+        <p:txBody>
+          <a:bodyPr rtlCol="0" anchor="ctr"/>
+          <a:lstStyle/>
+          <a:p>
+            <a:pPr algn="ctr"/>
+          </a:p>
+        </p:txBody>
+      </p:sp>
+      <p:sp>
+        <p:nvSpPr>
+          <p:cNvPr id="45" name="Panel 8 number"/>
+          <p:cNvSpPr/>
+          <p:nvPr/>
+        </p:nvSpPr>
+        <p:spPr>
+          <a:xfrm>
+            <a:off x="2727960" y="6876288"/>
+            <a:ext cx="201168" cy="201168"/>
+          </a:xfrm>
+          <a:prstGeom prst="ellipse">
+            <a:avLst/>
+          </a:prstGeom>
+          <a:solidFill>
+            <a:srgbClr val="0D366B"/>
+          </a:solidFill>
+          <a:ln>
+            <a:noFill/>
+          </a:ln>
+          <a:effectLst/>
+        </p:spPr>
+        <p:style>
+          <a:lnRef idx="1">
+            <a:schemeClr val="accent1"/>
+          </a:lnRef>
+          <a:fillRef idx="3">
+            <a:schemeClr val="accent1"/>
+          </a:fillRef>
+          <a:effectRef idx="2">
+            <a:schemeClr val="accent1"/>
+          </a:effectRef>
+          <a:fontRef idx="minor">
+            <a:schemeClr val="lt1"/>
+          </a:fontRef>
+        </p:style>
+        <p:txBody>
+          <a:bodyPr rtlCol="0" anchor="ctr" lIns="0" rIns="0" tIns="0" bIns="0"/>
+          <a:lstStyle/>
+          <a:p>
+            <a:pPr algn="ctr"/>
+            <a:r>
+              <a:rPr sz="750" b="1">
+                <a:solidFill>
+                  <a:srgbClr val="FFFFFF"/>
+                </a:solidFill>
+                <a:latin typeface="Arial"/>
+              </a:rPr>
+              <a:t>8</a:t>
+            </a:r>
+          </a:p>
+        </p:txBody>
+      </p:sp>
+      <p:sp>
+        <p:nvSpPr>
+          <p:cNvPr id="46" name="Panel 8 takeaway"/>
+          <p:cNvSpPr txBox="1"/>
+          <p:nvPr/>
+        </p:nvSpPr>
+        <p:spPr>
+          <a:xfrm>
+            <a:off x="2993136" y="6830568"/>
+            <a:ext cx="1840991" cy="310896"/>
+          </a:xfrm>
+          <a:prstGeom prst="rect">
+            <a:avLst/>
+          </a:prstGeom>
+          <a:noFill/>
+        </p:spPr>
+        <p:txBody>
+          <a:bodyPr wrap="square" lIns="0" rIns="0" tIns="0" bIns="0" anchor="ctr">
+            <a:spAutoFit/>
+          </a:bodyPr>
+          <a:lstStyle/>
+          <a:p>
+            <a:pPr>
+              <a:lnSpc>
+                <a:spcPct val="105000"/>
+              </a:lnSpc>
+              <a:spcAft>
+                <a:spcPts val="0"/>
+              </a:spcAft>
+            </a:pPr>
+            <a:r>
               <a:rPr sz="780" b="1">
                 <a:solidFill>
                   <a:srgbClr val="0B0B0B"/>
@@ -4699,7 +4993,7 @@
       </p:sp>
       <p:pic>
         <p:nvPicPr>
-          <p:cNvPr id="40" name="Panel 8 figure" descr="08_heatmap_tdsr.png"/>
+          <p:cNvPr id="47" name="Panel 8 figure" descr="08_heatmap_tdsr.png"/>
           <p:cNvPicPr>
             <a:picLocks noChangeAspect="1"/>
           </p:cNvPicPr>
@@ -4713,8 +5007,8 @@
         </p:blipFill>
         <p:spPr>
           <a:xfrm>
-            <a:off x="2702052" y="7196327"/>
-            <a:ext cx="2157984" cy="2011680"/>
+            <a:off x="2702052" y="7159751"/>
+            <a:ext cx="2157984" cy="1554480"/>
           </a:xfrm>
           <a:prstGeom prst="rect">
             <a:avLst/>
@@ -4723,113 +5017,14 @@
       </p:pic>
       <p:sp>
         <p:nvSpPr>
-          <p:cNvPr id="41" name="Panel 9 card"/>
-          <p:cNvSpPr/>
-          <p:nvPr/>
-        </p:nvSpPr>
-        <p:spPr>
-          <a:xfrm>
-            <a:off x="5035296" y="6821423"/>
-            <a:ext cx="2252472" cy="2423160"/>
-          </a:xfrm>
-          <a:prstGeom prst="roundRect">
-            <a:avLst>
-              <a:gd name="adj" fmla="val 4000"/>
-            </a:avLst>
-          </a:prstGeom>
-          <a:solidFill>
-            <a:srgbClr val="F4F5F7"/>
-          </a:solidFill>
-          <a:ln>
-            <a:noFill/>
-          </a:ln>
-          <a:effectLst/>
-        </p:spPr>
-        <p:style>
-          <a:lnRef idx="1">
-            <a:schemeClr val="accent1"/>
-          </a:lnRef>
-          <a:fillRef idx="3">
-            <a:schemeClr val="accent1"/>
-          </a:fillRef>
-          <a:effectRef idx="2">
-            <a:schemeClr val="accent1"/>
-          </a:effectRef>
-          <a:fontRef idx="minor">
-            <a:schemeClr val="lt1"/>
-          </a:fontRef>
-        </p:style>
-        <p:txBody>
-          <a:bodyPr rtlCol="0" anchor="ctr"/>
-          <a:lstStyle/>
-          <a:p>
-            <a:pPr algn="ctr"/>
-          </a:p>
-        </p:txBody>
-      </p:sp>
-      <p:sp>
-        <p:nvSpPr>
-          <p:cNvPr id="42" name="Panel 9 number"/>
-          <p:cNvSpPr/>
-          <p:nvPr/>
-        </p:nvSpPr>
-        <p:spPr>
-          <a:xfrm>
-            <a:off x="5108448" y="6912863"/>
-            <a:ext cx="201168" cy="201168"/>
-          </a:xfrm>
-          <a:prstGeom prst="ellipse">
-            <a:avLst/>
-          </a:prstGeom>
-          <a:solidFill>
-            <a:srgbClr val="0D366B"/>
-          </a:solidFill>
-          <a:ln>
-            <a:noFill/>
-          </a:ln>
-          <a:effectLst/>
-        </p:spPr>
-        <p:style>
-          <a:lnRef idx="1">
-            <a:schemeClr val="accent1"/>
-          </a:lnRef>
-          <a:fillRef idx="3">
-            <a:schemeClr val="accent1"/>
-          </a:fillRef>
-          <a:effectRef idx="2">
-            <a:schemeClr val="accent1"/>
-          </a:effectRef>
-          <a:fontRef idx="minor">
-            <a:schemeClr val="lt1"/>
-          </a:fontRef>
-        </p:style>
-        <p:txBody>
-          <a:bodyPr rtlCol="0" anchor="ctr" lIns="0" rIns="0" tIns="0" bIns="0"/>
-          <a:lstStyle/>
-          <a:p>
-            <a:pPr algn="ctr"/>
-            <a:r>
-              <a:rPr sz="750" b="1">
-                <a:solidFill>
-                  <a:srgbClr val="FFFFFF"/>
-                </a:solidFill>
-                <a:latin typeface="Arial"/>
-              </a:rPr>
-              <a:t>9</a:t>
-            </a:r>
-          </a:p>
-        </p:txBody>
-      </p:sp>
-      <p:sp>
-        <p:nvSpPr>
-          <p:cNvPr id="43" name="Panel 9 takeaway"/>
+          <p:cNvPr id="48" name="Panel 8 insight"/>
           <p:cNvSpPr txBox="1"/>
           <p:nvPr/>
         </p:nvSpPr>
         <p:spPr>
           <a:xfrm>
-            <a:off x="5373624" y="6867143"/>
-            <a:ext cx="1840991" cy="310896"/>
+            <a:off x="2764536" y="8741663"/>
+            <a:ext cx="2033016" cy="429768"/>
           </a:xfrm>
           <a:prstGeom prst="rect">
             <a:avLst/>
@@ -4837,7 +5032,7 @@
           <a:noFill/>
         </p:spPr>
         <p:txBody>
-          <a:bodyPr wrap="square" lIns="0" rIns="0" tIns="0" bIns="0" anchor="ctr">
+          <a:bodyPr wrap="square" lIns="0" rIns="0" tIns="0" bIns="0" anchor="t">
             <a:spAutoFit/>
           </a:bodyPr>
           <a:lstStyle/>
@@ -4851,6 +5046,147 @@
               </a:spcAft>
             </a:pPr>
             <a:r>
+              <a:rPr sz="690" b="0">
+                <a:solidFill>
+                  <a:srgbClr val="52514E"/>
+                </a:solidFill>
+                <a:latin typeface="Arial"/>
+              </a:rPr>
+              <a:t>The median new unit sits almost exactly at what the median household can borrow, which suggests launches are sized to the loan limit.</a:t>
+            </a:r>
+          </a:p>
+        </p:txBody>
+      </p:sp>
+      <p:sp>
+        <p:nvSpPr>
+          <p:cNvPr id="49" name="Panel 9 card"/>
+          <p:cNvSpPr/>
+          <p:nvPr/>
+        </p:nvSpPr>
+        <p:spPr>
+          <a:xfrm>
+            <a:off x="5035296" y="6784848"/>
+            <a:ext cx="2252472" cy="2414016"/>
+          </a:xfrm>
+          <a:prstGeom prst="roundRect">
+            <a:avLst>
+              <a:gd name="adj" fmla="val 4000"/>
+            </a:avLst>
+          </a:prstGeom>
+          <a:solidFill>
+            <a:srgbClr val="F4F5F7"/>
+          </a:solidFill>
+          <a:ln>
+            <a:noFill/>
+          </a:ln>
+          <a:effectLst/>
+        </p:spPr>
+        <p:style>
+          <a:lnRef idx="1">
+            <a:schemeClr val="accent1"/>
+          </a:lnRef>
+          <a:fillRef idx="3">
+            <a:schemeClr val="accent1"/>
+          </a:fillRef>
+          <a:effectRef idx="2">
+            <a:schemeClr val="accent1"/>
+          </a:effectRef>
+          <a:fontRef idx="minor">
+            <a:schemeClr val="lt1"/>
+          </a:fontRef>
+        </p:style>
+        <p:txBody>
+          <a:bodyPr rtlCol="0" anchor="ctr"/>
+          <a:lstStyle/>
+          <a:p>
+            <a:pPr algn="ctr"/>
+          </a:p>
+        </p:txBody>
+      </p:sp>
+      <p:sp>
+        <p:nvSpPr>
+          <p:cNvPr id="50" name="Panel 9 number"/>
+          <p:cNvSpPr/>
+          <p:nvPr/>
+        </p:nvSpPr>
+        <p:spPr>
+          <a:xfrm>
+            <a:off x="5108448" y="6876288"/>
+            <a:ext cx="201168" cy="201168"/>
+          </a:xfrm>
+          <a:prstGeom prst="ellipse">
+            <a:avLst/>
+          </a:prstGeom>
+          <a:solidFill>
+            <a:srgbClr val="0D366B"/>
+          </a:solidFill>
+          <a:ln>
+            <a:noFill/>
+          </a:ln>
+          <a:effectLst/>
+        </p:spPr>
+        <p:style>
+          <a:lnRef idx="1">
+            <a:schemeClr val="accent1"/>
+          </a:lnRef>
+          <a:fillRef idx="3">
+            <a:schemeClr val="accent1"/>
+          </a:fillRef>
+          <a:effectRef idx="2">
+            <a:schemeClr val="accent1"/>
+          </a:effectRef>
+          <a:fontRef idx="minor">
+            <a:schemeClr val="lt1"/>
+          </a:fontRef>
+        </p:style>
+        <p:txBody>
+          <a:bodyPr rtlCol="0" anchor="ctr" lIns="0" rIns="0" tIns="0" bIns="0"/>
+          <a:lstStyle/>
+          <a:p>
+            <a:pPr algn="ctr"/>
+            <a:r>
+              <a:rPr sz="750" b="1">
+                <a:solidFill>
+                  <a:srgbClr val="FFFFFF"/>
+                </a:solidFill>
+                <a:latin typeface="Arial"/>
+              </a:rPr>
+              <a:t>9</a:t>
+            </a:r>
+          </a:p>
+        </p:txBody>
+      </p:sp>
+      <p:sp>
+        <p:nvSpPr>
+          <p:cNvPr id="51" name="Panel 9 takeaway"/>
+          <p:cNvSpPr txBox="1"/>
+          <p:nvPr/>
+        </p:nvSpPr>
+        <p:spPr>
+          <a:xfrm>
+            <a:off x="5373624" y="6830568"/>
+            <a:ext cx="1840991" cy="310896"/>
+          </a:xfrm>
+          <a:prstGeom prst="rect">
+            <a:avLst/>
+          </a:prstGeom>
+          <a:noFill/>
+        </p:spPr>
+        <p:txBody>
+          <a:bodyPr wrap="square" lIns="0" rIns="0" tIns="0" bIns="0" anchor="ctr">
+            <a:spAutoFit/>
+          </a:bodyPr>
+          <a:lstStyle/>
+          <a:p>
+            <a:pPr>
+              <a:lnSpc>
+                <a:spcPct val="105000"/>
+              </a:lnSpc>
+              <a:spcAft>
+                <a:spcPts val="0"/>
+              </a:spcAft>
+            </a:pPr>
+            <a:r>
               <a:rPr sz="780" b="1">
                 <a:solidFill>
                   <a:srgbClr val="0B0B0B"/>
@@ -4864,7 +5200,7 @@
       </p:sp>
       <p:pic>
         <p:nvPicPr>
-          <p:cNvPr id="44" name="Panel 9 figure" descr="09_waterfall.png"/>
+          <p:cNvPr id="52" name="Panel 9 figure" descr="09_waterfall.png"/>
           <p:cNvPicPr>
             <a:picLocks noChangeAspect="1"/>
           </p:cNvPicPr>
@@ -4878,8 +5214,8 @@
         </p:blipFill>
         <p:spPr>
           <a:xfrm>
-            <a:off x="5082540" y="7196327"/>
-            <a:ext cx="2157984" cy="2011680"/>
+            <a:off x="5082540" y="7159751"/>
+            <a:ext cx="2157984" cy="1554480"/>
           </a:xfrm>
           <a:prstGeom prst="rect">
             <a:avLst/>
@@ -4888,60 +5224,14 @@
       </p:pic>
       <p:sp>
         <p:nvSpPr>
-          <p:cNvPr id="45" name="Answer card"/>
-          <p:cNvSpPr/>
-          <p:nvPr/>
-        </p:nvSpPr>
-        <p:spPr>
-          <a:xfrm>
-            <a:off x="274320" y="9326880"/>
-            <a:ext cx="7013448" cy="896112"/>
-          </a:xfrm>
-          <a:prstGeom prst="roundRect">
-            <a:avLst>
-              <a:gd name="adj" fmla="val 4000"/>
-            </a:avLst>
-          </a:prstGeom>
-          <a:solidFill>
-            <a:srgbClr val="0D366B"/>
-          </a:solidFill>
-          <a:ln>
-            <a:noFill/>
-          </a:ln>
-          <a:effectLst/>
-        </p:spPr>
-        <p:style>
-          <a:lnRef idx="1">
-            <a:schemeClr val="accent1"/>
-          </a:lnRef>
-          <a:fillRef idx="3">
-            <a:schemeClr val="accent1"/>
-          </a:fillRef>
-          <a:effectRef idx="2">
-            <a:schemeClr val="accent1"/>
-          </a:effectRef>
-          <a:fontRef idx="minor">
-            <a:schemeClr val="lt1"/>
-          </a:fontRef>
-        </p:style>
-        <p:txBody>
-          <a:bodyPr rtlCol="0" anchor="ctr"/>
-          <a:lstStyle/>
-          <a:p>
-            <a:pPr algn="ctr"/>
-          </a:p>
-        </p:txBody>
-      </p:sp>
-      <p:sp>
-        <p:nvSpPr>
-          <p:cNvPr id="46" name="Answer line"/>
+          <p:cNvPr id="53" name="Panel 9 insight"/>
           <p:cNvSpPr txBox="1"/>
           <p:nvPr/>
         </p:nvSpPr>
         <p:spPr>
           <a:xfrm>
-            <a:off x="420623" y="9400032"/>
-            <a:ext cx="6720840" cy="310896"/>
+            <a:off x="5145024" y="8741663"/>
+            <a:ext cx="2033016" cy="429768"/>
           </a:xfrm>
           <a:prstGeom prst="rect">
             <a:avLst/>
@@ -4949,7 +5239,7 @@
           <a:noFill/>
         </p:spPr>
         <p:txBody>
-          <a:bodyPr wrap="square" lIns="0" rIns="0" tIns="0" bIns="0" anchor="ctr">
+          <a:bodyPr wrap="square" lIns="0" rIns="0" tIns="0" bIns="0" anchor="t">
             <a:spAutoFit/>
           </a:bodyPr>
           <a:lstStyle/>
@@ -4963,42 +5253,35 @@
               </a:spcAft>
             </a:pPr>
             <a:r>
-              <a:rPr sz="919" b="1">
-                <a:solidFill>
-                  <a:srgbClr val="F7B89C"/>
+              <a:rPr sz="690" b="0">
+                <a:solidFill>
+                  <a:srgbClr val="52514E"/>
                 </a:solidFill>
                 <a:latin typeface="Arial"/>
               </a:rPr>
-              <a:t>Answer: </a:t>
-            </a:r>
-            <a:r>
-              <a:rPr sz="919" b="1">
-                <a:solidFill>
-                  <a:srgbClr val="FFFFFF"/>
-                </a:solidFill>
-                <a:latin typeface="Arial"/>
-              </a:rPr>
-              <a:t>yes, until URA stopped it. Homes shrank about 40% to hold the price tag down. Now that shrinking is capped, the price tag rises instead.</a:t>
-            </a:r>
-          </a:p>
-        </p:txBody>
-      </p:sp>
-      <p:sp>
-        <p:nvSpPr>
-          <p:cNvPr id="47" name="Finding 1 number"/>
+              <a:t>With the cap fixing sizes, any further PSF rise reaches buyers in full. Affordability now hinges on land costs and incomes.</a:t>
+            </a:r>
+          </a:p>
+        </p:txBody>
+      </p:sp>
+      <p:sp>
+        <p:nvSpPr>
+          <p:cNvPr id="54" name="Answer card"/>
           <p:cNvSpPr/>
           <p:nvPr/>
         </p:nvSpPr>
         <p:spPr>
           <a:xfrm>
-            <a:off x="420623" y="9811511"/>
-            <a:ext cx="182880" cy="182880"/>
-          </a:xfrm>
-          <a:prstGeom prst="ellipse">
-            <a:avLst/>
+            <a:off x="274320" y="9272016"/>
+            <a:ext cx="7013448" cy="896112"/>
+          </a:xfrm>
+          <a:prstGeom prst="roundRect">
+            <a:avLst>
+              <a:gd name="adj" fmla="val 4000"/>
+            </a:avLst>
           </a:prstGeom>
           <a:solidFill>
-            <a:srgbClr val="EB6834"/>
+            <a:srgbClr val="0D366B"/>
           </a:solidFill>
           <a:ln>
             <a:noFill/>
@@ -5020,32 +5303,23 @@
           </a:fontRef>
         </p:style>
         <p:txBody>
-          <a:bodyPr rtlCol="0" anchor="ctr" lIns="0" rIns="0" tIns="0" bIns="0"/>
+          <a:bodyPr rtlCol="0" anchor="ctr"/>
           <a:lstStyle/>
           <a:p>
             <a:pPr algn="ctr"/>
-            <a:r>
-              <a:rPr sz="700" b="1">
-                <a:solidFill>
-                  <a:srgbClr val="FFFFFF"/>
-                </a:solidFill>
-                <a:latin typeface="Arial"/>
-              </a:rPr>
-              <a:t>1</a:t>
-            </a:r>
-          </a:p>
-        </p:txBody>
-      </p:sp>
-      <p:sp>
-        <p:nvSpPr>
-          <p:cNvPr id="48" name="Finding 1"/>
+          </a:p>
+        </p:txBody>
+      </p:sp>
+      <p:sp>
+        <p:nvSpPr>
+          <p:cNvPr id="55" name="Answer line"/>
           <p:cNvSpPr txBox="1"/>
           <p:nvPr/>
         </p:nvSpPr>
         <p:spPr>
           <a:xfrm>
-            <a:off x="676656" y="9784080"/>
-            <a:ext cx="1862327" cy="402336"/>
+            <a:off x="420623" y="9345168"/>
+            <a:ext cx="6720840" cy="310896"/>
           </a:xfrm>
           <a:prstGeom prst="rect">
             <a:avLst/>
@@ -5053,7 +5327,7 @@
           <a:noFill/>
         </p:spPr>
         <p:txBody>
-          <a:bodyPr wrap="square" lIns="0" rIns="0" tIns="0" bIns="0" anchor="t">
+          <a:bodyPr wrap="square" lIns="0" rIns="0" tIns="0" bIns="0" anchor="ctr">
             <a:spAutoFit/>
           </a:bodyPr>
           <a:lstStyle/>
@@ -5067,26 +5341,35 @@
               </a:spcAft>
             </a:pPr>
             <a:r>
-              <a:rPr sz="720" b="0">
-                <a:solidFill>
-                  <a:srgbClr val="FFFFFF"/>
+              <a:rPr sz="919" b="1">
+                <a:solidFill>
+                  <a:srgbClr val="F7B89C"/>
                 </a:solidFill>
                 <a:latin typeface="Arial"/>
               </a:rPr>
-              <a:t>Homes on land sold after 2008 are about 40% smaller, and big homes all but disappeared</a:t>
-            </a:r>
-          </a:p>
-        </p:txBody>
-      </p:sp>
-      <p:sp>
-        <p:nvSpPr>
-          <p:cNvPr id="49" name="Finding 2 number"/>
+              <a:t>Answer: </a:t>
+            </a:r>
+            <a:r>
+              <a:rPr sz="919" b="1">
+                <a:solidFill>
+                  <a:srgbClr val="FFFFFF"/>
+                </a:solidFill>
+                <a:latin typeface="Arial"/>
+              </a:rPr>
+              <a:t>yes, until URA stopped it. Homes shrank about 40% to hold the price tag down. Now that shrinking is capped, the price tag rises instead.</a:t>
+            </a:r>
+          </a:p>
+        </p:txBody>
+      </p:sp>
+      <p:sp>
+        <p:nvSpPr>
+          <p:cNvPr id="56" name="Finding 1 number"/>
           <p:cNvSpPr/>
           <p:nvPr/>
         </p:nvSpPr>
         <p:spPr>
           <a:xfrm>
-            <a:off x="2721864" y="9811511"/>
+            <a:off x="420623" y="9756648"/>
             <a:ext cx="182880" cy="182880"/>
           </a:xfrm>
           <a:prstGeom prst="ellipse">
@@ -5126,20 +5409,20 @@
                 </a:solidFill>
                 <a:latin typeface="Arial"/>
               </a:rPr>
-              <a:t>2</a:t>
-            </a:r>
-          </a:p>
-        </p:txBody>
-      </p:sp>
-      <p:sp>
-        <p:nvSpPr>
-          <p:cNvPr id="50" name="Finding 2"/>
+              <a:t>1</a:t>
+            </a:r>
+          </a:p>
+        </p:txBody>
+      </p:sp>
+      <p:sp>
+        <p:nvSpPr>
+          <p:cNvPr id="57" name="Finding 1"/>
           <p:cNvSpPr txBox="1"/>
           <p:nvPr/>
         </p:nvSpPr>
         <p:spPr>
           <a:xfrm>
-            <a:off x="2977896" y="9784080"/>
+            <a:off x="676656" y="9729216"/>
             <a:ext cx="1862327" cy="402336"/>
           </a:xfrm>
           <a:prstGeom prst="rect">
@@ -5168,20 +5451,20 @@
                 </a:solidFill>
                 <a:latin typeface="Arial"/>
               </a:rPr>
-              <a:t>It is not location. It works because a launch is priced per sq ft, so fewer sq ft means a lower price tag</a:t>
-            </a:r>
-          </a:p>
-        </p:txBody>
-      </p:sp>
-      <p:sp>
-        <p:nvSpPr>
-          <p:cNvPr id="51" name="Finding 3 number"/>
+              <a:t>Homes on land sold after 2008 are about 40% smaller, and big homes all but disappeared</a:t>
+            </a:r>
+          </a:p>
+        </p:txBody>
+      </p:sp>
+      <p:sp>
+        <p:nvSpPr>
+          <p:cNvPr id="58" name="Finding 2 number"/>
           <p:cNvSpPr/>
           <p:nvPr/>
         </p:nvSpPr>
         <p:spPr>
           <a:xfrm>
-            <a:off x="5023104" y="9811511"/>
+            <a:off x="2721864" y="9756648"/>
             <a:ext cx="182880" cy="182880"/>
           </a:xfrm>
           <a:prstGeom prst="ellipse">
@@ -5221,20 +5504,20 @@
                 </a:solidFill>
                 <a:latin typeface="Arial"/>
               </a:rPr>
-              <a:t>3</a:t>
-            </a:r>
-          </a:p>
-        </p:txBody>
-      </p:sp>
-      <p:sp>
-        <p:nvSpPr>
-          <p:cNvPr id="52" name="Finding 3"/>
+              <a:t>2</a:t>
+            </a:r>
+          </a:p>
+        </p:txBody>
+      </p:sp>
+      <p:sp>
+        <p:nvSpPr>
+          <p:cNvPr id="59" name="Finding 2"/>
           <p:cNvSpPr txBox="1"/>
           <p:nvPr/>
         </p:nvSpPr>
         <p:spPr>
           <a:xfrm>
-            <a:off x="5279136" y="9784080"/>
+            <a:off x="2977896" y="9729216"/>
             <a:ext cx="1862327" cy="402336"/>
           </a:xfrm>
           <a:prstGeom prst="rect">
@@ -5263,21 +5546,116 @@
                 </a:solidFill>
                 <a:latin typeface="Arial"/>
               </a:rPr>
-              <a:t>Prices outran incomes when that land was sold. Since the 2019 cap the new-launch price tag is up 49%</a:t>
-            </a:r>
-          </a:p>
-        </p:txBody>
-      </p:sp>
-      <p:sp>
-        <p:nvSpPr>
-          <p:cNvPr id="53" name="Footnote"/>
+              <a:t>It is not location. It works because a launch is priced per sq ft, so fewer sq ft means a lower price tag</a:t>
+            </a:r>
+          </a:p>
+        </p:txBody>
+      </p:sp>
+      <p:sp>
+        <p:nvSpPr>
+          <p:cNvPr id="60" name="Finding 3 number"/>
+          <p:cNvSpPr/>
+          <p:nvPr/>
+        </p:nvSpPr>
+        <p:spPr>
+          <a:xfrm>
+            <a:off x="5023104" y="9756648"/>
+            <a:ext cx="182880" cy="182880"/>
+          </a:xfrm>
+          <a:prstGeom prst="ellipse">
+            <a:avLst/>
+          </a:prstGeom>
+          <a:solidFill>
+            <a:srgbClr val="EB6834"/>
+          </a:solidFill>
+          <a:ln>
+            <a:noFill/>
+          </a:ln>
+          <a:effectLst/>
+        </p:spPr>
+        <p:style>
+          <a:lnRef idx="1">
+            <a:schemeClr val="accent1"/>
+          </a:lnRef>
+          <a:fillRef idx="3">
+            <a:schemeClr val="accent1"/>
+          </a:fillRef>
+          <a:effectRef idx="2">
+            <a:schemeClr val="accent1"/>
+          </a:effectRef>
+          <a:fontRef idx="minor">
+            <a:schemeClr val="lt1"/>
+          </a:fontRef>
+        </p:style>
+        <p:txBody>
+          <a:bodyPr rtlCol="0" anchor="ctr" lIns="0" rIns="0" tIns="0" bIns="0"/>
+          <a:lstStyle/>
+          <a:p>
+            <a:pPr algn="ctr"/>
+            <a:r>
+              <a:rPr sz="700" b="1">
+                <a:solidFill>
+                  <a:srgbClr val="FFFFFF"/>
+                </a:solidFill>
+                <a:latin typeface="Arial"/>
+              </a:rPr>
+              <a:t>3</a:t>
+            </a:r>
+          </a:p>
+        </p:txBody>
+      </p:sp>
+      <p:sp>
+        <p:nvSpPr>
+          <p:cNvPr id="61" name="Finding 3"/>
           <p:cNvSpPr txBox="1"/>
           <p:nvPr/>
         </p:nvSpPr>
         <p:spPr>
           <a:xfrm>
-            <a:off x="274320" y="10277856"/>
-            <a:ext cx="7013448" cy="301751"/>
+            <a:off x="5279136" y="9729216"/>
+            <a:ext cx="1862327" cy="402336"/>
+          </a:xfrm>
+          <a:prstGeom prst="rect">
+            <a:avLst/>
+          </a:prstGeom>
+          <a:noFill/>
+        </p:spPr>
+        <p:txBody>
+          <a:bodyPr wrap="square" lIns="0" rIns="0" tIns="0" bIns="0" anchor="t">
+            <a:spAutoFit/>
+          </a:bodyPr>
+          <a:lstStyle/>
+          <a:p>
+            <a:pPr>
+              <a:lnSpc>
+                <a:spcPct val="105000"/>
+              </a:lnSpc>
+              <a:spcAft>
+                <a:spcPts val="0"/>
+              </a:spcAft>
+            </a:pPr>
+            <a:r>
+              <a:rPr sz="720" b="0">
+                <a:solidFill>
+                  <a:srgbClr val="FFFFFF"/>
+                </a:solidFill>
+                <a:latin typeface="Arial"/>
+              </a:rPr>
+              <a:t>Prices outran incomes when that land was sold. Since the 2019 cap the new-launch price tag is up 49%</a:t>
+            </a:r>
+          </a:p>
+        </p:txBody>
+      </p:sp>
+      <p:sp>
+        <p:nvSpPr>
+          <p:cNvPr id="62" name="Footnote"/>
+          <p:cNvSpPr txBox="1"/>
+          <p:nvPr/>
+        </p:nvSpPr>
+        <p:spPr>
+          <a:xfrm>
+            <a:off x="274320" y="10222992"/>
+            <a:ext cx="7013448" cy="356615"/>
           </a:xfrm>
           <a:prstGeom prst="rect">
             <a:avLst/>

</xml_diff>

<commit_message>
Humanize the poster text
Finding 1 gives the 34% to 8% drop instead of 'all but disappeared';
finding 2 drops the 'It is not X. It works because' construction;
chart 6 comment folds its closer into the sentence; 'hinges on' and
'the size of the product' made plain; chart 5 takeaway in past tense.
PDF, pptx, guide and zip rebuilt.

Co-Authored-By: Claude Opus 5.5 <noreply@anthropic.com>
</commit_message>
<xml_diff>
--- a/shrinkflation_poster.pptx
+++ b/shrinkflation_poster.pptx
@@ -4323,7 +4323,7 @@
                 </a:solidFill>
                 <a:latin typeface="Arial"/>
               </a:rPr>
-              <a:t>Shrinking cut prices to S$1.45M; after 2019 they jump to S$2.05M</a:t>
+              <a:t>Shrinking cut prices to S$1.45M; after 2019 they jumped to S$2.05M</a:t>
             </a:r>
           </a:p>
         </p:txBody>
@@ -4596,7 +4596,7 @@
                 </a:solidFill>
                 <a:latin typeface="Arial"/>
               </a:rPr>
-              <a:t>Small units carry no premium inside a launch, so every sq ft cut comes straight off the price tag. That made shrinking the easiest lever.</a:t>
+              <a:t>Small units carry no premium inside a launch, so every sq ft cut comes straight off the price tag, which made shrinking the easiest lever.</a:t>
             </a:r>
           </a:p>
         </p:txBody>
@@ -4845,7 +4845,7 @@
                 </a:solidFill>
                 <a:latin typeface="Arial"/>
               </a:rPr>
-              <a:t>When prices ran ahead of incomes, developers cut the size of the product instead of its price per sq ft.</a:t>
+              <a:t>When prices ran ahead of incomes, developers cut floor area instead of the price per sq ft.</a:t>
             </a:r>
           </a:p>
         </p:txBody>
@@ -5259,7 +5259,7 @@
                 </a:solidFill>
                 <a:latin typeface="Arial"/>
               </a:rPr>
-              <a:t>With the cap fixing sizes, any further PSF rise reaches buyers in full. Affordability now hinges on land costs and incomes.</a:t>
+              <a:t>With the cap fixing sizes, any further PSF rise reaches buyers in full. Affordability now depends on land costs and incomes.</a:t>
             </a:r>
           </a:p>
         </p:txBody>
@@ -5451,7 +5451,7 @@
                 </a:solidFill>
                 <a:latin typeface="Arial"/>
               </a:rPr>
-              <a:t>Homes on land sold after 2008 are about 40% smaller, and big homes all but disappeared</a:t>
+              <a:t>Homes on land sold after 2008 are about 40% smaller, and big homes fell from 34% to 8%</a:t>
             </a:r>
           </a:p>
         </p:txBody>
@@ -5546,7 +5546,7 @@
                 </a:solidFill>
                 <a:latin typeface="Arial"/>
               </a:rPr>
-              <a:t>It is not location. It works because a launch is priced per sq ft, so fewer sq ft means a lower price tag</a:t>
+              <a:t>Location does not explain it. Launches are priced per sq ft, so fewer sq ft means a lower price tag</a:t>
             </a:r>
           </a:p>
         </p:txBody>

</xml_diff>

<commit_message>
Keep both posters: original and humanized side by side
shrinkflation_poster.pdf/.pptx are back to the version before the
humanizer pass; the humanized one is shrinkflation_poster_humanized,
which build_poster.py now writes.

Co-Authored-By: Claude Opus 5.5 <noreply@anthropic.com>
</commit_message>
<xml_diff>
--- a/shrinkflation_poster.pptx
+++ b/shrinkflation_poster.pptx
@@ -4323,7 +4323,7 @@
                 </a:solidFill>
                 <a:latin typeface="Arial"/>
               </a:rPr>
-              <a:t>Shrinking cut prices to S$1.45M; after 2019 they jumped to S$2.05M</a:t>
+              <a:t>Shrinking cut prices to S$1.45M; after 2019 they jump to S$2.05M</a:t>
             </a:r>
           </a:p>
         </p:txBody>
@@ -4596,7 +4596,7 @@
                 </a:solidFill>
                 <a:latin typeface="Arial"/>
               </a:rPr>
-              <a:t>Small units carry no premium inside a launch, so every sq ft cut comes straight off the price tag, which made shrinking the easiest lever.</a:t>
+              <a:t>Small units carry no premium inside a launch, so every sq ft cut comes straight off the price tag. That made shrinking the easiest lever.</a:t>
             </a:r>
           </a:p>
         </p:txBody>
@@ -4845,7 +4845,7 @@
                 </a:solidFill>
                 <a:latin typeface="Arial"/>
               </a:rPr>
-              <a:t>When prices ran ahead of incomes, developers cut floor area instead of the price per sq ft.</a:t>
+              <a:t>When prices ran ahead of incomes, developers cut the size of the product instead of its price per sq ft.</a:t>
             </a:r>
           </a:p>
         </p:txBody>
@@ -5259,7 +5259,7 @@
                 </a:solidFill>
                 <a:latin typeface="Arial"/>
               </a:rPr>
-              <a:t>With the cap fixing sizes, any further PSF rise reaches buyers in full. Affordability now depends on land costs and incomes.</a:t>
+              <a:t>With the cap fixing sizes, any further PSF rise reaches buyers in full. Affordability now hinges on land costs and incomes.</a:t>
             </a:r>
           </a:p>
         </p:txBody>
@@ -5451,7 +5451,7 @@
                 </a:solidFill>
                 <a:latin typeface="Arial"/>
               </a:rPr>
-              <a:t>Homes on land sold after 2008 are about 40% smaller, and big homes fell from 34% to 8%</a:t>
+              <a:t>Homes on land sold after 2008 are about 40% smaller, and big homes all but disappeared</a:t>
             </a:r>
           </a:p>
         </p:txBody>
@@ -5546,7 +5546,7 @@
                 </a:solidFill>
                 <a:latin typeface="Arial"/>
               </a:rPr>
-              <a:t>Location does not explain it. Launches are priced per sq ft, so fewer sq ft means a lower price tag</a:t>
+              <a:t>It is not location. It works because a launch is priced per sq ft, so fewer sq ft means a lower price tag</a:t>
             </a:r>
           </a:p>
         </p:txBody>

</xml_diff>